<commit_message>
deck: fix inline-run line overlaps, explain Domain Authority (~30 goal), roadmap landing pages done in M1
- text() now renders list items as INLINE runs on one paragraph (was one
  line per item) — fixes the overlapping 'Prepared for / name', 'Target:' and
  team-name lines on the title/DA/roadmap/close slides.
- DA slide rewritten: plain-language explainer of what Domain Authority is,
  a visual 'YOUR TARGET ~30' marker on the chart (scaled to 40), and copy that
  reframes the goal as reaching ~30 (achievable, ahead of most local rivals)
  via backlinks. Dropped the overlapping chips.
- Roadmap: service & location landing pages moved to Month 1 (marked ✓ done);
  Month 2 = authority/backlinks + content. 'What we've done' adds landing pages.
  Content slide changed from 'build' to 'expand/refresh' landing pages.
- Target reframed as a Goal anchored to the 90-day score guarantee.

Co-Authored-By: Claude Opus 4.8 (1M context) <noreply@anthropic.com>
</commit_message>
<xml_diff>
--- a/deliverables/PracticeRank-SEO-Strategy-Paradigm-Experts.pptx
+++ b/deliverables/PracticeRank-SEO-Strategy-Paradigm-Experts.pptx
@@ -3384,13 +3384,6 @@
               </a:rPr>
               <a:t>Prepared for </a:t>
             </a:r>
-          </a:p>
-          <a:p>
-            <a:pPr algn="l">
-              <a:lnSpc>
-                <a:spcPct val="100000"/>
-              </a:lnSpc>
-            </a:pPr>
             <a:r>
               <a:rPr sz="2200" b="1">
                 <a:solidFill>
@@ -3400,13 +3393,6 @@
               </a:rPr>
               <a:t>Paradigm Experts</a:t>
             </a:r>
-          </a:p>
-          <a:p>
-            <a:pPr algn="l">
-              <a:lnSpc>
-                <a:spcPct val="100000"/>
-              </a:lnSpc>
-            </a:pPr>
             <a:r>
               <a:rPr sz="2200" b="0">
                 <a:solidFill>
@@ -4030,7 +4016,7 @@
                 </a:solidFill>
                 <a:latin typeface="Calibri"/>
               </a:rPr>
-              <a:t>City &amp; service landing pages for every area you serve (Springfield · Arlington · McLean · Fairfax · Alexandria · Lorton · DC)</a:t>
+              <a:t>Expand &amp; refresh your landing pages as we find new demand (Springfield · Arlington · McLean · Fairfax · Alexandria · Lorton · DC)</a:t>
             </a:r>
           </a:p>
           <a:p>
@@ -4635,7 +4621,7 @@
                 </a:solidFill>
                 <a:latin typeface="Calibri"/>
               </a:rPr>
-              <a:t>Month 1</a:t>
+              <a:t>Month 1  ✓</a:t>
             </a:r>
           </a:p>
         </p:txBody>
@@ -4674,7 +4660,7 @@
                 </a:solidFill>
                 <a:latin typeface="Calibri"/>
               </a:rPr>
-              <a:t>Technical foundation, Google Business Profile, homepage rebuild</a:t>
+              <a:t>Technical foundation, Google Business Profile, homepage rebuild, service &amp; location landing pages</a:t>
             </a:r>
           </a:p>
         </p:txBody>
@@ -4842,7 +4828,7 @@
                 </a:solidFill>
                 <a:latin typeface="Calibri"/>
               </a:rPr>
-              <a:t>City / service landing pages, first authority links, content cadence</a:t>
+              <a:t>Authority backlinks (raise Domain Authority), on-page depth, content cadence</a:t>
             </a:r>
           </a:p>
         </p:txBody>
@@ -5023,7 +5009,7 @@
         </p:nvSpPr>
         <p:spPr>
           <a:xfrm>
-            <a:off x="658368" y="5029200"/>
+            <a:off x="658368" y="5074920"/>
             <a:ext cx="10881360" cy="548640"/>
           </a:xfrm>
           <a:prstGeom prst="rect">
@@ -5043,29 +5029,31 @@
               </a:lnSpc>
             </a:pPr>
             <a:r>
-              <a:rPr sz="1800" b="0">
+              <a:rPr sz="1700" b="0">
                 <a:solidFill>
                   <a:srgbClr val="9AA6B4"/>
                 </a:solidFill>
                 <a:latin typeface="Calibri"/>
               </a:rPr>
-              <a:t>Target:  </a:t>
-            </a:r>
-          </a:p>
-          <a:p>
-            <a:pPr algn="l">
-              <a:lnSpc>
-                <a:spcPct val="100000"/>
-              </a:lnSpc>
-            </a:pPr>
-            <a:r>
-              <a:rPr sz="1800" b="1">
+              <a:t>Goal:  </a:t>
+            </a:r>
+            <a:r>
+              <a:rPr sz="1700" b="1">
                 <a:solidFill>
                   <a:srgbClr val="4ADE80"/>
                 </a:solidFill>
                 <a:latin typeface="Calibri"/>
               </a:rPr>
               <a:t>500+ monthly organic visits within 6 months</a:t>
+            </a:r>
+            <a:r>
+              <a:rPr sz="1400" b="0">
+                <a:solidFill>
+                  <a:srgbClr val="9AA6B4"/>
+                </a:solidFill>
+                <a:latin typeface="Calibri"/>
+              </a:rPr>
+              <a:t>   — backed by our 90-day score guarantee.</a:t>
             </a:r>
           </a:p>
         </p:txBody>
@@ -5729,13 +5717,6 @@
               </a:rPr>
               <a:t>Dan Toone</a:t>
             </a:r>
-          </a:p>
-          <a:p>
-            <a:pPr algn="ctr">
-              <a:lnSpc>
-                <a:spcPct val="100000"/>
-              </a:lnSpc>
-            </a:pPr>
             <a:r>
               <a:rPr sz="1800" b="0">
                 <a:solidFill>
@@ -5784,13 +5765,6 @@
               </a:rPr>
               <a:t>Kody Doherty</a:t>
             </a:r>
-          </a:p>
-          <a:p>
-            <a:pPr algn="ctr">
-              <a:lnSpc>
-                <a:spcPct val="100000"/>
-              </a:lnSpc>
-            </a:pPr>
             <a:r>
               <a:rPr sz="1800" b="0">
                 <a:solidFill>
@@ -11475,7 +11449,7 @@
                 </a:solidFill>
                 <a:latin typeface="Calibri"/>
               </a:rPr>
-              <a:t>Your Domain Authority vs. The Competition</a:t>
+              <a:t>Domain Authority — and Why ~30 Is the Goal</a:t>
             </a:r>
           </a:p>
         </p:txBody>
@@ -11634,8 +11608,130 @@
         </p:nvSpPr>
         <p:spPr>
           <a:xfrm>
-            <a:off x="640080" y="2057400"/>
-            <a:ext cx="3931920" cy="502920"/>
+            <a:off x="658368" y="1783080"/>
+            <a:ext cx="10881360" cy="640080"/>
+          </a:xfrm>
+          <a:prstGeom prst="rect">
+            <a:avLst/>
+          </a:prstGeom>
+          <a:noFill/>
+        </p:spPr>
+        <p:txBody>
+          <a:bodyPr wrap="square" anchor="t">
+            <a:spAutoFit/>
+          </a:bodyPr>
+          <a:lstStyle/>
+          <a:p>
+            <a:pPr algn="l">
+              <a:lnSpc>
+                <a:spcPct val="118000"/>
+              </a:lnSpc>
+            </a:pPr>
+            <a:r>
+              <a:rPr sz="1500" b="0">
+                <a:solidFill>
+                  <a:srgbClr val="9AA6B4"/>
+                </a:solidFill>
+                <a:latin typeface="Calibri"/>
+              </a:rPr>
+              <a:t>Domain Authority (0–100) is a trust score for your website — built mostly from quality backlinks. The higher it climbs, the easier everything else ranks.</a:t>
+            </a:r>
+          </a:p>
+        </p:txBody>
+      </p:sp>
+      <p:sp>
+        <p:nvSpPr>
+          <p:cNvPr id="13" name="Rectangle 12"/>
+          <p:cNvSpPr/>
+          <p:nvPr/>
+        </p:nvSpPr>
+        <p:spPr>
+          <a:xfrm>
+            <a:off x="8321040" y="2834640"/>
+            <a:ext cx="32004" cy="2240279"/>
+          </a:xfrm>
+          <a:prstGeom prst="rect">
+            <a:avLst/>
+          </a:prstGeom>
+          <a:solidFill>
+            <a:srgbClr val="4ADE80"/>
+          </a:solidFill>
+          <a:ln>
+            <a:noFill/>
+          </a:ln>
+          <a:effectLst/>
+        </p:spPr>
+        <p:style>
+          <a:lnRef idx="1">
+            <a:schemeClr val="accent1"/>
+          </a:lnRef>
+          <a:fillRef idx="3">
+            <a:schemeClr val="accent1"/>
+          </a:fillRef>
+          <a:effectRef idx="2">
+            <a:schemeClr val="accent1"/>
+          </a:effectRef>
+          <a:fontRef idx="minor">
+            <a:schemeClr val="lt1"/>
+          </a:fontRef>
+        </p:style>
+        <p:txBody>
+          <a:bodyPr rtlCol="0" anchor="ctr"/>
+          <a:lstStyle/>
+          <a:p>
+            <a:pPr algn="ctr"/>
+          </a:p>
+        </p:txBody>
+      </p:sp>
+      <p:sp>
+        <p:nvSpPr>
+          <p:cNvPr id="14" name="TextBox 13"/>
+          <p:cNvSpPr txBox="1"/>
+          <p:nvPr/>
+        </p:nvSpPr>
+        <p:spPr>
+          <a:xfrm>
+            <a:off x="7543800" y="2423160"/>
+            <a:ext cx="1645920" cy="320040"/>
+          </a:xfrm>
+          <a:prstGeom prst="rect">
+            <a:avLst/>
+          </a:prstGeom>
+          <a:noFill/>
+        </p:spPr>
+        <p:txBody>
+          <a:bodyPr wrap="square" anchor="t">
+            <a:spAutoFit/>
+          </a:bodyPr>
+          <a:lstStyle/>
+          <a:p>
+            <a:pPr algn="ctr">
+              <a:lnSpc>
+                <a:spcPct val="100000"/>
+              </a:lnSpc>
+            </a:pPr>
+            <a:r>
+              <a:rPr sz="1100" b="1">
+                <a:solidFill>
+                  <a:srgbClr val="4ADE80"/>
+                </a:solidFill>
+                <a:latin typeface="Calibri"/>
+              </a:rPr>
+              <a:t>YOUR TARGET  ~30</a:t>
+            </a:r>
+          </a:p>
+        </p:txBody>
+      </p:sp>
+      <p:sp>
+        <p:nvSpPr>
+          <p:cNvPr id="15" name="TextBox 14"/>
+          <p:cNvSpPr txBox="1"/>
+          <p:nvPr/>
+        </p:nvSpPr>
+        <p:spPr>
+          <a:xfrm>
+            <a:off x="640080" y="2880360"/>
+            <a:ext cx="3017520" cy="411480"/>
           </a:xfrm>
           <a:prstGeom prst="rect">
             <a:avLst/>
@@ -11654,7 +11750,7 @@
               </a:lnSpc>
             </a:pPr>
             <a:r>
-              <a:rPr sz="1500" b="0">
+              <a:rPr sz="1350" b="0">
                 <a:solidFill>
                   <a:srgbClr val="FFFFFF"/>
                 </a:solidFill>
@@ -11667,14 +11763,14 @@
       </p:sp>
       <p:sp>
         <p:nvSpPr>
-          <p:cNvPr id="13" name="Rectangle 12"/>
+          <p:cNvPr id="16" name="Rectangle 15"/>
           <p:cNvSpPr/>
           <p:nvPr/>
         </p:nvSpPr>
         <p:spPr>
           <a:xfrm>
-            <a:off x="4754880" y="2112264"/>
-            <a:ext cx="5212080" cy="384048"/>
+            <a:off x="3931920" y="2916936"/>
+            <a:ext cx="5852160" cy="329184"/>
           </a:xfrm>
           <a:prstGeom prst="rect">
             <a:avLst/>
@@ -11711,14 +11807,14 @@
       </p:sp>
       <p:sp>
         <p:nvSpPr>
-          <p:cNvPr id="14" name="Rectangle 13"/>
+          <p:cNvPr id="17" name="Rectangle 16"/>
           <p:cNvSpPr/>
           <p:nvPr/>
         </p:nvSpPr>
         <p:spPr>
           <a:xfrm>
-            <a:off x="4754880" y="2112264"/>
-            <a:ext cx="4690872" cy="384048"/>
+            <a:off x="3931920" y="2916936"/>
+            <a:ext cx="2633472" cy="329184"/>
           </a:xfrm>
           <a:prstGeom prst="rect">
             <a:avLst/>
@@ -11755,14 +11851,14 @@
       </p:sp>
       <p:sp>
         <p:nvSpPr>
-          <p:cNvPr id="15" name="TextBox 14"/>
+          <p:cNvPr id="18" name="TextBox 17"/>
           <p:cNvSpPr txBox="1"/>
           <p:nvPr/>
         </p:nvSpPr>
         <p:spPr>
           <a:xfrm>
-            <a:off x="9555480" y="2057400"/>
-            <a:ext cx="914400" cy="502920"/>
+            <a:off x="6656831" y="2880360"/>
+            <a:ext cx="548640" cy="411480"/>
           </a:xfrm>
           <a:prstGeom prst="rect">
             <a:avLst/>
@@ -11781,7 +11877,7 @@
               </a:lnSpc>
             </a:pPr>
             <a:r>
-              <a:rPr sz="1600" b="1">
+              <a:rPr sz="1400" b="1">
                 <a:solidFill>
                   <a:srgbClr val="9AA6B4"/>
                 </a:solidFill>
@@ -11794,14 +11890,14 @@
       </p:sp>
       <p:sp>
         <p:nvSpPr>
-          <p:cNvPr id="16" name="TextBox 15"/>
+          <p:cNvPr id="19" name="TextBox 18"/>
           <p:cNvSpPr txBox="1"/>
           <p:nvPr/>
         </p:nvSpPr>
         <p:spPr>
           <a:xfrm>
-            <a:off x="640080" y="2770632"/>
-            <a:ext cx="3931920" cy="502920"/>
+            <a:off x="640080" y="3429000"/>
+            <a:ext cx="3017520" cy="411480"/>
           </a:xfrm>
           <a:prstGeom prst="rect">
             <a:avLst/>
@@ -11820,7 +11916,7 @@
               </a:lnSpc>
             </a:pPr>
             <a:r>
-              <a:rPr sz="1500" b="1">
+              <a:rPr sz="1350" b="1">
                 <a:solidFill>
                   <a:srgbClr val="4ADE80"/>
                 </a:solidFill>
@@ -11833,14 +11929,14 @@
       </p:sp>
       <p:sp>
         <p:nvSpPr>
-          <p:cNvPr id="17" name="Rectangle 16"/>
+          <p:cNvPr id="20" name="Rectangle 19"/>
           <p:cNvSpPr/>
           <p:nvPr/>
         </p:nvSpPr>
         <p:spPr>
           <a:xfrm>
-            <a:off x="4754880" y="2825496"/>
-            <a:ext cx="5212080" cy="384048"/>
+            <a:off x="3931920" y="3465576"/>
+            <a:ext cx="5852160" cy="329184"/>
           </a:xfrm>
           <a:prstGeom prst="rect">
             <a:avLst/>
@@ -11877,14 +11973,14 @@
       </p:sp>
       <p:sp>
         <p:nvSpPr>
-          <p:cNvPr id="18" name="Rectangle 17"/>
+          <p:cNvPr id="21" name="Rectangle 20"/>
           <p:cNvSpPr/>
           <p:nvPr/>
         </p:nvSpPr>
         <p:spPr>
           <a:xfrm>
-            <a:off x="4754880" y="2825496"/>
-            <a:ext cx="3648456" cy="384048"/>
+            <a:off x="3931920" y="3465576"/>
+            <a:ext cx="2048256" cy="329184"/>
           </a:xfrm>
           <a:prstGeom prst="rect">
             <a:avLst/>
@@ -11921,14 +12017,14 @@
       </p:sp>
       <p:sp>
         <p:nvSpPr>
-          <p:cNvPr id="19" name="TextBox 18"/>
+          <p:cNvPr id="22" name="TextBox 21"/>
           <p:cNvSpPr txBox="1"/>
           <p:nvPr/>
         </p:nvSpPr>
         <p:spPr>
           <a:xfrm>
-            <a:off x="8513063" y="2770632"/>
-            <a:ext cx="914400" cy="502920"/>
+            <a:off x="6071616" y="3429000"/>
+            <a:ext cx="548640" cy="411480"/>
           </a:xfrm>
           <a:prstGeom prst="rect">
             <a:avLst/>
@@ -11947,7 +12043,7 @@
               </a:lnSpc>
             </a:pPr>
             <a:r>
-              <a:rPr sz="1600" b="1">
+              <a:rPr sz="1400" b="1">
                 <a:solidFill>
                   <a:srgbClr val="4ADE80"/>
                 </a:solidFill>
@@ -11960,14 +12056,14 @@
       </p:sp>
       <p:sp>
         <p:nvSpPr>
-          <p:cNvPr id="20" name="TextBox 19"/>
+          <p:cNvPr id="23" name="TextBox 22"/>
           <p:cNvSpPr txBox="1"/>
           <p:nvPr/>
         </p:nvSpPr>
         <p:spPr>
           <a:xfrm>
-            <a:off x="640080" y="3483864"/>
-            <a:ext cx="3931920" cy="502920"/>
+            <a:off x="640080" y="3977639"/>
+            <a:ext cx="3017520" cy="411480"/>
           </a:xfrm>
           <a:prstGeom prst="rect">
             <a:avLst/>
@@ -11986,7 +12082,7 @@
               </a:lnSpc>
             </a:pPr>
             <a:r>
-              <a:rPr sz="1500" b="0">
+              <a:rPr sz="1350" b="0">
                 <a:solidFill>
                   <a:srgbClr val="FFFFFF"/>
                 </a:solidFill>
@@ -11999,14 +12095,14 @@
       </p:sp>
       <p:sp>
         <p:nvSpPr>
-          <p:cNvPr id="21" name="Rectangle 20"/>
+          <p:cNvPr id="24" name="Rectangle 23"/>
           <p:cNvSpPr/>
           <p:nvPr/>
         </p:nvSpPr>
         <p:spPr>
           <a:xfrm>
-            <a:off x="4754880" y="3538728"/>
-            <a:ext cx="5212080" cy="384048"/>
+            <a:off x="3931920" y="4014215"/>
+            <a:ext cx="5852160" cy="329184"/>
           </a:xfrm>
           <a:prstGeom prst="rect">
             <a:avLst/>
@@ -12043,14 +12139,14 @@
       </p:sp>
       <p:sp>
         <p:nvSpPr>
-          <p:cNvPr id="22" name="Rectangle 21"/>
+          <p:cNvPr id="25" name="Rectangle 24"/>
           <p:cNvSpPr/>
           <p:nvPr/>
         </p:nvSpPr>
         <p:spPr>
           <a:xfrm>
-            <a:off x="4754880" y="3538728"/>
-            <a:ext cx="2866644" cy="384048"/>
+            <a:off x="3931920" y="4014215"/>
+            <a:ext cx="1609344" cy="329184"/>
           </a:xfrm>
           <a:prstGeom prst="rect">
             <a:avLst/>
@@ -12087,14 +12183,14 @@
       </p:sp>
       <p:sp>
         <p:nvSpPr>
-          <p:cNvPr id="23" name="TextBox 22"/>
+          <p:cNvPr id="26" name="TextBox 25"/>
           <p:cNvSpPr txBox="1"/>
           <p:nvPr/>
         </p:nvSpPr>
         <p:spPr>
           <a:xfrm>
-            <a:off x="7731252" y="3483864"/>
-            <a:ext cx="914400" cy="502920"/>
+            <a:off x="5632704" y="3977639"/>
+            <a:ext cx="548640" cy="411480"/>
           </a:xfrm>
           <a:prstGeom prst="rect">
             <a:avLst/>
@@ -12113,7 +12209,7 @@
               </a:lnSpc>
             </a:pPr>
             <a:r>
-              <a:rPr sz="1600" b="1">
+              <a:rPr sz="1400" b="1">
                 <a:solidFill>
                   <a:srgbClr val="9AA6B4"/>
                 </a:solidFill>
@@ -12126,14 +12222,14 @@
       </p:sp>
       <p:sp>
         <p:nvSpPr>
-          <p:cNvPr id="24" name="TextBox 23"/>
+          <p:cNvPr id="27" name="TextBox 26"/>
           <p:cNvSpPr txBox="1"/>
           <p:nvPr/>
         </p:nvSpPr>
         <p:spPr>
           <a:xfrm>
-            <a:off x="640080" y="4197096"/>
-            <a:ext cx="3931920" cy="502920"/>
+            <a:off x="640080" y="4526279"/>
+            <a:ext cx="3017520" cy="411480"/>
           </a:xfrm>
           <a:prstGeom prst="rect">
             <a:avLst/>
@@ -12152,7 +12248,7 @@
               </a:lnSpc>
             </a:pPr>
             <a:r>
-              <a:rPr sz="1500" b="0">
+              <a:rPr sz="1350" b="0">
                 <a:solidFill>
                   <a:srgbClr val="FFFFFF"/>
                 </a:solidFill>
@@ -12165,14 +12261,14 @@
       </p:sp>
       <p:sp>
         <p:nvSpPr>
-          <p:cNvPr id="25" name="Rectangle 24"/>
+          <p:cNvPr id="28" name="Rectangle 27"/>
           <p:cNvSpPr/>
           <p:nvPr/>
         </p:nvSpPr>
         <p:spPr>
           <a:xfrm>
-            <a:off x="4754880" y="4251959"/>
-            <a:ext cx="5212080" cy="384048"/>
+            <a:off x="3931920" y="4562855"/>
+            <a:ext cx="5852160" cy="329184"/>
           </a:xfrm>
           <a:prstGeom prst="rect">
             <a:avLst/>
@@ -12209,14 +12305,14 @@
       </p:sp>
       <p:sp>
         <p:nvSpPr>
-          <p:cNvPr id="26" name="Rectangle 25"/>
+          <p:cNvPr id="29" name="Rectangle 28"/>
           <p:cNvSpPr/>
           <p:nvPr/>
         </p:nvSpPr>
         <p:spPr>
           <a:xfrm>
-            <a:off x="4754880" y="4251959"/>
-            <a:ext cx="2606040" cy="384048"/>
+            <a:off x="3931920" y="4562855"/>
+            <a:ext cx="1463040" cy="329184"/>
           </a:xfrm>
           <a:prstGeom prst="rect">
             <a:avLst/>
@@ -12253,14 +12349,14 @@
       </p:sp>
       <p:sp>
         <p:nvSpPr>
-          <p:cNvPr id="27" name="TextBox 26"/>
+          <p:cNvPr id="30" name="TextBox 29"/>
           <p:cNvSpPr txBox="1"/>
           <p:nvPr/>
         </p:nvSpPr>
         <p:spPr>
           <a:xfrm>
-            <a:off x="7470648" y="4197096"/>
-            <a:ext cx="914400" cy="502920"/>
+            <a:off x="5486400" y="4526279"/>
+            <a:ext cx="548640" cy="411480"/>
           </a:xfrm>
           <a:prstGeom prst="rect">
             <a:avLst/>
@@ -12279,7 +12375,7 @@
               </a:lnSpc>
             </a:pPr>
             <a:r>
-              <a:rPr sz="1600" b="1">
+              <a:rPr sz="1400" b="1">
                 <a:solidFill>
                   <a:srgbClr val="9AA6B4"/>
                 </a:solidFill>
@@ -12292,14 +12388,14 @@
       </p:sp>
       <p:sp>
         <p:nvSpPr>
-          <p:cNvPr id="28" name="TextBox 27"/>
+          <p:cNvPr id="31" name="TextBox 30"/>
           <p:cNvSpPr txBox="1"/>
           <p:nvPr/>
         </p:nvSpPr>
         <p:spPr>
           <a:xfrm>
-            <a:off x="640080" y="5074920"/>
-            <a:ext cx="10881360" cy="914400"/>
+            <a:off x="658368" y="5074920"/>
+            <a:ext cx="10881360" cy="1005840"/>
           </a:xfrm>
           <a:prstGeom prst="rect">
             <a:avLst/>
@@ -12318,26 +12414,26 @@
               </a:lnSpc>
             </a:pPr>
             <a:r>
-              <a:rPr sz="1500" b="0">
-                <a:solidFill>
-                  <a:srgbClr val="9AA6B4"/>
-                </a:solidFill>
-                <a:latin typeface="Calibri"/>
-              </a:rPr>
-              <a:t>You already out-rank Alexandria on Domain Authority (14 vs 11) — yet they pull ~10x your traffic. That proves the gap is on-page &amp; local, not authority. We close that gap AND push your DA past the market leader to lock in the lead.</a:t>
-            </a:r>
-          </a:p>
-        </p:txBody>
-      </p:sp>
-      <p:sp>
-        <p:nvSpPr>
-          <p:cNvPr id="29" name="TextBox 28"/>
+              <a:rPr sz="1450" b="0">
+                <a:solidFill>
+                  <a:srgbClr val="DCE2E8"/>
+                </a:solidFill>
+                <a:latin typeface="Calibri"/>
+              </a:rPr>
+              <a:t>Most local businesses live in the single digits to low teens. You're already at 14 — ahead of most rivals here. The goal isn't 80; it's ~30, which is very achievable for a local business and puts you clearly ahead of nearly every local competitor. Getting there is exactly what our backlink program does.</a:t>
+            </a:r>
+          </a:p>
+        </p:txBody>
+      </p:sp>
+      <p:sp>
+        <p:nvSpPr>
+          <p:cNvPr id="32" name="TextBox 31"/>
           <p:cNvSpPr txBox="1"/>
           <p:nvPr/>
         </p:nvSpPr>
         <p:spPr>
           <a:xfrm>
-            <a:off x="640080" y="6355080"/>
+            <a:off x="658368" y="6199632"/>
             <a:ext cx="7315200" cy="274320"/>
           </a:xfrm>
           <a:prstGeom prst="rect">
@@ -12359,390 +12455,11 @@
             <a:r>
               <a:rPr sz="1050" b="0">
                 <a:solidFill>
-                  <a:srgbClr val="9AA6B4"/>
-                </a:solidFill>
-                <a:latin typeface="Calibri"/>
-              </a:rPr>
-              <a:t>Domain Authority — Moz, June 2026</a:t>
-            </a:r>
-          </a:p>
-        </p:txBody>
-      </p:sp>
-      <p:sp>
-        <p:nvSpPr>
-          <p:cNvPr id="30" name="TextBox 29"/>
-          <p:cNvSpPr txBox="1"/>
-          <p:nvPr/>
-        </p:nvSpPr>
-        <p:spPr>
-          <a:xfrm>
-            <a:off x="8229600" y="2011680"/>
-            <a:ext cx="3291840" cy="365760"/>
-          </a:xfrm>
-          <a:prstGeom prst="rect">
-            <a:avLst/>
-          </a:prstGeom>
-          <a:noFill/>
-        </p:spPr>
-        <p:txBody>
-          <a:bodyPr wrap="square" anchor="t">
-            <a:spAutoFit/>
-          </a:bodyPr>
-          <a:lstStyle/>
-          <a:p>
-            <a:pPr algn="l">
-              <a:lnSpc>
-                <a:spcPct val="100000"/>
-              </a:lnSpc>
-            </a:pPr>
-            <a:r>
-              <a:rPr sz="1200" b="1">
-                <a:solidFill>
-                  <a:srgbClr val="4ADE80"/>
-                </a:solidFill>
-                <a:latin typeface="Calibri"/>
-              </a:rPr>
-              <a:t>HOW WE GROW IT</a:t>
-            </a:r>
-          </a:p>
-        </p:txBody>
-      </p:sp>
-      <p:sp>
-        <p:nvSpPr>
-          <p:cNvPr id="31" name="Rounded Rectangle 30"/>
-          <p:cNvSpPr/>
-          <p:nvPr/>
-        </p:nvSpPr>
-        <p:spPr>
-          <a:xfrm>
-            <a:off x="8229600" y="2423160"/>
-            <a:ext cx="3291840" cy="457200"/>
-          </a:xfrm>
-          <a:prstGeom prst="roundRect">
-            <a:avLst/>
-          </a:prstGeom>
-          <a:solidFill>
-            <a:srgbClr val="121822"/>
-          </a:solidFill>
-          <a:ln w="9525">
-            <a:solidFill>
-              <a:srgbClr val="232C39"/>
-            </a:solidFill>
-          </a:ln>
-          <a:effectLst/>
-        </p:spPr>
-        <p:style>
-          <a:lnRef idx="1">
-            <a:schemeClr val="accent1"/>
-          </a:lnRef>
-          <a:fillRef idx="3">
-            <a:schemeClr val="accent1"/>
-          </a:fillRef>
-          <a:effectRef idx="2">
-            <a:schemeClr val="accent1"/>
-          </a:effectRef>
-          <a:fontRef idx="minor">
-            <a:schemeClr val="lt1"/>
-          </a:fontRef>
-        </p:style>
-        <p:txBody>
-          <a:bodyPr rtlCol="0" anchor="ctr"/>
-          <a:lstStyle/>
-          <a:p>
-            <a:pPr algn="ctr"/>
-          </a:p>
-        </p:txBody>
-      </p:sp>
-      <p:sp>
-        <p:nvSpPr>
-          <p:cNvPr id="32" name="TextBox 31"/>
-          <p:cNvSpPr txBox="1"/>
-          <p:nvPr/>
-        </p:nvSpPr>
-        <p:spPr>
-          <a:xfrm>
-            <a:off x="8412480" y="2450592"/>
-            <a:ext cx="3017520" cy="411480"/>
-          </a:xfrm>
-          <a:prstGeom prst="rect">
-            <a:avLst/>
-          </a:prstGeom>
-          <a:noFill/>
-        </p:spPr>
-        <p:txBody>
-          <a:bodyPr wrap="square" anchor="ctr">
-            <a:spAutoFit/>
-          </a:bodyPr>
-          <a:lstStyle/>
-          <a:p>
-            <a:pPr algn="l">
-              <a:lnSpc>
-                <a:spcPct val="100000"/>
-              </a:lnSpc>
-            </a:pPr>
-            <a:r>
-              <a:rPr sz="1250" b="0">
-                <a:solidFill>
-                  <a:srgbClr val="FFFFFF"/>
-                </a:solidFill>
-                <a:latin typeface="Calibri"/>
-              </a:rPr>
-              <a:t>High-value local links</a:t>
-            </a:r>
-          </a:p>
-        </p:txBody>
-      </p:sp>
-      <p:sp>
-        <p:nvSpPr>
-          <p:cNvPr id="33" name="Rounded Rectangle 32"/>
-          <p:cNvSpPr/>
-          <p:nvPr/>
-        </p:nvSpPr>
-        <p:spPr>
-          <a:xfrm>
-            <a:off x="8229600" y="2990088"/>
-            <a:ext cx="3291840" cy="457200"/>
-          </a:xfrm>
-          <a:prstGeom prst="roundRect">
-            <a:avLst/>
-          </a:prstGeom>
-          <a:solidFill>
-            <a:srgbClr val="121822"/>
-          </a:solidFill>
-          <a:ln w="9525">
-            <a:solidFill>
-              <a:srgbClr val="232C39"/>
-            </a:solidFill>
-          </a:ln>
-          <a:effectLst/>
-        </p:spPr>
-        <p:style>
-          <a:lnRef idx="1">
-            <a:schemeClr val="accent1"/>
-          </a:lnRef>
-          <a:fillRef idx="3">
-            <a:schemeClr val="accent1"/>
-          </a:fillRef>
-          <a:effectRef idx="2">
-            <a:schemeClr val="accent1"/>
-          </a:effectRef>
-          <a:fontRef idx="minor">
-            <a:schemeClr val="lt1"/>
-          </a:fontRef>
-        </p:style>
-        <p:txBody>
-          <a:bodyPr rtlCol="0" anchor="ctr"/>
-          <a:lstStyle/>
-          <a:p>
-            <a:pPr algn="ctr"/>
-          </a:p>
-        </p:txBody>
-      </p:sp>
-      <p:sp>
-        <p:nvSpPr>
-          <p:cNvPr id="34" name="TextBox 33"/>
-          <p:cNvSpPr txBox="1"/>
-          <p:nvPr/>
-        </p:nvSpPr>
-        <p:spPr>
-          <a:xfrm>
-            <a:off x="8412480" y="3017520"/>
-            <a:ext cx="3017520" cy="411480"/>
-          </a:xfrm>
-          <a:prstGeom prst="rect">
-            <a:avLst/>
-          </a:prstGeom>
-          <a:noFill/>
-        </p:spPr>
-        <p:txBody>
-          <a:bodyPr wrap="square" anchor="ctr">
-            <a:spAutoFit/>
-          </a:bodyPr>
-          <a:lstStyle/>
-          <a:p>
-            <a:pPr algn="l">
-              <a:lnSpc>
-                <a:spcPct val="100000"/>
-              </a:lnSpc>
-            </a:pPr>
-            <a:r>
-              <a:rPr sz="1250" b="0">
-                <a:solidFill>
-                  <a:srgbClr val="FFFFFF"/>
-                </a:solidFill>
-                <a:latin typeface="Calibri"/>
-              </a:rPr>
-              <a:t>Citation building + cleanup</a:t>
-            </a:r>
-          </a:p>
-        </p:txBody>
-      </p:sp>
-      <p:sp>
-        <p:nvSpPr>
-          <p:cNvPr id="35" name="Rounded Rectangle 34"/>
-          <p:cNvSpPr/>
-          <p:nvPr/>
-        </p:nvSpPr>
-        <p:spPr>
-          <a:xfrm>
-            <a:off x="8229600" y="3557015"/>
-            <a:ext cx="3291840" cy="457200"/>
-          </a:xfrm>
-          <a:prstGeom prst="roundRect">
-            <a:avLst/>
-          </a:prstGeom>
-          <a:solidFill>
-            <a:srgbClr val="121822"/>
-          </a:solidFill>
-          <a:ln w="9525">
-            <a:solidFill>
-              <a:srgbClr val="232C39"/>
-            </a:solidFill>
-          </a:ln>
-          <a:effectLst/>
-        </p:spPr>
-        <p:style>
-          <a:lnRef idx="1">
-            <a:schemeClr val="accent1"/>
-          </a:lnRef>
-          <a:fillRef idx="3">
-            <a:schemeClr val="accent1"/>
-          </a:fillRef>
-          <a:effectRef idx="2">
-            <a:schemeClr val="accent1"/>
-          </a:effectRef>
-          <a:fontRef idx="minor">
-            <a:schemeClr val="lt1"/>
-          </a:fontRef>
-        </p:style>
-        <p:txBody>
-          <a:bodyPr rtlCol="0" anchor="ctr"/>
-          <a:lstStyle/>
-          <a:p>
-            <a:pPr algn="ctr"/>
-          </a:p>
-        </p:txBody>
-      </p:sp>
-      <p:sp>
-        <p:nvSpPr>
-          <p:cNvPr id="36" name="TextBox 35"/>
-          <p:cNvSpPr txBox="1"/>
-          <p:nvPr/>
-        </p:nvSpPr>
-        <p:spPr>
-          <a:xfrm>
-            <a:off x="8412480" y="3584448"/>
-            <a:ext cx="3017520" cy="411480"/>
-          </a:xfrm>
-          <a:prstGeom prst="rect">
-            <a:avLst/>
-          </a:prstGeom>
-          <a:noFill/>
-        </p:spPr>
-        <p:txBody>
-          <a:bodyPr wrap="square" anchor="ctr">
-            <a:spAutoFit/>
-          </a:bodyPr>
-          <a:lstStyle/>
-          <a:p>
-            <a:pPr algn="l">
-              <a:lnSpc>
-                <a:spcPct val="100000"/>
-              </a:lnSpc>
-            </a:pPr>
-            <a:r>
-              <a:rPr sz="1250" b="0">
-                <a:solidFill>
-                  <a:srgbClr val="FFFFFF"/>
-                </a:solidFill>
-                <a:latin typeface="Calibri"/>
-              </a:rPr>
-              <a:t>Local press &amp; sponsorships</a:t>
-            </a:r>
-          </a:p>
-        </p:txBody>
-      </p:sp>
-      <p:sp>
-        <p:nvSpPr>
-          <p:cNvPr id="37" name="Rounded Rectangle 36"/>
-          <p:cNvSpPr/>
-          <p:nvPr/>
-        </p:nvSpPr>
-        <p:spPr>
-          <a:xfrm>
-            <a:off x="8229600" y="4123944"/>
-            <a:ext cx="3291840" cy="457200"/>
-          </a:xfrm>
-          <a:prstGeom prst="roundRect">
-            <a:avLst/>
-          </a:prstGeom>
-          <a:solidFill>
-            <a:srgbClr val="121822"/>
-          </a:solidFill>
-          <a:ln w="9525">
-            <a:solidFill>
-              <a:srgbClr val="232C39"/>
-            </a:solidFill>
-          </a:ln>
-          <a:effectLst/>
-        </p:spPr>
-        <p:style>
-          <a:lnRef idx="1">
-            <a:schemeClr val="accent1"/>
-          </a:lnRef>
-          <a:fillRef idx="3">
-            <a:schemeClr val="accent1"/>
-          </a:fillRef>
-          <a:effectRef idx="2">
-            <a:schemeClr val="accent1"/>
-          </a:effectRef>
-          <a:fontRef idx="minor">
-            <a:schemeClr val="lt1"/>
-          </a:fontRef>
-        </p:style>
-        <p:txBody>
-          <a:bodyPr rtlCol="0" anchor="ctr"/>
-          <a:lstStyle/>
-          <a:p>
-            <a:pPr algn="ctr"/>
-          </a:p>
-        </p:txBody>
-      </p:sp>
-      <p:sp>
-        <p:nvSpPr>
-          <p:cNvPr id="38" name="TextBox 37"/>
-          <p:cNvSpPr txBox="1"/>
-          <p:nvPr/>
-        </p:nvSpPr>
-        <p:spPr>
-          <a:xfrm>
-            <a:off x="8412480" y="4151376"/>
-            <a:ext cx="3017520" cy="411480"/>
-          </a:xfrm>
-          <a:prstGeom prst="rect">
-            <a:avLst/>
-          </a:prstGeom>
-          <a:noFill/>
-        </p:spPr>
-        <p:txBody>
-          <a:bodyPr wrap="square" anchor="ctr">
-            <a:spAutoFit/>
-          </a:bodyPr>
-          <a:lstStyle/>
-          <a:p>
-            <a:pPr algn="l">
-              <a:lnSpc>
-                <a:spcPct val="100000"/>
-              </a:lnSpc>
-            </a:pPr>
-            <a:r>
-              <a:rPr sz="1250" b="0">
-                <a:solidFill>
-                  <a:srgbClr val="FFFFFF"/>
-                </a:solidFill>
-                <a:latin typeface="Calibri"/>
-              </a:rPr>
-              <a:t>Partner / supplier links</a:t>
+                  <a:srgbClr val="5E6A79"/>
+                </a:solidFill>
+                <a:latin typeface="Calibri"/>
+              </a:rPr>
+              <a:t>Domain Authority — Moz, June 2026   ·   Backlinks are the #1 lever for raising Domain Authority.</a:t>
             </a:r>
           </a:p>
         </p:txBody>
@@ -13269,6 +12986,33 @@
                 <a:latin typeface="Calibri"/>
               </a:rPr>
               <a:t>Technical foundation: schema markup, llms.txt / llms-full.txt, HTTPS-canonical fixes</a:t>
+            </a:r>
+          </a:p>
+          <a:p>
+            <a:pPr>
+              <a:lnSpc>
+                <a:spcPct val="110000"/>
+              </a:lnSpc>
+              <a:spcAft>
+                <a:spcPts val="1000"/>
+              </a:spcAft>
+            </a:pPr>
+            <a:r>
+              <a:rPr b="1" sz="1800">
+                <a:solidFill>
+                  <a:srgbClr val="4ADE80"/>
+                </a:solidFill>
+              </a:rPr>
+              <a:t>—  </a:t>
+            </a:r>
+            <a:r>
+              <a:rPr sz="1800">
+                <a:solidFill>
+                  <a:srgbClr val="FFFFFF"/>
+                </a:solidFill>
+                <a:latin typeface="Calibri"/>
+              </a:rPr>
+              <a:t>Service &amp; city/location landing pages built for your core markets</a:t>
             </a:r>
           </a:p>
           <a:p>

</xml_diff>

<commit_message>
deck: add visuals — gold cover image, section photos, projected-growth chart
- Full-bleed darkened gold-bar cover image on the title slide.
- Relevant Pexels photos (storefront, jewelry, handshake) on the Done/Backlinks/
  Content slides (license-clean, configurable per client via CLIENT image keys).
- New 'Projected Organic Growth' slide: on-brand rising column chart from current
  (131) toward the 500+ goal with a target line, clearly labeled illustrative.
- picture()/cover_image()/column_chart() helpers added; all paths config-driven
  so a non-Paradigm pitch just swaps the CLIENT image/number block.

Co-Authored-By: Claude Opus 4.8 (1M context) <noreply@anthropic.com>
</commit_message>
<xml_diff>
--- a/deliverables/PracticeRank-SEO-Strategy-Paradigm-Experts.pptx
+++ b/deliverables/PracticeRank-SEO-Strategy-Paradigm-Experts.pptx
@@ -18,6 +18,7 @@
     <p:sldId id="266" r:id="rId17"/>
     <p:sldId id="267" r:id="rId18"/>
     <p:sldId id="268" r:id="rId19"/>
+    <p:sldId id="269" r:id="rId20"/>
   </p:sldIdLst>
   <p:sldSz cx="12191695" cy="6858000" type="screen4x3"/>
   <p:notesSz cx="6858000" cy="9144000"/>
@@ -3240,9 +3241,79 @@
           </a:p>
         </p:txBody>
       </p:sp>
-      <p:sp>
-        <p:nvSpPr>
-          <p:cNvPr id="5" name="Rectangle 4"/>
+      <p:pic>
+        <p:nvPicPr>
+          <p:cNvPr id="5" name="Picture 4" descr="cover-gold.jpg"/>
+          <p:cNvPicPr>
+            <a:picLocks noChangeAspect="1"/>
+          </p:cNvPicPr>
+          <p:nvPr/>
+        </p:nvPicPr>
+        <p:blipFill>
+          <a:blip r:embed="rId2"/>
+          <a:stretch>
+            <a:fillRect/>
+          </a:stretch>
+        </p:blipFill>
+        <p:spPr>
+          <a:xfrm>
+            <a:off x="0" y="-777240"/>
+            <a:ext cx="12191695" cy="8124894"/>
+          </a:xfrm>
+          <a:prstGeom prst="rect">
+            <a:avLst/>
+          </a:prstGeom>
+        </p:spPr>
+      </p:pic>
+      <p:sp>
+        <p:nvSpPr>
+          <p:cNvPr id="6" name="Rectangle 5"/>
+          <p:cNvSpPr/>
+          <p:nvPr/>
+        </p:nvSpPr>
+        <p:spPr>
+          <a:xfrm>
+            <a:off x="0" y="0"/>
+            <a:ext cx="12191695" cy="6858000"/>
+          </a:xfrm>
+          <a:prstGeom prst="rect">
+            <a:avLst/>
+          </a:prstGeom>
+          <a:solidFill>
+            <a:srgbClr val="08080D">
+              <a:alpha val="76000"/>
+            </a:srgbClr>
+          </a:solidFill>
+          <a:ln>
+            <a:noFill/>
+          </a:ln>
+          <a:effectLst/>
+        </p:spPr>
+        <p:style>
+          <a:lnRef idx="1">
+            <a:schemeClr val="accent1"/>
+          </a:lnRef>
+          <a:fillRef idx="3">
+            <a:schemeClr val="accent1"/>
+          </a:fillRef>
+          <a:effectRef idx="2">
+            <a:schemeClr val="accent1"/>
+          </a:effectRef>
+          <a:fontRef idx="minor">
+            <a:schemeClr val="lt1"/>
+          </a:fontRef>
+        </p:style>
+        <p:txBody>
+          <a:bodyPr rtlCol="0" anchor="ctr"/>
+          <a:lstStyle/>
+          <a:p>
+            <a:pPr algn="ctr"/>
+          </a:p>
+        </p:txBody>
+      </p:sp>
+      <p:sp>
+        <p:nvSpPr>
+          <p:cNvPr id="7" name="Rectangle 6"/>
           <p:cNvSpPr/>
           <p:nvPr/>
         </p:nvSpPr>
@@ -3286,14 +3357,14 @@
       </p:sp>
       <p:pic>
         <p:nvPicPr>
-          <p:cNvPr id="6" name="Picture 5" descr="practicerank-logo-360.png"/>
+          <p:cNvPr id="8" name="Picture 7" descr="practicerank-logo-360.png"/>
           <p:cNvPicPr>
             <a:picLocks noChangeAspect="1"/>
           </p:cNvPicPr>
           <p:nvPr/>
         </p:nvPicPr>
         <p:blipFill>
-          <a:blip r:embed="rId2"/>
+          <a:blip r:embed="rId3"/>
           <a:stretch>
             <a:fillRect/>
           </a:stretch>
@@ -3310,7 +3381,7 @@
       </p:pic>
       <p:sp>
         <p:nvSpPr>
-          <p:cNvPr id="7" name="TextBox 6"/>
+          <p:cNvPr id="9" name="TextBox 8"/>
           <p:cNvSpPr txBox="1"/>
           <p:nvPr/>
         </p:nvSpPr>
@@ -3350,7 +3421,7 @@
       </p:sp>
       <p:sp>
         <p:nvSpPr>
-          <p:cNvPr id="8" name="TextBox 7"/>
+          <p:cNvPr id="10" name="TextBox 9"/>
           <p:cNvSpPr txBox="1"/>
           <p:nvPr/>
         </p:nvSpPr>
@@ -3407,7 +3478,7 @@
       </p:sp>
       <p:sp>
         <p:nvSpPr>
-          <p:cNvPr id="9" name="TextBox 8"/>
+          <p:cNvPr id="11" name="TextBox 10"/>
           <p:cNvSpPr txBox="1"/>
           <p:nvPr/>
         </p:nvSpPr>
@@ -3446,7 +3517,7 @@
       </p:sp>
       <p:sp>
         <p:nvSpPr>
-          <p:cNvPr id="10" name="TextBox 9"/>
+          <p:cNvPr id="12" name="TextBox 11"/>
           <p:cNvSpPr txBox="1"/>
           <p:nvPr/>
         </p:nvSpPr>
@@ -3952,8 +4023,8 @@
         </p:nvSpPr>
         <p:spPr>
           <a:xfrm>
-            <a:off x="822960" y="2606040"/>
-            <a:ext cx="10424160" cy="4572000"/>
+            <a:off x="822960" y="2697480"/>
+            <a:ext cx="6583680" cy="4572000"/>
           </a:xfrm>
           <a:prstGeom prst="rect">
             <a:avLst/>
@@ -3975,7 +4046,7 @@
               </a:spcAft>
             </a:pPr>
             <a:r>
-              <a:rPr b="1" sz="1600">
+              <a:rPr b="1" sz="1500">
                 <a:solidFill>
                   <a:srgbClr val="4ADE80"/>
                 </a:solidFill>
@@ -3983,13 +4054,13 @@
               <a:t>—  </a:t>
             </a:r>
             <a:r>
-              <a:rPr sz="1600">
+              <a:rPr sz="1500">
                 <a:solidFill>
                   <a:srgbClr val="FFFFFF"/>
                 </a:solidFill>
                 <a:latin typeface="Calibri"/>
               </a:rPr>
-              <a:t>Target transactional searches like "sell gold in Springfield VA", "estate jewelry buyer near me", "where to sell silver Northern Virginia"</a:t>
+              <a:t>Target real transactional searches from your Google data, like "sell gold in Springfield VA", "estate jewelry buyer near me"</a:t>
             </a:r>
           </a:p>
           <a:p>
@@ -4002,7 +4073,7 @@
               </a:spcAft>
             </a:pPr>
             <a:r>
-              <a:rPr b="1" sz="1600">
+              <a:rPr b="1" sz="1500">
                 <a:solidFill>
                   <a:srgbClr val="4ADE80"/>
                 </a:solidFill>
@@ -4010,13 +4081,13 @@
               <a:t>—  </a:t>
             </a:r>
             <a:r>
-              <a:rPr sz="1600">
+              <a:rPr sz="1500">
                 <a:solidFill>
                   <a:srgbClr val="FFFFFF"/>
                 </a:solidFill>
                 <a:latin typeface="Calibri"/>
               </a:rPr>
-              <a:t>Expand &amp; refresh your landing pages as we find new demand (Springfield · Arlington · McLean · Fairfax · Alexandria · Lorton · DC)</a:t>
+              <a:t>Expand &amp; refresh landing pages as we find new demand</a:t>
             </a:r>
           </a:p>
           <a:p>
@@ -4029,7 +4100,7 @@
               </a:spcAft>
             </a:pPr>
             <a:r>
-              <a:rPr b="1" sz="1600">
+              <a:rPr b="1" sz="1500">
                 <a:solidFill>
                   <a:srgbClr val="4ADE80"/>
                 </a:solidFill>
@@ -4037,13 +4108,13 @@
               <a:t>—  </a:t>
             </a:r>
             <a:r>
-              <a:rPr sz="1600">
+              <a:rPr sz="1500">
                 <a:solidFill>
                   <a:srgbClr val="FFFFFF"/>
                 </a:solidFill>
                 <a:latin typeface="Calibri"/>
               </a:rPr>
-              <a:t>2–4 new posts per month on high-intent topics, refreshed so they stay ranking</a:t>
+              <a:t>2–4 new posts per month on high-intent topics, refreshed to keep ranking</a:t>
             </a:r>
           </a:p>
           <a:p>
@@ -4056,7 +4127,7 @@
               </a:spcAft>
             </a:pPr>
             <a:r>
-              <a:rPr b="1" sz="1600">
+              <a:rPr b="1" sz="1500">
                 <a:solidFill>
                   <a:srgbClr val="4ADE80"/>
                 </a:solidFill>
@@ -4064,7 +4135,7 @@
               <a:t>—  </a:t>
             </a:r>
             <a:r>
-              <a:rPr sz="1600">
+              <a:rPr sz="1500">
                 <a:solidFill>
                   <a:srgbClr val="FFFFFF"/>
                 </a:solidFill>
@@ -4075,6 +4146,35 @@
           </a:p>
         </p:txBody>
       </p:sp>
+      <p:pic>
+        <p:nvPicPr>
+          <p:cNvPr id="14" name="Picture 13" descr="jewelry.jpg"/>
+          <p:cNvPicPr>
+            <a:picLocks noChangeAspect="1"/>
+          </p:cNvPicPr>
+          <p:nvPr/>
+        </p:nvPicPr>
+        <p:blipFill>
+          <a:blip r:embed="rId3"/>
+          <a:stretch>
+            <a:fillRect/>
+          </a:stretch>
+        </p:blipFill>
+        <p:spPr>
+          <a:xfrm>
+            <a:off x="7589520" y="2697480"/>
+            <a:ext cx="3931920" cy="2624328"/>
+          </a:xfrm>
+          <a:prstGeom prst="rect">
+            <a:avLst/>
+          </a:prstGeom>
+          <a:ln w="12700">
+            <a:solidFill>
+              <a:srgbClr val="232C39"/>
+            </a:solidFill>
+          </a:ln>
+        </p:spPr>
+      </p:pic>
     </p:spTree>
   </p:cSld>
   <p:clrMapOvr>
@@ -5170,55 +5270,7 @@
       </p:sp>
       <p:sp>
         <p:nvSpPr>
-          <p:cNvPr id="4" name="Oval 3"/>
-          <p:cNvSpPr/>
-          <p:nvPr/>
-        </p:nvSpPr>
-        <p:spPr>
-          <a:xfrm>
-            <a:off x="8503920" y="3749039"/>
-            <a:ext cx="6400800" cy="6400800"/>
-          </a:xfrm>
-          <a:prstGeom prst="ellipse">
-            <a:avLst/>
-          </a:prstGeom>
-          <a:solidFill>
-            <a:srgbClr val="4ADE80">
-              <a:alpha val="12000"/>
-            </a:srgbClr>
-          </a:solidFill>
-          <a:ln>
-            <a:noFill/>
-          </a:ln>
-          <a:effectLst>
-            <a:softEdge rad="1645920"/>
-          </a:effectLst>
-        </p:spPr>
-        <p:style>
-          <a:lnRef idx="1">
-            <a:schemeClr val="accent1"/>
-          </a:lnRef>
-          <a:fillRef idx="3">
-            <a:schemeClr val="accent1"/>
-          </a:fillRef>
-          <a:effectRef idx="2">
-            <a:schemeClr val="accent1"/>
-          </a:effectRef>
-          <a:fontRef idx="minor">
-            <a:schemeClr val="lt1"/>
-          </a:fontRef>
-        </p:style>
-        <p:txBody>
-          <a:bodyPr rtlCol="0" anchor="ctr"/>
-          <a:lstStyle/>
-          <a:p>
-            <a:pPr algn="ctr"/>
-          </a:p>
-        </p:txBody>
-      </p:sp>
-      <p:sp>
-        <p:nvSpPr>
-          <p:cNvPr id="5" name="Rectangle 4"/>
+          <p:cNvPr id="4" name="Rectangle 3"/>
           <p:cNvSpPr/>
           <p:nvPr/>
         </p:nvSpPr>
@@ -5262,14 +5314,58 @@
       </p:sp>
       <p:sp>
         <p:nvSpPr>
+          <p:cNvPr id="5" name="Rectangle 4"/>
+          <p:cNvSpPr/>
+          <p:nvPr/>
+        </p:nvSpPr>
+        <p:spPr>
+          <a:xfrm>
+            <a:off x="658368" y="566928"/>
+            <a:ext cx="201168" cy="201168"/>
+          </a:xfrm>
+          <a:prstGeom prst="rect">
+            <a:avLst/>
+          </a:prstGeom>
+          <a:solidFill>
+            <a:srgbClr val="4ADE80"/>
+          </a:solidFill>
+          <a:ln>
+            <a:noFill/>
+          </a:ln>
+          <a:effectLst/>
+        </p:spPr>
+        <p:style>
+          <a:lnRef idx="1">
+            <a:schemeClr val="accent1"/>
+          </a:lnRef>
+          <a:fillRef idx="3">
+            <a:schemeClr val="accent1"/>
+          </a:fillRef>
+          <a:effectRef idx="2">
+            <a:schemeClr val="accent1"/>
+          </a:effectRef>
+          <a:fontRef idx="minor">
+            <a:schemeClr val="lt1"/>
+          </a:fontRef>
+        </p:style>
+        <p:txBody>
+          <a:bodyPr rtlCol="0" anchor="ctr"/>
+          <a:lstStyle/>
+          <a:p>
+            <a:pPr algn="ctr"/>
+          </a:p>
+        </p:txBody>
+      </p:sp>
+      <p:sp>
+        <p:nvSpPr>
           <p:cNvPr id="6" name="TextBox 5"/>
           <p:cNvSpPr txBox="1"/>
           <p:nvPr/>
         </p:nvSpPr>
         <p:spPr>
           <a:xfrm>
-            <a:off x="640080" y="1920240"/>
-            <a:ext cx="10972800" cy="457200"/>
+            <a:off x="960120" y="502920"/>
+            <a:ext cx="10058400" cy="365760"/>
           </a:xfrm>
           <a:prstGeom prst="rect">
             <a:avLst/>
@@ -5282,19 +5378,19 @@
           </a:bodyPr>
           <a:lstStyle/>
           <a:p>
-            <a:pPr algn="ctr">
+            <a:pPr algn="l">
               <a:lnSpc>
                 <a:spcPct val="100000"/>
               </a:lnSpc>
             </a:pPr>
             <a:r>
-              <a:rPr sz="1500" b="1">
+              <a:rPr sz="1300" b="1">
                 <a:solidFill>
                   <a:srgbClr val="4ADE80"/>
                 </a:solidFill>
                 <a:latin typeface="Calibri"/>
               </a:rPr>
-              <a:t>OUR PROMISE</a:t>
+              <a:t>THE TRAJECTORY</a:t>
             </a:r>
           </a:p>
         </p:txBody>
@@ -5307,8 +5403,8 @@
         </p:nvSpPr>
         <p:spPr>
           <a:xfrm>
-            <a:off x="914400" y="2468880"/>
-            <a:ext cx="10332720" cy="1097280"/>
+            <a:off x="621792" y="896112"/>
+            <a:ext cx="10972800" cy="914400"/>
           </a:xfrm>
           <a:prstGeom prst="rect">
             <a:avLst/>
@@ -5321,33 +5417,267 @@
           </a:bodyPr>
           <a:lstStyle/>
           <a:p>
-            <a:pPr algn="ctr">
+            <a:pPr algn="l">
               <a:lnSpc>
                 <a:spcPct val="100000"/>
               </a:lnSpc>
             </a:pPr>
             <a:r>
-              <a:rPr sz="3400" b="1">
+              <a:rPr sz="3200" b="1">
                 <a:solidFill>
                   <a:srgbClr val="FFFFFF"/>
                 </a:solidFill>
                 <a:latin typeface="Calibri"/>
               </a:rPr>
-              <a:t>The 90-Day Results-or-Refund Guarantee</a:t>
-            </a:r>
-          </a:p>
-        </p:txBody>
-      </p:sp>
-      <p:sp>
-        <p:nvSpPr>
-          <p:cNvPr id="8" name="TextBox 7"/>
+              <a:t>Projected Organic Growth</a:t>
+            </a:r>
+          </a:p>
+        </p:txBody>
+      </p:sp>
+      <p:sp>
+        <p:nvSpPr>
+          <p:cNvPr id="8" name="Rectangle 7"/>
+          <p:cNvSpPr/>
+          <p:nvPr/>
+        </p:nvSpPr>
+        <p:spPr>
+          <a:xfrm>
+            <a:off x="676656" y="1627632"/>
+            <a:ext cx="731520" cy="50292"/>
+          </a:xfrm>
+          <a:prstGeom prst="rect">
+            <a:avLst/>
+          </a:prstGeom>
+          <a:solidFill>
+            <a:srgbClr val="4ADE80"/>
+          </a:solidFill>
+          <a:ln>
+            <a:noFill/>
+          </a:ln>
+          <a:effectLst/>
+        </p:spPr>
+        <p:style>
+          <a:lnRef idx="1">
+            <a:schemeClr val="accent1"/>
+          </a:lnRef>
+          <a:fillRef idx="3">
+            <a:schemeClr val="accent1"/>
+          </a:fillRef>
+          <a:effectRef idx="2">
+            <a:schemeClr val="accent1"/>
+          </a:effectRef>
+          <a:fontRef idx="minor">
+            <a:schemeClr val="lt1"/>
+          </a:fontRef>
+        </p:style>
+        <p:txBody>
+          <a:bodyPr rtlCol="0" anchor="ctr"/>
+          <a:lstStyle/>
+          <a:p>
+            <a:pPr algn="ctr"/>
+          </a:p>
+        </p:txBody>
+      </p:sp>
+      <p:pic>
+        <p:nvPicPr>
+          <p:cNvPr id="9" name="Picture 8" descr="practicerank-logo-360.png"/>
+          <p:cNvPicPr>
+            <a:picLocks noChangeAspect="1"/>
+          </p:cNvPicPr>
+          <p:nvPr/>
+        </p:nvPicPr>
+        <p:blipFill>
+          <a:blip r:embed="rId2"/>
+          <a:stretch>
+            <a:fillRect/>
+          </a:stretch>
+        </p:blipFill>
+        <p:spPr>
+          <a:xfrm>
+            <a:off x="640080" y="6419088"/>
+            <a:ext cx="237744" cy="237744"/>
+          </a:xfrm>
+          <a:prstGeom prst="rect">
+            <a:avLst/>
+          </a:prstGeom>
+        </p:spPr>
+      </p:pic>
+      <p:sp>
+        <p:nvSpPr>
+          <p:cNvPr id="10" name="TextBox 9"/>
           <p:cNvSpPr txBox="1"/>
           <p:nvPr/>
         </p:nvSpPr>
         <p:spPr>
           <a:xfrm>
-            <a:off x="1371600" y="3749039"/>
-            <a:ext cx="9418320" cy="1280160"/>
+            <a:off x="960120" y="6400800"/>
+            <a:ext cx="3657600" cy="274320"/>
+          </a:xfrm>
+          <a:prstGeom prst="rect">
+            <a:avLst/>
+          </a:prstGeom>
+          <a:noFill/>
+        </p:spPr>
+        <p:txBody>
+          <a:bodyPr wrap="square" anchor="ctr">
+            <a:spAutoFit/>
+          </a:bodyPr>
+          <a:lstStyle/>
+          <a:p>
+            <a:pPr algn="l">
+              <a:lnSpc>
+                <a:spcPct val="100000"/>
+              </a:lnSpc>
+            </a:pPr>
+            <a:r>
+              <a:rPr sz="900" b="0">
+                <a:solidFill>
+                  <a:srgbClr val="5E6A79"/>
+                </a:solidFill>
+                <a:latin typeface="Calibri"/>
+              </a:rPr>
+              <a:t>practicerank.ai</a:t>
+            </a:r>
+          </a:p>
+        </p:txBody>
+      </p:sp>
+      <p:sp>
+        <p:nvSpPr>
+          <p:cNvPr id="11" name="TextBox 10"/>
+          <p:cNvSpPr txBox="1"/>
+          <p:nvPr/>
+        </p:nvSpPr>
+        <p:spPr>
+          <a:xfrm>
+            <a:off x="10561320" y="6400800"/>
+            <a:ext cx="1005840" cy="274320"/>
+          </a:xfrm>
+          <a:prstGeom prst="rect">
+            <a:avLst/>
+          </a:prstGeom>
+          <a:noFill/>
+        </p:spPr>
+        <p:txBody>
+          <a:bodyPr wrap="square" anchor="ctr">
+            <a:spAutoFit/>
+          </a:bodyPr>
+          <a:lstStyle/>
+          <a:p>
+            <a:pPr algn="r">
+              <a:lnSpc>
+                <a:spcPct val="100000"/>
+              </a:lnSpc>
+            </a:pPr>
+            <a:r>
+              <a:rPr sz="900" b="0">
+                <a:solidFill>
+                  <a:srgbClr val="5E6A79"/>
+                </a:solidFill>
+                <a:latin typeface="Calibri"/>
+              </a:rPr>
+              <a:t>12</a:t>
+            </a:r>
+          </a:p>
+        </p:txBody>
+      </p:sp>
+      <p:sp>
+        <p:nvSpPr>
+          <p:cNvPr id="12" name="Rectangle 11"/>
+          <p:cNvSpPr/>
+          <p:nvPr/>
+        </p:nvSpPr>
+        <p:spPr>
+          <a:xfrm>
+            <a:off x="1143000" y="5303520"/>
+            <a:ext cx="9875519" cy="18288"/>
+          </a:xfrm>
+          <a:prstGeom prst="rect">
+            <a:avLst/>
+          </a:prstGeom>
+          <a:solidFill>
+            <a:srgbClr val="232C39"/>
+          </a:solidFill>
+          <a:ln>
+            <a:noFill/>
+          </a:ln>
+          <a:effectLst/>
+        </p:spPr>
+        <p:style>
+          <a:lnRef idx="1">
+            <a:schemeClr val="accent1"/>
+          </a:lnRef>
+          <a:fillRef idx="3">
+            <a:schemeClr val="accent1"/>
+          </a:fillRef>
+          <a:effectRef idx="2">
+            <a:schemeClr val="accent1"/>
+          </a:effectRef>
+          <a:fontRef idx="minor">
+            <a:schemeClr val="lt1"/>
+          </a:fontRef>
+        </p:style>
+        <p:txBody>
+          <a:bodyPr rtlCol="0" anchor="ctr"/>
+          <a:lstStyle/>
+          <a:p>
+            <a:pPr algn="ctr"/>
+          </a:p>
+        </p:txBody>
+      </p:sp>
+      <p:sp>
+        <p:nvSpPr>
+          <p:cNvPr id="13" name="Rectangle 12"/>
+          <p:cNvSpPr/>
+          <p:nvPr/>
+        </p:nvSpPr>
+        <p:spPr>
+          <a:xfrm>
+            <a:off x="1188720" y="2895055"/>
+            <a:ext cx="9784080" cy="22860"/>
+          </a:xfrm>
+          <a:prstGeom prst="rect">
+            <a:avLst/>
+          </a:prstGeom>
+          <a:solidFill>
+            <a:srgbClr val="4ADE80"/>
+          </a:solidFill>
+          <a:ln>
+            <a:noFill/>
+          </a:ln>
+          <a:effectLst/>
+        </p:spPr>
+        <p:style>
+          <a:lnRef idx="1">
+            <a:schemeClr val="accent1"/>
+          </a:lnRef>
+          <a:fillRef idx="3">
+            <a:schemeClr val="accent1"/>
+          </a:fillRef>
+          <a:effectRef idx="2">
+            <a:schemeClr val="accent1"/>
+          </a:effectRef>
+          <a:fontRef idx="minor">
+            <a:schemeClr val="lt1"/>
+          </a:fontRef>
+        </p:style>
+        <p:txBody>
+          <a:bodyPr rtlCol="0" anchor="ctr"/>
+          <a:lstStyle/>
+          <a:p>
+            <a:pPr algn="ctr"/>
+          </a:p>
+        </p:txBody>
+      </p:sp>
+      <p:sp>
+        <p:nvSpPr>
+          <p:cNvPr id="14" name="TextBox 13"/>
+          <p:cNvSpPr txBox="1"/>
+          <p:nvPr/>
+        </p:nvSpPr>
+        <p:spPr>
+          <a:xfrm>
+            <a:off x="9144000" y="2529295"/>
+            <a:ext cx="1828800" cy="274320"/>
           </a:xfrm>
           <a:prstGeom prst="rect">
             <a:avLst/>
@@ -5360,19 +5690,912 @@
           </a:bodyPr>
           <a:lstStyle/>
           <a:p>
+            <a:pPr algn="r">
+              <a:lnSpc>
+                <a:spcPct val="100000"/>
+              </a:lnSpc>
+            </a:pPr>
+            <a:r>
+              <a:rPr sz="1100" b="1">
+                <a:solidFill>
+                  <a:srgbClr val="4ADE80"/>
+                </a:solidFill>
+                <a:latin typeface="Calibri"/>
+              </a:rPr>
+              <a:t>Goal 520+</a:t>
+            </a:r>
+          </a:p>
+        </p:txBody>
+      </p:sp>
+      <p:sp>
+        <p:nvSpPr>
+          <p:cNvPr id="15" name="Rectangle 14"/>
+          <p:cNvSpPr/>
+          <p:nvPr/>
+        </p:nvSpPr>
+        <p:spPr>
+          <a:xfrm>
+            <a:off x="1188720" y="4696772"/>
+            <a:ext cx="1225295" cy="606747"/>
+          </a:xfrm>
+          <a:prstGeom prst="rect">
+            <a:avLst/>
+          </a:prstGeom>
+          <a:solidFill>
+            <a:srgbClr val="3A4655"/>
+          </a:solidFill>
+          <a:ln>
+            <a:noFill/>
+          </a:ln>
+          <a:effectLst/>
+        </p:spPr>
+        <p:style>
+          <a:lnRef idx="1">
+            <a:schemeClr val="accent1"/>
+          </a:lnRef>
+          <a:fillRef idx="3">
+            <a:schemeClr val="accent1"/>
+          </a:fillRef>
+          <a:effectRef idx="2">
+            <a:schemeClr val="accent1"/>
+          </a:effectRef>
+          <a:fontRef idx="minor">
+            <a:schemeClr val="lt1"/>
+          </a:fontRef>
+        </p:style>
+        <p:txBody>
+          <a:bodyPr rtlCol="0" anchor="ctr"/>
+          <a:lstStyle/>
+          <a:p>
+            <a:pPr algn="ctr"/>
+          </a:p>
+        </p:txBody>
+      </p:sp>
+      <p:sp>
+        <p:nvSpPr>
+          <p:cNvPr id="16" name="TextBox 15"/>
+          <p:cNvSpPr txBox="1"/>
+          <p:nvPr/>
+        </p:nvSpPr>
+        <p:spPr>
+          <a:xfrm>
+            <a:off x="1005840" y="4312724"/>
+            <a:ext cx="1591055" cy="320040"/>
+          </a:xfrm>
+          <a:prstGeom prst="rect">
+            <a:avLst/>
+          </a:prstGeom>
+          <a:noFill/>
+        </p:spPr>
+        <p:txBody>
+          <a:bodyPr wrap="square" anchor="t">
+            <a:spAutoFit/>
+          </a:bodyPr>
+          <a:lstStyle/>
+          <a:p>
             <a:pPr algn="ctr">
               <a:lnSpc>
-                <a:spcPct val="125000"/>
-              </a:lnSpc>
-            </a:pPr>
-            <a:r>
-              <a:rPr sz="1800" b="0">
+                <a:spcPct val="100000"/>
+              </a:lnSpc>
+            </a:pPr>
+            <a:r>
+              <a:rPr sz="1200" b="1">
+                <a:solidFill>
+                  <a:srgbClr val="FFFFFF"/>
+                </a:solidFill>
+                <a:latin typeface="Calibri"/>
+              </a:rPr>
+              <a:t>131</a:t>
+            </a:r>
+          </a:p>
+        </p:txBody>
+      </p:sp>
+      <p:sp>
+        <p:nvSpPr>
+          <p:cNvPr id="17" name="TextBox 16"/>
+          <p:cNvSpPr txBox="1"/>
+          <p:nvPr/>
+        </p:nvSpPr>
+        <p:spPr>
+          <a:xfrm>
+            <a:off x="1005840" y="5376672"/>
+            <a:ext cx="1591055" cy="274320"/>
+          </a:xfrm>
+          <a:prstGeom prst="rect">
+            <a:avLst/>
+          </a:prstGeom>
+          <a:noFill/>
+        </p:spPr>
+        <p:txBody>
+          <a:bodyPr wrap="square" anchor="t">
+            <a:spAutoFit/>
+          </a:bodyPr>
+          <a:lstStyle/>
+          <a:p>
+            <a:pPr algn="ctr">
+              <a:lnSpc>
+                <a:spcPct val="100000"/>
+              </a:lnSpc>
+            </a:pPr>
+            <a:r>
+              <a:rPr sz="1100" b="0">
                 <a:solidFill>
                   <a:srgbClr val="9AA6B4"/>
                 </a:solidFill>
                 <a:latin typeface="Calibri"/>
               </a:rPr>
-              <a:t>If your PracticeRank Score doesn't improve by 20+ points in 90 days, we refund your monthly fees — and you keep everything we built. Month-to-month. No long-term contracts.</a:t>
+              <a:t>Now</a:t>
+            </a:r>
+          </a:p>
+        </p:txBody>
+      </p:sp>
+      <p:sp>
+        <p:nvSpPr>
+          <p:cNvPr id="18" name="Rectangle 17"/>
+          <p:cNvSpPr/>
+          <p:nvPr/>
+        </p:nvSpPr>
+        <p:spPr>
+          <a:xfrm>
+            <a:off x="2615184" y="4395714"/>
+            <a:ext cx="1225295" cy="907805"/>
+          </a:xfrm>
+          <a:prstGeom prst="rect">
+            <a:avLst/>
+          </a:prstGeom>
+          <a:solidFill>
+            <a:srgbClr val="3A4655"/>
+          </a:solidFill>
+          <a:ln>
+            <a:noFill/>
+          </a:ln>
+          <a:effectLst/>
+        </p:spPr>
+        <p:style>
+          <a:lnRef idx="1">
+            <a:schemeClr val="accent1"/>
+          </a:lnRef>
+          <a:fillRef idx="3">
+            <a:schemeClr val="accent1"/>
+          </a:fillRef>
+          <a:effectRef idx="2">
+            <a:schemeClr val="accent1"/>
+          </a:effectRef>
+          <a:fontRef idx="minor">
+            <a:schemeClr val="lt1"/>
+          </a:fontRef>
+        </p:style>
+        <p:txBody>
+          <a:bodyPr rtlCol="0" anchor="ctr"/>
+          <a:lstStyle/>
+          <a:p>
+            <a:pPr algn="ctr"/>
+          </a:p>
+        </p:txBody>
+      </p:sp>
+      <p:sp>
+        <p:nvSpPr>
+          <p:cNvPr id="19" name="TextBox 18"/>
+          <p:cNvSpPr txBox="1"/>
+          <p:nvPr/>
+        </p:nvSpPr>
+        <p:spPr>
+          <a:xfrm>
+            <a:off x="2432303" y="4011666"/>
+            <a:ext cx="1591055" cy="320040"/>
+          </a:xfrm>
+          <a:prstGeom prst="rect">
+            <a:avLst/>
+          </a:prstGeom>
+          <a:noFill/>
+        </p:spPr>
+        <p:txBody>
+          <a:bodyPr wrap="square" anchor="t">
+            <a:spAutoFit/>
+          </a:bodyPr>
+          <a:lstStyle/>
+          <a:p>
+            <a:pPr algn="ctr">
+              <a:lnSpc>
+                <a:spcPct val="100000"/>
+              </a:lnSpc>
+            </a:pPr>
+            <a:r>
+              <a:rPr sz="1200" b="1">
+                <a:solidFill>
+                  <a:srgbClr val="FFFFFF"/>
+                </a:solidFill>
+                <a:latin typeface="Calibri"/>
+              </a:rPr>
+              <a:t>196</a:t>
+            </a:r>
+          </a:p>
+        </p:txBody>
+      </p:sp>
+      <p:sp>
+        <p:nvSpPr>
+          <p:cNvPr id="20" name="TextBox 19"/>
+          <p:cNvSpPr txBox="1"/>
+          <p:nvPr/>
+        </p:nvSpPr>
+        <p:spPr>
+          <a:xfrm>
+            <a:off x="2432303" y="5376672"/>
+            <a:ext cx="1591055" cy="274320"/>
+          </a:xfrm>
+          <a:prstGeom prst="rect">
+            <a:avLst/>
+          </a:prstGeom>
+          <a:noFill/>
+        </p:spPr>
+        <p:txBody>
+          <a:bodyPr wrap="square" anchor="t">
+            <a:spAutoFit/>
+          </a:bodyPr>
+          <a:lstStyle/>
+          <a:p>
+            <a:pPr algn="ctr">
+              <a:lnSpc>
+                <a:spcPct val="100000"/>
+              </a:lnSpc>
+            </a:pPr>
+            <a:r>
+              <a:rPr sz="1100" b="0">
+                <a:solidFill>
+                  <a:srgbClr val="9AA6B4"/>
+                </a:solidFill>
+                <a:latin typeface="Calibri"/>
+              </a:rPr>
+              <a:t>Mo 1</a:t>
+            </a:r>
+          </a:p>
+        </p:txBody>
+      </p:sp>
+      <p:sp>
+        <p:nvSpPr>
+          <p:cNvPr id="21" name="Rectangle 20"/>
+          <p:cNvSpPr/>
+          <p:nvPr/>
+        </p:nvSpPr>
+        <p:spPr>
+          <a:xfrm>
+            <a:off x="4041648" y="4094656"/>
+            <a:ext cx="1225295" cy="1208863"/>
+          </a:xfrm>
+          <a:prstGeom prst="rect">
+            <a:avLst/>
+          </a:prstGeom>
+          <a:solidFill>
+            <a:srgbClr val="3A4655"/>
+          </a:solidFill>
+          <a:ln>
+            <a:noFill/>
+          </a:ln>
+          <a:effectLst/>
+        </p:spPr>
+        <p:style>
+          <a:lnRef idx="1">
+            <a:schemeClr val="accent1"/>
+          </a:lnRef>
+          <a:fillRef idx="3">
+            <a:schemeClr val="accent1"/>
+          </a:fillRef>
+          <a:effectRef idx="2">
+            <a:schemeClr val="accent1"/>
+          </a:effectRef>
+          <a:fontRef idx="minor">
+            <a:schemeClr val="lt1"/>
+          </a:fontRef>
+        </p:style>
+        <p:txBody>
+          <a:bodyPr rtlCol="0" anchor="ctr"/>
+          <a:lstStyle/>
+          <a:p>
+            <a:pPr algn="ctr"/>
+          </a:p>
+        </p:txBody>
+      </p:sp>
+      <p:sp>
+        <p:nvSpPr>
+          <p:cNvPr id="22" name="TextBox 21"/>
+          <p:cNvSpPr txBox="1"/>
+          <p:nvPr/>
+        </p:nvSpPr>
+        <p:spPr>
+          <a:xfrm>
+            <a:off x="3858768" y="3710608"/>
+            <a:ext cx="1591055" cy="320040"/>
+          </a:xfrm>
+          <a:prstGeom prst="rect">
+            <a:avLst/>
+          </a:prstGeom>
+          <a:noFill/>
+        </p:spPr>
+        <p:txBody>
+          <a:bodyPr wrap="square" anchor="t">
+            <a:spAutoFit/>
+          </a:bodyPr>
+          <a:lstStyle/>
+          <a:p>
+            <a:pPr algn="ctr">
+              <a:lnSpc>
+                <a:spcPct val="100000"/>
+              </a:lnSpc>
+            </a:pPr>
+            <a:r>
+              <a:rPr sz="1200" b="1">
+                <a:solidFill>
+                  <a:srgbClr val="FFFFFF"/>
+                </a:solidFill>
+                <a:latin typeface="Calibri"/>
+              </a:rPr>
+              <a:t>261</a:t>
+            </a:r>
+          </a:p>
+        </p:txBody>
+      </p:sp>
+      <p:sp>
+        <p:nvSpPr>
+          <p:cNvPr id="23" name="TextBox 22"/>
+          <p:cNvSpPr txBox="1"/>
+          <p:nvPr/>
+        </p:nvSpPr>
+        <p:spPr>
+          <a:xfrm>
+            <a:off x="3858768" y="5376672"/>
+            <a:ext cx="1591055" cy="274320"/>
+          </a:xfrm>
+          <a:prstGeom prst="rect">
+            <a:avLst/>
+          </a:prstGeom>
+          <a:noFill/>
+        </p:spPr>
+        <p:txBody>
+          <a:bodyPr wrap="square" anchor="t">
+            <a:spAutoFit/>
+          </a:bodyPr>
+          <a:lstStyle/>
+          <a:p>
+            <a:pPr algn="ctr">
+              <a:lnSpc>
+                <a:spcPct val="100000"/>
+              </a:lnSpc>
+            </a:pPr>
+            <a:r>
+              <a:rPr sz="1100" b="0">
+                <a:solidFill>
+                  <a:srgbClr val="9AA6B4"/>
+                </a:solidFill>
+                <a:latin typeface="Calibri"/>
+              </a:rPr>
+              <a:t>Mo 2</a:t>
+            </a:r>
+          </a:p>
+        </p:txBody>
+      </p:sp>
+      <p:sp>
+        <p:nvSpPr>
+          <p:cNvPr id="24" name="Rectangle 23"/>
+          <p:cNvSpPr/>
+          <p:nvPr/>
+        </p:nvSpPr>
+        <p:spPr>
+          <a:xfrm>
+            <a:off x="5468112" y="3793598"/>
+            <a:ext cx="1225295" cy="1509921"/>
+          </a:xfrm>
+          <a:prstGeom prst="rect">
+            <a:avLst/>
+          </a:prstGeom>
+          <a:solidFill>
+            <a:srgbClr val="3A4655"/>
+          </a:solidFill>
+          <a:ln>
+            <a:noFill/>
+          </a:ln>
+          <a:effectLst/>
+        </p:spPr>
+        <p:style>
+          <a:lnRef idx="1">
+            <a:schemeClr val="accent1"/>
+          </a:lnRef>
+          <a:fillRef idx="3">
+            <a:schemeClr val="accent1"/>
+          </a:fillRef>
+          <a:effectRef idx="2">
+            <a:schemeClr val="accent1"/>
+          </a:effectRef>
+          <a:fontRef idx="minor">
+            <a:schemeClr val="lt1"/>
+          </a:fontRef>
+        </p:style>
+        <p:txBody>
+          <a:bodyPr rtlCol="0" anchor="ctr"/>
+          <a:lstStyle/>
+          <a:p>
+            <a:pPr algn="ctr"/>
+          </a:p>
+        </p:txBody>
+      </p:sp>
+      <p:sp>
+        <p:nvSpPr>
+          <p:cNvPr id="25" name="TextBox 24"/>
+          <p:cNvSpPr txBox="1"/>
+          <p:nvPr/>
+        </p:nvSpPr>
+        <p:spPr>
+          <a:xfrm>
+            <a:off x="5285231" y="3409550"/>
+            <a:ext cx="1591055" cy="320040"/>
+          </a:xfrm>
+          <a:prstGeom prst="rect">
+            <a:avLst/>
+          </a:prstGeom>
+          <a:noFill/>
+        </p:spPr>
+        <p:txBody>
+          <a:bodyPr wrap="square" anchor="t">
+            <a:spAutoFit/>
+          </a:bodyPr>
+          <a:lstStyle/>
+          <a:p>
+            <a:pPr algn="ctr">
+              <a:lnSpc>
+                <a:spcPct val="100000"/>
+              </a:lnSpc>
+            </a:pPr>
+            <a:r>
+              <a:rPr sz="1200" b="1">
+                <a:solidFill>
+                  <a:srgbClr val="FFFFFF"/>
+                </a:solidFill>
+                <a:latin typeface="Calibri"/>
+              </a:rPr>
+              <a:t>326</a:t>
+            </a:r>
+          </a:p>
+        </p:txBody>
+      </p:sp>
+      <p:sp>
+        <p:nvSpPr>
+          <p:cNvPr id="26" name="TextBox 25"/>
+          <p:cNvSpPr txBox="1"/>
+          <p:nvPr/>
+        </p:nvSpPr>
+        <p:spPr>
+          <a:xfrm>
+            <a:off x="5285231" y="5376672"/>
+            <a:ext cx="1591055" cy="274320"/>
+          </a:xfrm>
+          <a:prstGeom prst="rect">
+            <a:avLst/>
+          </a:prstGeom>
+          <a:noFill/>
+        </p:spPr>
+        <p:txBody>
+          <a:bodyPr wrap="square" anchor="t">
+            <a:spAutoFit/>
+          </a:bodyPr>
+          <a:lstStyle/>
+          <a:p>
+            <a:pPr algn="ctr">
+              <a:lnSpc>
+                <a:spcPct val="100000"/>
+              </a:lnSpc>
+            </a:pPr>
+            <a:r>
+              <a:rPr sz="1100" b="0">
+                <a:solidFill>
+                  <a:srgbClr val="9AA6B4"/>
+                </a:solidFill>
+                <a:latin typeface="Calibri"/>
+              </a:rPr>
+              <a:t>Mo 3</a:t>
+            </a:r>
+          </a:p>
+        </p:txBody>
+      </p:sp>
+      <p:sp>
+        <p:nvSpPr>
+          <p:cNvPr id="27" name="Rectangle 26"/>
+          <p:cNvSpPr/>
+          <p:nvPr/>
+        </p:nvSpPr>
+        <p:spPr>
+          <a:xfrm>
+            <a:off x="6894575" y="3497171"/>
+            <a:ext cx="1225295" cy="1806348"/>
+          </a:xfrm>
+          <a:prstGeom prst="rect">
+            <a:avLst/>
+          </a:prstGeom>
+          <a:solidFill>
+            <a:srgbClr val="3A4655"/>
+          </a:solidFill>
+          <a:ln>
+            <a:noFill/>
+          </a:ln>
+          <a:effectLst/>
+        </p:spPr>
+        <p:style>
+          <a:lnRef idx="1">
+            <a:schemeClr val="accent1"/>
+          </a:lnRef>
+          <a:fillRef idx="3">
+            <a:schemeClr val="accent1"/>
+          </a:fillRef>
+          <a:effectRef idx="2">
+            <a:schemeClr val="accent1"/>
+          </a:effectRef>
+          <a:fontRef idx="minor">
+            <a:schemeClr val="lt1"/>
+          </a:fontRef>
+        </p:style>
+        <p:txBody>
+          <a:bodyPr rtlCol="0" anchor="ctr"/>
+          <a:lstStyle/>
+          <a:p>
+            <a:pPr algn="ctr"/>
+          </a:p>
+        </p:txBody>
+      </p:sp>
+      <p:sp>
+        <p:nvSpPr>
+          <p:cNvPr id="28" name="TextBox 27"/>
+          <p:cNvSpPr txBox="1"/>
+          <p:nvPr/>
+        </p:nvSpPr>
+        <p:spPr>
+          <a:xfrm>
+            <a:off x="6711695" y="3113123"/>
+            <a:ext cx="1591055" cy="320040"/>
+          </a:xfrm>
+          <a:prstGeom prst="rect">
+            <a:avLst/>
+          </a:prstGeom>
+          <a:noFill/>
+        </p:spPr>
+        <p:txBody>
+          <a:bodyPr wrap="square" anchor="t">
+            <a:spAutoFit/>
+          </a:bodyPr>
+          <a:lstStyle/>
+          <a:p>
+            <a:pPr algn="ctr">
+              <a:lnSpc>
+                <a:spcPct val="100000"/>
+              </a:lnSpc>
+            </a:pPr>
+            <a:r>
+              <a:rPr sz="1200" b="1">
+                <a:solidFill>
+                  <a:srgbClr val="FFFFFF"/>
+                </a:solidFill>
+                <a:latin typeface="Calibri"/>
+              </a:rPr>
+              <a:t>390</a:t>
+            </a:r>
+          </a:p>
+        </p:txBody>
+      </p:sp>
+      <p:sp>
+        <p:nvSpPr>
+          <p:cNvPr id="29" name="TextBox 28"/>
+          <p:cNvSpPr txBox="1"/>
+          <p:nvPr/>
+        </p:nvSpPr>
+        <p:spPr>
+          <a:xfrm>
+            <a:off x="6711695" y="5376672"/>
+            <a:ext cx="1591055" cy="274320"/>
+          </a:xfrm>
+          <a:prstGeom prst="rect">
+            <a:avLst/>
+          </a:prstGeom>
+          <a:noFill/>
+        </p:spPr>
+        <p:txBody>
+          <a:bodyPr wrap="square" anchor="t">
+            <a:spAutoFit/>
+          </a:bodyPr>
+          <a:lstStyle/>
+          <a:p>
+            <a:pPr algn="ctr">
+              <a:lnSpc>
+                <a:spcPct val="100000"/>
+              </a:lnSpc>
+            </a:pPr>
+            <a:r>
+              <a:rPr sz="1100" b="0">
+                <a:solidFill>
+                  <a:srgbClr val="9AA6B4"/>
+                </a:solidFill>
+                <a:latin typeface="Calibri"/>
+              </a:rPr>
+              <a:t>Mo 4</a:t>
+            </a:r>
+          </a:p>
+        </p:txBody>
+      </p:sp>
+      <p:sp>
+        <p:nvSpPr>
+          <p:cNvPr id="30" name="Rectangle 29"/>
+          <p:cNvSpPr/>
+          <p:nvPr/>
+        </p:nvSpPr>
+        <p:spPr>
+          <a:xfrm>
+            <a:off x="8321040" y="3196113"/>
+            <a:ext cx="1225295" cy="2107406"/>
+          </a:xfrm>
+          <a:prstGeom prst="rect">
+            <a:avLst/>
+          </a:prstGeom>
+          <a:solidFill>
+            <a:srgbClr val="3A4655"/>
+          </a:solidFill>
+          <a:ln>
+            <a:noFill/>
+          </a:ln>
+          <a:effectLst/>
+        </p:spPr>
+        <p:style>
+          <a:lnRef idx="1">
+            <a:schemeClr val="accent1"/>
+          </a:lnRef>
+          <a:fillRef idx="3">
+            <a:schemeClr val="accent1"/>
+          </a:fillRef>
+          <a:effectRef idx="2">
+            <a:schemeClr val="accent1"/>
+          </a:effectRef>
+          <a:fontRef idx="minor">
+            <a:schemeClr val="lt1"/>
+          </a:fontRef>
+        </p:style>
+        <p:txBody>
+          <a:bodyPr rtlCol="0" anchor="ctr"/>
+          <a:lstStyle/>
+          <a:p>
+            <a:pPr algn="ctr"/>
+          </a:p>
+        </p:txBody>
+      </p:sp>
+      <p:sp>
+        <p:nvSpPr>
+          <p:cNvPr id="31" name="TextBox 30"/>
+          <p:cNvSpPr txBox="1"/>
+          <p:nvPr/>
+        </p:nvSpPr>
+        <p:spPr>
+          <a:xfrm>
+            <a:off x="8138160" y="2812065"/>
+            <a:ext cx="1591055" cy="320040"/>
+          </a:xfrm>
+          <a:prstGeom prst="rect">
+            <a:avLst/>
+          </a:prstGeom>
+          <a:noFill/>
+        </p:spPr>
+        <p:txBody>
+          <a:bodyPr wrap="square" anchor="t">
+            <a:spAutoFit/>
+          </a:bodyPr>
+          <a:lstStyle/>
+          <a:p>
+            <a:pPr algn="ctr">
+              <a:lnSpc>
+                <a:spcPct val="100000"/>
+              </a:lnSpc>
+            </a:pPr>
+            <a:r>
+              <a:rPr sz="1200" b="1">
+                <a:solidFill>
+                  <a:srgbClr val="FFFFFF"/>
+                </a:solidFill>
+                <a:latin typeface="Calibri"/>
+              </a:rPr>
+              <a:t>455</a:t>
+            </a:r>
+          </a:p>
+        </p:txBody>
+      </p:sp>
+      <p:sp>
+        <p:nvSpPr>
+          <p:cNvPr id="32" name="TextBox 31"/>
+          <p:cNvSpPr txBox="1"/>
+          <p:nvPr/>
+        </p:nvSpPr>
+        <p:spPr>
+          <a:xfrm>
+            <a:off x="8138160" y="5376672"/>
+            <a:ext cx="1591055" cy="274320"/>
+          </a:xfrm>
+          <a:prstGeom prst="rect">
+            <a:avLst/>
+          </a:prstGeom>
+          <a:noFill/>
+        </p:spPr>
+        <p:txBody>
+          <a:bodyPr wrap="square" anchor="t">
+            <a:spAutoFit/>
+          </a:bodyPr>
+          <a:lstStyle/>
+          <a:p>
+            <a:pPr algn="ctr">
+              <a:lnSpc>
+                <a:spcPct val="100000"/>
+              </a:lnSpc>
+            </a:pPr>
+            <a:r>
+              <a:rPr sz="1100" b="0">
+                <a:solidFill>
+                  <a:srgbClr val="9AA6B4"/>
+                </a:solidFill>
+                <a:latin typeface="Calibri"/>
+              </a:rPr>
+              <a:t>Mo 5</a:t>
+            </a:r>
+          </a:p>
+        </p:txBody>
+      </p:sp>
+      <p:sp>
+        <p:nvSpPr>
+          <p:cNvPr id="33" name="Rectangle 32"/>
+          <p:cNvSpPr/>
+          <p:nvPr/>
+        </p:nvSpPr>
+        <p:spPr>
+          <a:xfrm>
+            <a:off x="9747504" y="2895055"/>
+            <a:ext cx="1225295" cy="2408464"/>
+          </a:xfrm>
+          <a:prstGeom prst="rect">
+            <a:avLst/>
+          </a:prstGeom>
+          <a:solidFill>
+            <a:srgbClr val="4ADE80"/>
+          </a:solidFill>
+          <a:ln>
+            <a:noFill/>
+          </a:ln>
+          <a:effectLst/>
+        </p:spPr>
+        <p:style>
+          <a:lnRef idx="1">
+            <a:schemeClr val="accent1"/>
+          </a:lnRef>
+          <a:fillRef idx="3">
+            <a:schemeClr val="accent1"/>
+          </a:fillRef>
+          <a:effectRef idx="2">
+            <a:schemeClr val="accent1"/>
+          </a:effectRef>
+          <a:fontRef idx="minor">
+            <a:schemeClr val="lt1"/>
+          </a:fontRef>
+        </p:style>
+        <p:txBody>
+          <a:bodyPr rtlCol="0" anchor="ctr"/>
+          <a:lstStyle/>
+          <a:p>
+            <a:pPr algn="ctr"/>
+          </a:p>
+        </p:txBody>
+      </p:sp>
+      <p:sp>
+        <p:nvSpPr>
+          <p:cNvPr id="34" name="TextBox 33"/>
+          <p:cNvSpPr txBox="1"/>
+          <p:nvPr/>
+        </p:nvSpPr>
+        <p:spPr>
+          <a:xfrm>
+            <a:off x="9564624" y="2511007"/>
+            <a:ext cx="1591055" cy="320040"/>
+          </a:xfrm>
+          <a:prstGeom prst="rect">
+            <a:avLst/>
+          </a:prstGeom>
+          <a:noFill/>
+        </p:spPr>
+        <p:txBody>
+          <a:bodyPr wrap="square" anchor="t">
+            <a:spAutoFit/>
+          </a:bodyPr>
+          <a:lstStyle/>
+          <a:p>
+            <a:pPr algn="ctr">
+              <a:lnSpc>
+                <a:spcPct val="100000"/>
+              </a:lnSpc>
+            </a:pPr>
+            <a:r>
+              <a:rPr sz="1200" b="1">
+                <a:solidFill>
+                  <a:srgbClr val="4ADE80"/>
+                </a:solidFill>
+                <a:latin typeface="Calibri"/>
+              </a:rPr>
+              <a:t>520</a:t>
+            </a:r>
+          </a:p>
+        </p:txBody>
+      </p:sp>
+      <p:sp>
+        <p:nvSpPr>
+          <p:cNvPr id="35" name="TextBox 34"/>
+          <p:cNvSpPr txBox="1"/>
+          <p:nvPr/>
+        </p:nvSpPr>
+        <p:spPr>
+          <a:xfrm>
+            <a:off x="9564624" y="5376672"/>
+            <a:ext cx="1591055" cy="274320"/>
+          </a:xfrm>
+          <a:prstGeom prst="rect">
+            <a:avLst/>
+          </a:prstGeom>
+          <a:noFill/>
+        </p:spPr>
+        <p:txBody>
+          <a:bodyPr wrap="square" anchor="t">
+            <a:spAutoFit/>
+          </a:bodyPr>
+          <a:lstStyle/>
+          <a:p>
+            <a:pPr algn="ctr">
+              <a:lnSpc>
+                <a:spcPct val="100000"/>
+              </a:lnSpc>
+            </a:pPr>
+            <a:r>
+              <a:rPr sz="1100" b="0">
+                <a:solidFill>
+                  <a:srgbClr val="9AA6B4"/>
+                </a:solidFill>
+                <a:latin typeface="Calibri"/>
+              </a:rPr>
+              <a:t>Mo 6</a:t>
+            </a:r>
+          </a:p>
+        </p:txBody>
+      </p:sp>
+      <p:sp>
+        <p:nvSpPr>
+          <p:cNvPr id="36" name="TextBox 35"/>
+          <p:cNvSpPr txBox="1"/>
+          <p:nvPr/>
+        </p:nvSpPr>
+        <p:spPr>
+          <a:xfrm>
+            <a:off x="658368" y="5806440"/>
+            <a:ext cx="10881360" cy="548640"/>
+          </a:xfrm>
+          <a:prstGeom prst="rect">
+            <a:avLst/>
+          </a:prstGeom>
+          <a:noFill/>
+        </p:spPr>
+        <p:txBody>
+          <a:bodyPr wrap="square" anchor="t">
+            <a:spAutoFit/>
+          </a:bodyPr>
+          <a:lstStyle/>
+          <a:p>
+            <a:pPr algn="l">
+              <a:lnSpc>
+                <a:spcPct val="115000"/>
+              </a:lnSpc>
+            </a:pPr>
+            <a:r>
+              <a:rPr sz="1250" b="0">
+                <a:solidFill>
+                  <a:srgbClr val="5E6A79"/>
+                </a:solidFill>
+                <a:latin typeface="Calibri"/>
+              </a:rPr>
+              <a:t>Illustrative trajectory toward the 500+ monthly-visit goal as on-page, local, and authority work compound — not a guarantee. Backed by our 90-day score-improvement guarantee.</a:t>
             </a:r>
           </a:p>
         </p:txBody>
@@ -5579,6 +6802,325 @@
           </a:p>
         </p:txBody>
       </p:sp>
+      <p:sp>
+        <p:nvSpPr>
+          <p:cNvPr id="6" name="TextBox 5"/>
+          <p:cNvSpPr txBox="1"/>
+          <p:nvPr/>
+        </p:nvSpPr>
+        <p:spPr>
+          <a:xfrm>
+            <a:off x="640080" y="1920240"/>
+            <a:ext cx="10972800" cy="457200"/>
+          </a:xfrm>
+          <a:prstGeom prst="rect">
+            <a:avLst/>
+          </a:prstGeom>
+          <a:noFill/>
+        </p:spPr>
+        <p:txBody>
+          <a:bodyPr wrap="square" anchor="t">
+            <a:spAutoFit/>
+          </a:bodyPr>
+          <a:lstStyle/>
+          <a:p>
+            <a:pPr algn="ctr">
+              <a:lnSpc>
+                <a:spcPct val="100000"/>
+              </a:lnSpc>
+            </a:pPr>
+            <a:r>
+              <a:rPr sz="1500" b="1">
+                <a:solidFill>
+                  <a:srgbClr val="4ADE80"/>
+                </a:solidFill>
+                <a:latin typeface="Calibri"/>
+              </a:rPr>
+              <a:t>OUR PROMISE</a:t>
+            </a:r>
+          </a:p>
+        </p:txBody>
+      </p:sp>
+      <p:sp>
+        <p:nvSpPr>
+          <p:cNvPr id="7" name="TextBox 6"/>
+          <p:cNvSpPr txBox="1"/>
+          <p:nvPr/>
+        </p:nvSpPr>
+        <p:spPr>
+          <a:xfrm>
+            <a:off x="914400" y="2468880"/>
+            <a:ext cx="10332720" cy="1097280"/>
+          </a:xfrm>
+          <a:prstGeom prst="rect">
+            <a:avLst/>
+          </a:prstGeom>
+          <a:noFill/>
+        </p:spPr>
+        <p:txBody>
+          <a:bodyPr wrap="square" anchor="t">
+            <a:spAutoFit/>
+          </a:bodyPr>
+          <a:lstStyle/>
+          <a:p>
+            <a:pPr algn="ctr">
+              <a:lnSpc>
+                <a:spcPct val="100000"/>
+              </a:lnSpc>
+            </a:pPr>
+            <a:r>
+              <a:rPr sz="3400" b="1">
+                <a:solidFill>
+                  <a:srgbClr val="FFFFFF"/>
+                </a:solidFill>
+                <a:latin typeface="Calibri"/>
+              </a:rPr>
+              <a:t>The 90-Day Results-or-Refund Guarantee</a:t>
+            </a:r>
+          </a:p>
+        </p:txBody>
+      </p:sp>
+      <p:sp>
+        <p:nvSpPr>
+          <p:cNvPr id="8" name="TextBox 7"/>
+          <p:cNvSpPr txBox="1"/>
+          <p:nvPr/>
+        </p:nvSpPr>
+        <p:spPr>
+          <a:xfrm>
+            <a:off x="1371600" y="3749039"/>
+            <a:ext cx="9418320" cy="1280160"/>
+          </a:xfrm>
+          <a:prstGeom prst="rect">
+            <a:avLst/>
+          </a:prstGeom>
+          <a:noFill/>
+        </p:spPr>
+        <p:txBody>
+          <a:bodyPr wrap="square" anchor="t">
+            <a:spAutoFit/>
+          </a:bodyPr>
+          <a:lstStyle/>
+          <a:p>
+            <a:pPr algn="ctr">
+              <a:lnSpc>
+                <a:spcPct val="125000"/>
+              </a:lnSpc>
+            </a:pPr>
+            <a:r>
+              <a:rPr sz="1800" b="0">
+                <a:solidFill>
+                  <a:srgbClr val="9AA6B4"/>
+                </a:solidFill>
+                <a:latin typeface="Calibri"/>
+              </a:rPr>
+              <a:t>If your PracticeRank Score doesn't improve by 20+ points in 90 days, we refund your monthly fees — and you keep everything we built. Month-to-month. No long-term contracts.</a:t>
+            </a:r>
+          </a:p>
+        </p:txBody>
+      </p:sp>
+    </p:spTree>
+  </p:cSld>
+  <p:clrMapOvr>
+    <a:masterClrMapping/>
+  </p:clrMapOvr>
+</p:sld>
+</file>
+
+<file path=ppt/slides/slide14.xml><?xml version="1.0" encoding="utf-8"?>
+<p:sld xmlns:a="http://schemas.openxmlformats.org/drawingml/2006/main" xmlns:p="http://schemas.openxmlformats.org/presentationml/2006/main" xmlns:r="http://schemas.openxmlformats.org/officeDocument/2006/relationships">
+  <p:cSld>
+    <p:spTree>
+      <p:nvGrpSpPr>
+        <p:cNvPr id="1" name=""/>
+        <p:cNvGrpSpPr/>
+        <p:nvPr/>
+      </p:nvGrpSpPr>
+      <p:grpSpPr/>
+      <p:sp>
+        <p:nvSpPr>
+          <p:cNvPr id="2" name="Rectangle 1"/>
+          <p:cNvSpPr/>
+          <p:nvPr/>
+        </p:nvSpPr>
+        <p:spPr>
+          <a:xfrm>
+            <a:off x="0" y="0"/>
+            <a:ext cx="12191695" cy="6858000"/>
+          </a:xfrm>
+          <a:prstGeom prst="rect">
+            <a:avLst/>
+          </a:prstGeom>
+          <a:solidFill>
+            <a:srgbClr val="08080D"/>
+          </a:solidFill>
+          <a:ln>
+            <a:noFill/>
+          </a:ln>
+          <a:effectLst/>
+        </p:spPr>
+        <p:style>
+          <a:lnRef idx="1">
+            <a:schemeClr val="accent1"/>
+          </a:lnRef>
+          <a:fillRef idx="3">
+            <a:schemeClr val="accent1"/>
+          </a:fillRef>
+          <a:effectRef idx="2">
+            <a:schemeClr val="accent1"/>
+          </a:effectRef>
+          <a:fontRef idx="minor">
+            <a:schemeClr val="lt1"/>
+          </a:fontRef>
+        </p:style>
+        <p:txBody>
+          <a:bodyPr rtlCol="0" anchor="ctr"/>
+          <a:lstStyle/>
+          <a:p>
+            <a:pPr algn="ctr"/>
+          </a:p>
+        </p:txBody>
+      </p:sp>
+      <p:sp>
+        <p:nvSpPr>
+          <p:cNvPr id="3" name="Oval 2"/>
+          <p:cNvSpPr/>
+          <p:nvPr/>
+        </p:nvSpPr>
+        <p:spPr>
+          <a:xfrm>
+            <a:off x="-758952" y="-4251960"/>
+            <a:ext cx="13716000" cy="5943600"/>
+          </a:xfrm>
+          <a:prstGeom prst="ellipse">
+            <a:avLst/>
+          </a:prstGeom>
+          <a:solidFill>
+            <a:srgbClr val="16213E">
+              <a:alpha val="46000"/>
+            </a:srgbClr>
+          </a:solidFill>
+          <a:ln>
+            <a:noFill/>
+          </a:ln>
+          <a:effectLst>
+            <a:softEdge rad="1463040"/>
+          </a:effectLst>
+        </p:spPr>
+        <p:style>
+          <a:lnRef idx="1">
+            <a:schemeClr val="accent1"/>
+          </a:lnRef>
+          <a:fillRef idx="3">
+            <a:schemeClr val="accent1"/>
+          </a:fillRef>
+          <a:effectRef idx="2">
+            <a:schemeClr val="accent1"/>
+          </a:effectRef>
+          <a:fontRef idx="minor">
+            <a:schemeClr val="lt1"/>
+          </a:fontRef>
+        </p:style>
+        <p:txBody>
+          <a:bodyPr rtlCol="0" anchor="ctr"/>
+          <a:lstStyle/>
+          <a:p>
+            <a:pPr algn="ctr"/>
+          </a:p>
+        </p:txBody>
+      </p:sp>
+      <p:sp>
+        <p:nvSpPr>
+          <p:cNvPr id="4" name="Oval 3"/>
+          <p:cNvSpPr/>
+          <p:nvPr/>
+        </p:nvSpPr>
+        <p:spPr>
+          <a:xfrm>
+            <a:off x="8503920" y="3749039"/>
+            <a:ext cx="6400800" cy="6400800"/>
+          </a:xfrm>
+          <a:prstGeom prst="ellipse">
+            <a:avLst/>
+          </a:prstGeom>
+          <a:solidFill>
+            <a:srgbClr val="4ADE80">
+              <a:alpha val="12000"/>
+            </a:srgbClr>
+          </a:solidFill>
+          <a:ln>
+            <a:noFill/>
+          </a:ln>
+          <a:effectLst>
+            <a:softEdge rad="1645920"/>
+          </a:effectLst>
+        </p:spPr>
+        <p:style>
+          <a:lnRef idx="1">
+            <a:schemeClr val="accent1"/>
+          </a:lnRef>
+          <a:fillRef idx="3">
+            <a:schemeClr val="accent1"/>
+          </a:fillRef>
+          <a:effectRef idx="2">
+            <a:schemeClr val="accent1"/>
+          </a:effectRef>
+          <a:fontRef idx="minor">
+            <a:schemeClr val="lt1"/>
+          </a:fontRef>
+        </p:style>
+        <p:txBody>
+          <a:bodyPr rtlCol="0" anchor="ctr"/>
+          <a:lstStyle/>
+          <a:p>
+            <a:pPr algn="ctr"/>
+          </a:p>
+        </p:txBody>
+      </p:sp>
+      <p:sp>
+        <p:nvSpPr>
+          <p:cNvPr id="5" name="Rectangle 4"/>
+          <p:cNvSpPr/>
+          <p:nvPr/>
+        </p:nvSpPr>
+        <p:spPr>
+          <a:xfrm>
+            <a:off x="0" y="0"/>
+            <a:ext cx="12191695" cy="109728"/>
+          </a:xfrm>
+          <a:prstGeom prst="rect">
+            <a:avLst/>
+          </a:prstGeom>
+          <a:solidFill>
+            <a:srgbClr val="4ADE80"/>
+          </a:solidFill>
+          <a:ln>
+            <a:noFill/>
+          </a:ln>
+          <a:effectLst/>
+        </p:spPr>
+        <p:style>
+          <a:lnRef idx="1">
+            <a:schemeClr val="accent1"/>
+          </a:lnRef>
+          <a:fillRef idx="3">
+            <a:schemeClr val="accent1"/>
+          </a:fillRef>
+          <a:effectRef idx="2">
+            <a:schemeClr val="accent1"/>
+          </a:effectRef>
+          <a:fontRef idx="minor">
+            <a:schemeClr val="lt1"/>
+          </a:fontRef>
+        </p:style>
+        <p:txBody>
+          <a:bodyPr rtlCol="0" anchor="ctr"/>
+          <a:lstStyle/>
+          <a:p>
+            <a:pPr algn="ctr"/>
+          </a:p>
+        </p:txBody>
+      </p:sp>
       <p:pic>
         <p:nvPicPr>
           <p:cNvPr id="6" name="Picture 5" descr="practicerank-logo-360.png"/>
@@ -12894,8 +14436,8 @@
         </p:nvSpPr>
         <p:spPr>
           <a:xfrm>
-            <a:off x="822960" y="2103120"/>
-            <a:ext cx="10424160" cy="4572000"/>
+            <a:off x="822960" y="2057400"/>
+            <a:ext cx="6858000" cy="4572000"/>
           </a:xfrm>
           <a:prstGeom prst="rect">
             <a:avLst/>
@@ -12917,7 +14459,7 @@
               </a:spcAft>
             </a:pPr>
             <a:r>
-              <a:rPr b="1" sz="1800">
+              <a:rPr b="1" sz="1500">
                 <a:solidFill>
                   <a:srgbClr val="4ADE80"/>
                 </a:solidFill>
@@ -12925,7 +14467,7 @@
               <a:t>—  </a:t>
             </a:r>
             <a:r>
-              <a:rPr sz="1800">
+              <a:rPr sz="1500">
                 <a:solidFill>
                   <a:srgbClr val="FFFFFF"/>
                 </a:solidFill>
@@ -12944,7 +14486,7 @@
               </a:spcAft>
             </a:pPr>
             <a:r>
-              <a:rPr b="1" sz="1800">
+              <a:rPr b="1" sz="1500">
                 <a:solidFill>
                   <a:srgbClr val="4ADE80"/>
                 </a:solidFill>
@@ -12952,7 +14494,7 @@
               <a:t>—  </a:t>
             </a:r>
             <a:r>
-              <a:rPr sz="1800">
+              <a:rPr sz="1500">
                 <a:solidFill>
                   <a:srgbClr val="FFFFFF"/>
                 </a:solidFill>
@@ -12971,7 +14513,7 @@
               </a:spcAft>
             </a:pPr>
             <a:r>
-              <a:rPr b="1" sz="1800">
+              <a:rPr b="1" sz="1500">
                 <a:solidFill>
                   <a:srgbClr val="4ADE80"/>
                 </a:solidFill>
@@ -12979,7 +14521,7 @@
               <a:t>—  </a:t>
             </a:r>
             <a:r>
-              <a:rPr sz="1800">
+              <a:rPr sz="1500">
                 <a:solidFill>
                   <a:srgbClr val="FFFFFF"/>
                 </a:solidFill>
@@ -12998,7 +14540,7 @@
               </a:spcAft>
             </a:pPr>
             <a:r>
-              <a:rPr b="1" sz="1800">
+              <a:rPr b="1" sz="1500">
                 <a:solidFill>
                   <a:srgbClr val="4ADE80"/>
                 </a:solidFill>
@@ -13006,7 +14548,7 @@
               <a:t>—  </a:t>
             </a:r>
             <a:r>
-              <a:rPr sz="1800">
+              <a:rPr sz="1500">
                 <a:solidFill>
                   <a:srgbClr val="FFFFFF"/>
                 </a:solidFill>
@@ -13025,7 +14567,7 @@
               </a:spcAft>
             </a:pPr>
             <a:r>
-              <a:rPr b="1" sz="1800">
+              <a:rPr b="1" sz="1500">
                 <a:solidFill>
                   <a:srgbClr val="4ADE80"/>
                 </a:solidFill>
@@ -13033,7 +14575,7 @@
               <a:t>—  </a:t>
             </a:r>
             <a:r>
-              <a:rPr sz="1800">
+              <a:rPr sz="1500">
                 <a:solidFill>
                   <a:srgbClr val="FFFFFF"/>
                 </a:solidFill>
@@ -13052,7 +14594,7 @@
               </a:spcAft>
             </a:pPr>
             <a:r>
-              <a:rPr b="1" sz="1800">
+              <a:rPr b="1" sz="1500">
                 <a:solidFill>
                   <a:srgbClr val="4ADE80"/>
                 </a:solidFill>
@@ -13060,7 +14602,7 @@
               <a:t>—  </a:t>
             </a:r>
             <a:r>
-              <a:rPr sz="1800">
+              <a:rPr sz="1500">
                 <a:solidFill>
                   <a:srgbClr val="FFFFFF"/>
                 </a:solidFill>
@@ -13071,15 +14613,44 @@
           </a:p>
         </p:txBody>
       </p:sp>
-      <p:sp>
-        <p:nvSpPr>
-          <p:cNvPr id="13" name="TextBox 12"/>
+      <p:pic>
+        <p:nvPicPr>
+          <p:cNvPr id="13" name="Picture 12" descr="consult.jpg"/>
+          <p:cNvPicPr>
+            <a:picLocks noChangeAspect="1"/>
+          </p:cNvPicPr>
+          <p:nvPr/>
+        </p:nvPicPr>
+        <p:blipFill>
+          <a:blip r:embed="rId3"/>
+          <a:stretch>
+            <a:fillRect/>
+          </a:stretch>
+        </p:blipFill>
+        <p:spPr>
+          <a:xfrm>
+            <a:off x="7818120" y="2103120"/>
+            <a:ext cx="3749039" cy="2496312"/>
+          </a:xfrm>
+          <a:prstGeom prst="rect">
+            <a:avLst/>
+          </a:prstGeom>
+          <a:ln w="12700">
+            <a:solidFill>
+              <a:srgbClr val="232C39"/>
+            </a:solidFill>
+          </a:ln>
+        </p:spPr>
+      </p:pic>
+      <p:sp>
+        <p:nvSpPr>
+          <p:cNvPr id="14" name="TextBox 13"/>
           <p:cNvSpPr txBox="1"/>
           <p:nvPr/>
         </p:nvSpPr>
         <p:spPr>
           <a:xfrm>
-            <a:off x="822960" y="5394960"/>
+            <a:off x="822960" y="5623560"/>
             <a:ext cx="10424160" cy="457200"/>
           </a:xfrm>
           <a:prstGeom prst="rect">
@@ -13579,8 +15150,8 @@
         </p:nvSpPr>
         <p:spPr>
           <a:xfrm>
-            <a:off x="822960" y="2651760"/>
-            <a:ext cx="10424160" cy="4572000"/>
+            <a:off x="822960" y="2697480"/>
+            <a:ext cx="6583680" cy="4572000"/>
           </a:xfrm>
           <a:prstGeom prst="rect">
             <a:avLst/>
@@ -13602,7 +15173,7 @@
               </a:spcAft>
             </a:pPr>
             <a:r>
-              <a:rPr b="1" sz="1600">
+              <a:rPr b="1" sz="1500">
                 <a:solidFill>
                   <a:srgbClr val="4ADE80"/>
                 </a:solidFill>
@@ -13610,13 +15181,13 @@
               <a:t>—  </a:t>
             </a:r>
             <a:r>
-              <a:rPr sz="1600">
+              <a:rPr sz="1500">
                 <a:solidFill>
                   <a:srgbClr val="FFFFFF"/>
                 </a:solidFill>
                 <a:latin typeface="Calibri"/>
               </a:rPr>
-              <a:t>Local citations + NAP consistency across the directories that matter (industry + general)</a:t>
+              <a:t>Local citations + NAP consistency across the directories that matter</a:t>
             </a:r>
           </a:p>
           <a:p>
@@ -13629,7 +15200,7 @@
               </a:spcAft>
             </a:pPr>
             <a:r>
-              <a:rPr b="1" sz="1600">
+              <a:rPr b="1" sz="1500">
                 <a:solidFill>
                   <a:srgbClr val="4ADE80"/>
                 </a:solidFill>
@@ -13637,13 +15208,13 @@
               <a:t>—  </a:t>
             </a:r>
             <a:r>
-              <a:rPr sz="1600">
+              <a:rPr sz="1500">
                 <a:solidFill>
                   <a:srgbClr val="FFFFFF"/>
                 </a:solidFill>
                 <a:latin typeface="Calibri"/>
               </a:rPr>
-              <a:t>Local press, community sponsorships &amp; events for authoritative local mentions</a:t>
+              <a:t>Local press, community sponsorships &amp; events for authoritative mentions</a:t>
             </a:r>
           </a:p>
           <a:p>
@@ -13656,7 +15227,7 @@
               </a:spcAft>
             </a:pPr>
             <a:r>
-              <a:rPr b="1" sz="1600">
+              <a:rPr b="1" sz="1500">
                 <a:solidFill>
                   <a:srgbClr val="4ADE80"/>
                 </a:solidFill>
@@ -13664,7 +15235,7 @@
               <a:t>—  </a:t>
             </a:r>
             <a:r>
-              <a:rPr sz="1600">
+              <a:rPr sz="1500">
                 <a:solidFill>
                   <a:srgbClr val="FFFFFF"/>
                 </a:solidFill>
@@ -13683,7 +15254,7 @@
               </a:spcAft>
             </a:pPr>
             <a:r>
-              <a:rPr b="1" sz="1600">
+              <a:rPr b="1" sz="1500">
                 <a:solidFill>
                   <a:srgbClr val="4ADE80"/>
                 </a:solidFill>
@@ -13691,7 +15262,7 @@
               <a:t>—  </a:t>
             </a:r>
             <a:r>
-              <a:rPr sz="1600">
+              <a:rPr sz="1500">
                 <a:solidFill>
                   <a:srgbClr val="FFFFFF"/>
                 </a:solidFill>
@@ -13710,7 +15281,7 @@
               </a:spcAft>
             </a:pPr>
             <a:r>
-              <a:rPr b="1" sz="1600">
+              <a:rPr b="1" sz="1500">
                 <a:solidFill>
                   <a:srgbClr val="4ADE80"/>
                 </a:solidFill>
@@ -13718,17 +15289,46 @@
               <a:t>—  </a:t>
             </a:r>
             <a:r>
-              <a:rPr sz="1600">
+              <a:rPr sz="1500">
                 <a:solidFill>
                   <a:srgbClr val="FFFFFF"/>
                 </a:solidFill>
                 <a:latin typeface="Calibri"/>
               </a:rPr>
-              <a:t>Steady cadence of high-authority links each month — no spam, no risky tactics</a:t>
-            </a:r>
-          </a:p>
-        </p:txBody>
-      </p:sp>
+              <a:t>Steady cadence of high-authority links each month — no spam</a:t>
+            </a:r>
+          </a:p>
+        </p:txBody>
+      </p:sp>
+      <p:pic>
+        <p:nvPicPr>
+          <p:cNvPr id="14" name="Picture 13" descr="storefront.jpg"/>
+          <p:cNvPicPr>
+            <a:picLocks noChangeAspect="1"/>
+          </p:cNvPicPr>
+          <p:nvPr/>
+        </p:nvPicPr>
+        <p:blipFill>
+          <a:blip r:embed="rId3"/>
+          <a:stretch>
+            <a:fillRect/>
+          </a:stretch>
+        </p:blipFill>
+        <p:spPr>
+          <a:xfrm>
+            <a:off x="7589520" y="2697480"/>
+            <a:ext cx="3931920" cy="2624328"/>
+          </a:xfrm>
+          <a:prstGeom prst="rect">
+            <a:avLst/>
+          </a:prstGeom>
+          <a:ln w="12700">
+            <a:solidFill>
+              <a:srgbClr val="232C39"/>
+            </a:solidFill>
+          </a:ln>
+        </p:spPr>
+      </p:pic>
     </p:spTree>
   </p:cSld>
   <p:clrMapOvr>

</xml_diff>

<commit_message>
deck: genericize 'Semrush' -> 'competitive organic-search analysis'
Don't name a specific third-party tool in the client deck — the claim stays
accurate without depending on a Semrush subscription. Ongoing data comes from
tools we own (Google Search Console + Moz).
</commit_message>
<xml_diff>
--- a/deliverables/PracticeRank-SEO-Strategy-Paradigm-Experts.pptx
+++ b/deliverables/PracticeRank-SEO-Strategy-Paradigm-Experts.pptx
@@ -12715,7 +12715,7 @@
                 </a:solidFill>
                 <a:latin typeface="Calibri"/>
               </a:rPr>
-              <a:t>Source: Semrush organic research, May 2026</a:t>
+              <a:t>Source: competitive organic-search analysis, May 2026</a:t>
             </a:r>
           </a:p>
         </p:txBody>
@@ -14473,7 +14473,7 @@
                 </a:solidFill>
                 <a:latin typeface="Calibri"/>
               </a:rPr>
-              <a:t>Deep competitive &amp; keyword-gap analysis vs your top local rival (Semrush)</a:t>
+              <a:t>Deep competitive &amp; keyword-gap analysis vs your top local rival</a:t>
             </a:r>
           </a:p>
           <a:p>

</xml_diff>

<commit_message>
deck: fix growth-chart label overlap (move 'Goal' label to top-left, off the Mo 6 bar)
</commit_message>
<xml_diff>
--- a/deliverables/PracticeRank-SEO-Strategy-Paradigm-Experts.pptx
+++ b/deliverables/PracticeRank-SEO-Strategy-Paradigm-Experts.pptx
@@ -5676,8 +5676,8 @@
         </p:nvSpPr>
         <p:spPr>
           <a:xfrm>
-            <a:off x="9144000" y="2529295"/>
-            <a:ext cx="1828800" cy="274320"/>
+            <a:off x="1188720" y="2492719"/>
+            <a:ext cx="2743200" cy="292608"/>
           </a:xfrm>
           <a:prstGeom prst="rect">
             <a:avLst/>
@@ -5690,7 +5690,7 @@
           </a:bodyPr>
           <a:lstStyle/>
           <a:p>
-            <a:pPr algn="r">
+            <a:pPr algn="l">
               <a:lnSpc>
                 <a:spcPct val="100000"/>
               </a:lnSpc>
@@ -5702,7 +5702,7 @@
                 </a:solidFill>
                 <a:latin typeface="Calibri"/>
               </a:rPr>
-              <a:t>Goal 520+</a:t>
+              <a:t>Goal: 520+</a:t>
             </a:r>
           </a:p>
         </p:txBody>

</xml_diff>

<commit_message>
deck: add PracticeRank Score proof slide (65 -> 79, +14 already) + chart label fix
Shows Paradigm's real score journey (started 65, now 79 = +14 of the 20-point
guarantee lift, in a few weeks) — start vs today cards + delta + guarantee
tie-in. Real data from practicerank_scores. Also moved the growth-chart 'Goal'
label off the Mo 6 bar.
</commit_message>
<xml_diff>
--- a/deliverables/PracticeRank-SEO-Strategy-Paradigm-Experts.pptx
+++ b/deliverables/PracticeRank-SEO-Strategy-Paradigm-Experts.pptx
@@ -19,6 +19,7 @@
     <p:sldId id="267" r:id="rId18"/>
     <p:sldId id="268" r:id="rId19"/>
     <p:sldId id="269" r:id="rId20"/>
+    <p:sldId id="270" r:id="rId21"/>
   </p:sldIdLst>
   <p:sldSz cx="12191695" cy="6858000" type="screen4x3"/>
   <p:notesSz cx="6858000" cy="9144000"/>
@@ -3786,7 +3787,7 @@
                 </a:solidFill>
                 <a:latin typeface="Calibri"/>
               </a:rPr>
-              <a:t>NEXT STEPS · 2 OF 2</a:t>
+              <a:t>NEXT STEPS · 1 OF 2</a:t>
             </a:r>
           </a:p>
         </p:txBody>
@@ -3825,7 +3826,7 @@
                 </a:solidFill>
                 <a:latin typeface="Calibri"/>
               </a:rPr>
-              <a:t>Content &amp; Blog — Capture Ready-to-Buy Searches</a:t>
+              <a:t>Building Authority — High-Value Backlinks</a:t>
             </a:r>
           </a:p>
         </p:txBody>
@@ -4010,7 +4011,7 @@
                 </a:solidFill>
                 <a:latin typeface="Calibri"/>
               </a:rPr>
-              <a:t>Shift from curiosity content to buyer-intent content that brings customers through the door.</a:t>
+              <a:t>Quality over volume: a few strong, locally-relevant links that lift rankings AND AI recommendations.</a:t>
             </a:r>
           </a:p>
         </p:txBody>
@@ -4060,7 +4061,7 @@
                 </a:solidFill>
                 <a:latin typeface="Calibri"/>
               </a:rPr>
-              <a:t>Target real transactional searches from your Google data, like "sell gold in Springfield VA", "estate jewelry buyer near me"</a:t>
+              <a:t>Local citations + NAP consistency across the directories that matter</a:t>
             </a:r>
           </a:p>
           <a:p>
@@ -4087,7 +4088,7 @@
                 </a:solidFill>
                 <a:latin typeface="Calibri"/>
               </a:rPr>
-              <a:t>Expand &amp; refresh landing pages as we find new demand</a:t>
+              <a:t>Local press, community sponsorships &amp; events for authoritative mentions</a:t>
             </a:r>
           </a:p>
           <a:p>
@@ -4114,7 +4115,7 @@
                 </a:solidFill>
                 <a:latin typeface="Calibri"/>
               </a:rPr>
-              <a:t>2–4 new posts per month on high-intent topics, refreshed to keep ranking</a:t>
+              <a:t>Partner, supplier &amp; association links relevant to your business</a:t>
             </a:r>
           </a:p>
           <a:p>
@@ -4141,14 +4142,41 @@
                 </a:solidFill>
                 <a:latin typeface="Calibri"/>
               </a:rPr>
-              <a:t>FAQ content structured for Google snippets and AI answers</a:t>
+              <a:t>“Best in {city}” roundups and local guides that AI assistants cite</a:t>
+            </a:r>
+          </a:p>
+          <a:p>
+            <a:pPr>
+              <a:lnSpc>
+                <a:spcPct val="110000"/>
+              </a:lnSpc>
+              <a:spcAft>
+                <a:spcPts val="1000"/>
+              </a:spcAft>
+            </a:pPr>
+            <a:r>
+              <a:rPr b="1" sz="1500">
+                <a:solidFill>
+                  <a:srgbClr val="4ADE80"/>
+                </a:solidFill>
+              </a:rPr>
+              <a:t>—  </a:t>
+            </a:r>
+            <a:r>
+              <a:rPr sz="1500">
+                <a:solidFill>
+                  <a:srgbClr val="FFFFFF"/>
+                </a:solidFill>
+                <a:latin typeface="Calibri"/>
+              </a:rPr>
+              <a:t>Steady cadence of high-authority links each month — no spam</a:t>
             </a:r>
           </a:p>
         </p:txBody>
       </p:sp>
       <p:pic>
         <p:nvPicPr>
-          <p:cNvPr id="14" name="Picture 13" descr="jewelry.jpg"/>
+          <p:cNvPr id="14" name="Picture 13" descr="storefront.jpg"/>
           <p:cNvPicPr>
             <a:picLocks noChangeAspect="1"/>
           </p:cNvPicPr>
@@ -4407,7 +4435,7 @@
                 </a:solidFill>
                 <a:latin typeface="Calibri"/>
               </a:rPr>
-              <a:t>THE PLAN</a:t>
+              <a:t>NEXT STEPS · 2 OF 2</a:t>
             </a:r>
           </a:p>
         </p:txBody>
@@ -4446,7 +4474,7 @@
                 </a:solidFill>
                 <a:latin typeface="Calibri"/>
               </a:rPr>
-              <a:t>Your 90-Day Roadmap</a:t>
+              <a:t>Content &amp; Blog — Capture Ready-to-Buy Searches</a:t>
             </a:r>
           </a:p>
         </p:txBody>
@@ -4599,565 +4627,203 @@
       </p:sp>
       <p:sp>
         <p:nvSpPr>
-          <p:cNvPr id="12" name="Rounded Rectangle 11"/>
-          <p:cNvSpPr/>
-          <p:nvPr/>
-        </p:nvSpPr>
-        <p:spPr>
-          <a:xfrm>
-            <a:off x="640080" y="2194560"/>
-            <a:ext cx="3474720" cy="2468880"/>
-          </a:xfrm>
-          <a:prstGeom prst="roundRect">
-            <a:avLst/>
-          </a:prstGeom>
-          <a:solidFill>
-            <a:srgbClr val="121822"/>
-          </a:solidFill>
-          <a:ln w="9525">
+          <p:cNvPr id="12" name="TextBox 11"/>
+          <p:cNvSpPr txBox="1"/>
+          <p:nvPr/>
+        </p:nvSpPr>
+        <p:spPr>
+          <a:xfrm>
+            <a:off x="658368" y="1828800"/>
+            <a:ext cx="10881360" cy="548640"/>
+          </a:xfrm>
+          <a:prstGeom prst="rect">
+            <a:avLst/>
+          </a:prstGeom>
+          <a:noFill/>
+        </p:spPr>
+        <p:txBody>
+          <a:bodyPr wrap="square" anchor="t">
+            <a:spAutoFit/>
+          </a:bodyPr>
+          <a:lstStyle/>
+          <a:p>
+            <a:pPr algn="l">
+              <a:lnSpc>
+                <a:spcPct val="100000"/>
+              </a:lnSpc>
+            </a:pPr>
+            <a:r>
+              <a:rPr sz="1600" b="0">
+                <a:solidFill>
+                  <a:srgbClr val="9AA6B4"/>
+                </a:solidFill>
+                <a:latin typeface="Calibri"/>
+              </a:rPr>
+              <a:t>Shift from curiosity content to buyer-intent content that brings customers through the door.</a:t>
+            </a:r>
+          </a:p>
+        </p:txBody>
+      </p:sp>
+      <p:sp>
+        <p:nvSpPr>
+          <p:cNvPr id="13" name="TextBox 12"/>
+          <p:cNvSpPr txBox="1"/>
+          <p:nvPr/>
+        </p:nvSpPr>
+        <p:spPr>
+          <a:xfrm>
+            <a:off x="822960" y="2697480"/>
+            <a:ext cx="6583680" cy="4572000"/>
+          </a:xfrm>
+          <a:prstGeom prst="rect">
+            <a:avLst/>
+          </a:prstGeom>
+          <a:noFill/>
+        </p:spPr>
+        <p:txBody>
+          <a:bodyPr wrap="square">
+            <a:spAutoFit/>
+          </a:bodyPr>
+          <a:lstStyle/>
+          <a:p>
+            <a:pPr>
+              <a:lnSpc>
+                <a:spcPct val="110000"/>
+              </a:lnSpc>
+              <a:spcAft>
+                <a:spcPts val="1000"/>
+              </a:spcAft>
+            </a:pPr>
+            <a:r>
+              <a:rPr b="1" sz="1500">
+                <a:solidFill>
+                  <a:srgbClr val="4ADE80"/>
+                </a:solidFill>
+              </a:rPr>
+              <a:t>—  </a:t>
+            </a:r>
+            <a:r>
+              <a:rPr sz="1500">
+                <a:solidFill>
+                  <a:srgbClr val="FFFFFF"/>
+                </a:solidFill>
+                <a:latin typeface="Calibri"/>
+              </a:rPr>
+              <a:t>Target real transactional searches from your Google data, like "sell gold in Springfield VA", "estate jewelry buyer near me"</a:t>
+            </a:r>
+          </a:p>
+          <a:p>
+            <a:pPr>
+              <a:lnSpc>
+                <a:spcPct val="110000"/>
+              </a:lnSpc>
+              <a:spcAft>
+                <a:spcPts val="1000"/>
+              </a:spcAft>
+            </a:pPr>
+            <a:r>
+              <a:rPr b="1" sz="1500">
+                <a:solidFill>
+                  <a:srgbClr val="4ADE80"/>
+                </a:solidFill>
+              </a:rPr>
+              <a:t>—  </a:t>
+            </a:r>
+            <a:r>
+              <a:rPr sz="1500">
+                <a:solidFill>
+                  <a:srgbClr val="FFFFFF"/>
+                </a:solidFill>
+                <a:latin typeface="Calibri"/>
+              </a:rPr>
+              <a:t>Expand &amp; refresh landing pages as we find new demand</a:t>
+            </a:r>
+          </a:p>
+          <a:p>
+            <a:pPr>
+              <a:lnSpc>
+                <a:spcPct val="110000"/>
+              </a:lnSpc>
+              <a:spcAft>
+                <a:spcPts val="1000"/>
+              </a:spcAft>
+            </a:pPr>
+            <a:r>
+              <a:rPr b="1" sz="1500">
+                <a:solidFill>
+                  <a:srgbClr val="4ADE80"/>
+                </a:solidFill>
+              </a:rPr>
+              <a:t>—  </a:t>
+            </a:r>
+            <a:r>
+              <a:rPr sz="1500">
+                <a:solidFill>
+                  <a:srgbClr val="FFFFFF"/>
+                </a:solidFill>
+                <a:latin typeface="Calibri"/>
+              </a:rPr>
+              <a:t>2–4 new posts per month on high-intent topics, refreshed to keep ranking</a:t>
+            </a:r>
+          </a:p>
+          <a:p>
+            <a:pPr>
+              <a:lnSpc>
+                <a:spcPct val="110000"/>
+              </a:lnSpc>
+              <a:spcAft>
+                <a:spcPts val="1000"/>
+              </a:spcAft>
+            </a:pPr>
+            <a:r>
+              <a:rPr b="1" sz="1500">
+                <a:solidFill>
+                  <a:srgbClr val="4ADE80"/>
+                </a:solidFill>
+              </a:rPr>
+              <a:t>—  </a:t>
+            </a:r>
+            <a:r>
+              <a:rPr sz="1500">
+                <a:solidFill>
+                  <a:srgbClr val="FFFFFF"/>
+                </a:solidFill>
+                <a:latin typeface="Calibri"/>
+              </a:rPr>
+              <a:t>FAQ content structured for Google snippets and AI answers</a:t>
+            </a:r>
+          </a:p>
+        </p:txBody>
+      </p:sp>
+      <p:pic>
+        <p:nvPicPr>
+          <p:cNvPr id="14" name="Picture 13" descr="jewelry.jpg"/>
+          <p:cNvPicPr>
+            <a:picLocks noChangeAspect="1"/>
+          </p:cNvPicPr>
+          <p:nvPr/>
+        </p:nvPicPr>
+        <p:blipFill>
+          <a:blip r:embed="rId3"/>
+          <a:stretch>
+            <a:fillRect/>
+          </a:stretch>
+        </p:blipFill>
+        <p:spPr>
+          <a:xfrm>
+            <a:off x="7589520" y="2697480"/>
+            <a:ext cx="3931920" cy="2624328"/>
+          </a:xfrm>
+          <a:prstGeom prst="rect">
+            <a:avLst/>
+          </a:prstGeom>
+          <a:ln w="12700">
             <a:solidFill>
               <a:srgbClr val="232C39"/>
             </a:solidFill>
           </a:ln>
-          <a:effectLst/>
-        </p:spPr>
-        <p:style>
-          <a:lnRef idx="1">
-            <a:schemeClr val="accent1"/>
-          </a:lnRef>
-          <a:fillRef idx="3">
-            <a:schemeClr val="accent1"/>
-          </a:fillRef>
-          <a:effectRef idx="2">
-            <a:schemeClr val="accent1"/>
-          </a:effectRef>
-          <a:fontRef idx="minor">
-            <a:schemeClr val="lt1"/>
-          </a:fontRef>
-        </p:style>
-        <p:txBody>
-          <a:bodyPr rtlCol="0" anchor="ctr"/>
-          <a:lstStyle/>
-          <a:p>
-            <a:pPr algn="ctr"/>
-          </a:p>
-        </p:txBody>
-      </p:sp>
-      <p:sp>
-        <p:nvSpPr>
-          <p:cNvPr id="13" name="Rounded Rectangle 12"/>
-          <p:cNvSpPr/>
-          <p:nvPr/>
-        </p:nvSpPr>
-        <p:spPr>
-          <a:xfrm>
-            <a:off x="640080" y="2194560"/>
-            <a:ext cx="3474720" cy="640080"/>
-          </a:xfrm>
-          <a:prstGeom prst="roundRect">
-            <a:avLst/>
-          </a:prstGeom>
-          <a:solidFill>
-            <a:srgbClr val="4ADE80"/>
-          </a:solidFill>
-          <a:ln>
-            <a:noFill/>
-          </a:ln>
-          <a:effectLst/>
-        </p:spPr>
-        <p:style>
-          <a:lnRef idx="1">
-            <a:schemeClr val="accent1"/>
-          </a:lnRef>
-          <a:fillRef idx="3">
-            <a:schemeClr val="accent1"/>
-          </a:fillRef>
-          <a:effectRef idx="2">
-            <a:schemeClr val="accent1"/>
-          </a:effectRef>
-          <a:fontRef idx="minor">
-            <a:schemeClr val="lt1"/>
-          </a:fontRef>
-        </p:style>
-        <p:txBody>
-          <a:bodyPr rtlCol="0" anchor="ctr"/>
-          <a:lstStyle/>
-          <a:p>
-            <a:pPr algn="ctr"/>
-          </a:p>
-        </p:txBody>
-      </p:sp>
-      <p:sp>
-        <p:nvSpPr>
-          <p:cNvPr id="14" name="TextBox 13"/>
-          <p:cNvSpPr txBox="1"/>
-          <p:nvPr/>
-        </p:nvSpPr>
-        <p:spPr>
-          <a:xfrm>
-            <a:off x="640080" y="2240280"/>
-            <a:ext cx="3474720" cy="548640"/>
-          </a:xfrm>
-          <a:prstGeom prst="rect">
-            <a:avLst/>
-          </a:prstGeom>
-          <a:noFill/>
-        </p:spPr>
-        <p:txBody>
-          <a:bodyPr wrap="square" anchor="ctr">
-            <a:spAutoFit/>
-          </a:bodyPr>
-          <a:lstStyle/>
-          <a:p>
-            <a:pPr algn="ctr">
-              <a:lnSpc>
-                <a:spcPct val="100000"/>
-              </a:lnSpc>
-            </a:pPr>
-            <a:r>
-              <a:rPr sz="1800" b="1">
-                <a:solidFill>
-                  <a:srgbClr val="04210F"/>
-                </a:solidFill>
-                <a:latin typeface="Calibri"/>
-              </a:rPr>
-              <a:t>Month 1  ✓</a:t>
-            </a:r>
-          </a:p>
-        </p:txBody>
-      </p:sp>
-      <p:sp>
-        <p:nvSpPr>
-          <p:cNvPr id="15" name="TextBox 14"/>
-          <p:cNvSpPr txBox="1"/>
-          <p:nvPr/>
-        </p:nvSpPr>
-        <p:spPr>
-          <a:xfrm>
-            <a:off x="914400" y="3108960"/>
-            <a:ext cx="2926080" cy="1371600"/>
-          </a:xfrm>
-          <a:prstGeom prst="rect">
-            <a:avLst/>
-          </a:prstGeom>
-          <a:noFill/>
-        </p:spPr>
-        <p:txBody>
-          <a:bodyPr wrap="square" anchor="t">
-            <a:spAutoFit/>
-          </a:bodyPr>
-          <a:lstStyle/>
-          <a:p>
-            <a:pPr algn="l">
-              <a:lnSpc>
-                <a:spcPct val="120000"/>
-              </a:lnSpc>
-            </a:pPr>
-            <a:r>
-              <a:rPr sz="1500" b="0">
-                <a:solidFill>
-                  <a:srgbClr val="9AA6B4"/>
-                </a:solidFill>
-                <a:latin typeface="Calibri"/>
-              </a:rPr>
-              <a:t>Technical foundation, Google Business Profile, homepage rebuild, service &amp; location landing pages</a:t>
-            </a:r>
-          </a:p>
-        </p:txBody>
-      </p:sp>
-      <p:sp>
-        <p:nvSpPr>
-          <p:cNvPr id="16" name="Rounded Rectangle 15"/>
-          <p:cNvSpPr/>
-          <p:nvPr/>
-        </p:nvSpPr>
-        <p:spPr>
-          <a:xfrm>
-            <a:off x="4389120" y="2194560"/>
-            <a:ext cx="3474720" cy="2468880"/>
-          </a:xfrm>
-          <a:prstGeom prst="roundRect">
-            <a:avLst/>
-          </a:prstGeom>
-          <a:solidFill>
-            <a:srgbClr val="121822"/>
-          </a:solidFill>
-          <a:ln w="9525">
-            <a:solidFill>
-              <a:srgbClr val="232C39"/>
-            </a:solidFill>
-          </a:ln>
-          <a:effectLst/>
-        </p:spPr>
-        <p:style>
-          <a:lnRef idx="1">
-            <a:schemeClr val="accent1"/>
-          </a:lnRef>
-          <a:fillRef idx="3">
-            <a:schemeClr val="accent1"/>
-          </a:fillRef>
-          <a:effectRef idx="2">
-            <a:schemeClr val="accent1"/>
-          </a:effectRef>
-          <a:fontRef idx="minor">
-            <a:schemeClr val="lt1"/>
-          </a:fontRef>
-        </p:style>
-        <p:txBody>
-          <a:bodyPr rtlCol="0" anchor="ctr"/>
-          <a:lstStyle/>
-          <a:p>
-            <a:pPr algn="ctr"/>
-          </a:p>
-        </p:txBody>
-      </p:sp>
-      <p:sp>
-        <p:nvSpPr>
-          <p:cNvPr id="17" name="Rounded Rectangle 16"/>
-          <p:cNvSpPr/>
-          <p:nvPr/>
-        </p:nvSpPr>
-        <p:spPr>
-          <a:xfrm>
-            <a:off x="4389120" y="2194560"/>
-            <a:ext cx="3474720" cy="640080"/>
-          </a:xfrm>
-          <a:prstGeom prst="roundRect">
-            <a:avLst/>
-          </a:prstGeom>
-          <a:solidFill>
-            <a:srgbClr val="4ADE80"/>
-          </a:solidFill>
-          <a:ln>
-            <a:noFill/>
-          </a:ln>
-          <a:effectLst/>
-        </p:spPr>
-        <p:style>
-          <a:lnRef idx="1">
-            <a:schemeClr val="accent1"/>
-          </a:lnRef>
-          <a:fillRef idx="3">
-            <a:schemeClr val="accent1"/>
-          </a:fillRef>
-          <a:effectRef idx="2">
-            <a:schemeClr val="accent1"/>
-          </a:effectRef>
-          <a:fontRef idx="minor">
-            <a:schemeClr val="lt1"/>
-          </a:fontRef>
-        </p:style>
-        <p:txBody>
-          <a:bodyPr rtlCol="0" anchor="ctr"/>
-          <a:lstStyle/>
-          <a:p>
-            <a:pPr algn="ctr"/>
-          </a:p>
-        </p:txBody>
-      </p:sp>
-      <p:sp>
-        <p:nvSpPr>
-          <p:cNvPr id="18" name="TextBox 17"/>
-          <p:cNvSpPr txBox="1"/>
-          <p:nvPr/>
-        </p:nvSpPr>
-        <p:spPr>
-          <a:xfrm>
-            <a:off x="4389120" y="2240280"/>
-            <a:ext cx="3474720" cy="548640"/>
-          </a:xfrm>
-          <a:prstGeom prst="rect">
-            <a:avLst/>
-          </a:prstGeom>
-          <a:noFill/>
-        </p:spPr>
-        <p:txBody>
-          <a:bodyPr wrap="square" anchor="ctr">
-            <a:spAutoFit/>
-          </a:bodyPr>
-          <a:lstStyle/>
-          <a:p>
-            <a:pPr algn="ctr">
-              <a:lnSpc>
-                <a:spcPct val="100000"/>
-              </a:lnSpc>
-            </a:pPr>
-            <a:r>
-              <a:rPr sz="1800" b="1">
-                <a:solidFill>
-                  <a:srgbClr val="04210F"/>
-                </a:solidFill>
-                <a:latin typeface="Calibri"/>
-              </a:rPr>
-              <a:t>Month 2</a:t>
-            </a:r>
-          </a:p>
-        </p:txBody>
-      </p:sp>
-      <p:sp>
-        <p:nvSpPr>
-          <p:cNvPr id="19" name="TextBox 18"/>
-          <p:cNvSpPr txBox="1"/>
-          <p:nvPr/>
-        </p:nvSpPr>
-        <p:spPr>
-          <a:xfrm>
-            <a:off x="4663440" y="3108960"/>
-            <a:ext cx="2926080" cy="1371600"/>
-          </a:xfrm>
-          <a:prstGeom prst="rect">
-            <a:avLst/>
-          </a:prstGeom>
-          <a:noFill/>
-        </p:spPr>
-        <p:txBody>
-          <a:bodyPr wrap="square" anchor="t">
-            <a:spAutoFit/>
-          </a:bodyPr>
-          <a:lstStyle/>
-          <a:p>
-            <a:pPr algn="l">
-              <a:lnSpc>
-                <a:spcPct val="120000"/>
-              </a:lnSpc>
-            </a:pPr>
-            <a:r>
-              <a:rPr sz="1500" b="0">
-                <a:solidFill>
-                  <a:srgbClr val="9AA6B4"/>
-                </a:solidFill>
-                <a:latin typeface="Calibri"/>
-              </a:rPr>
-              <a:t>Authority backlinks (raise Domain Authority), on-page depth, content cadence</a:t>
-            </a:r>
-          </a:p>
-        </p:txBody>
-      </p:sp>
-      <p:sp>
-        <p:nvSpPr>
-          <p:cNvPr id="20" name="Rounded Rectangle 19"/>
-          <p:cNvSpPr/>
-          <p:nvPr/>
-        </p:nvSpPr>
-        <p:spPr>
-          <a:xfrm>
-            <a:off x="8138159" y="2194560"/>
-            <a:ext cx="3474720" cy="2468880"/>
-          </a:xfrm>
-          <a:prstGeom prst="roundRect">
-            <a:avLst/>
-          </a:prstGeom>
-          <a:solidFill>
-            <a:srgbClr val="121822"/>
-          </a:solidFill>
-          <a:ln w="9525">
-            <a:solidFill>
-              <a:srgbClr val="232C39"/>
-            </a:solidFill>
-          </a:ln>
-          <a:effectLst/>
-        </p:spPr>
-        <p:style>
-          <a:lnRef idx="1">
-            <a:schemeClr val="accent1"/>
-          </a:lnRef>
-          <a:fillRef idx="3">
-            <a:schemeClr val="accent1"/>
-          </a:fillRef>
-          <a:effectRef idx="2">
-            <a:schemeClr val="accent1"/>
-          </a:effectRef>
-          <a:fontRef idx="minor">
-            <a:schemeClr val="lt1"/>
-          </a:fontRef>
-        </p:style>
-        <p:txBody>
-          <a:bodyPr rtlCol="0" anchor="ctr"/>
-          <a:lstStyle/>
-          <a:p>
-            <a:pPr algn="ctr"/>
-          </a:p>
-        </p:txBody>
-      </p:sp>
-      <p:sp>
-        <p:nvSpPr>
-          <p:cNvPr id="21" name="Rounded Rectangle 20"/>
-          <p:cNvSpPr/>
-          <p:nvPr/>
-        </p:nvSpPr>
-        <p:spPr>
-          <a:xfrm>
-            <a:off x="8138159" y="2194560"/>
-            <a:ext cx="3474720" cy="640080"/>
-          </a:xfrm>
-          <a:prstGeom prst="roundRect">
-            <a:avLst/>
-          </a:prstGeom>
-          <a:solidFill>
-            <a:srgbClr val="4ADE80"/>
-          </a:solidFill>
-          <a:ln>
-            <a:noFill/>
-          </a:ln>
-          <a:effectLst/>
-        </p:spPr>
-        <p:style>
-          <a:lnRef idx="1">
-            <a:schemeClr val="accent1"/>
-          </a:lnRef>
-          <a:fillRef idx="3">
-            <a:schemeClr val="accent1"/>
-          </a:fillRef>
-          <a:effectRef idx="2">
-            <a:schemeClr val="accent1"/>
-          </a:effectRef>
-          <a:fontRef idx="minor">
-            <a:schemeClr val="lt1"/>
-          </a:fontRef>
-        </p:style>
-        <p:txBody>
-          <a:bodyPr rtlCol="0" anchor="ctr"/>
-          <a:lstStyle/>
-          <a:p>
-            <a:pPr algn="ctr"/>
-          </a:p>
-        </p:txBody>
-      </p:sp>
-      <p:sp>
-        <p:nvSpPr>
-          <p:cNvPr id="22" name="TextBox 21"/>
-          <p:cNvSpPr txBox="1"/>
-          <p:nvPr/>
-        </p:nvSpPr>
-        <p:spPr>
-          <a:xfrm>
-            <a:off x="8138159" y="2240280"/>
-            <a:ext cx="3474720" cy="548640"/>
-          </a:xfrm>
-          <a:prstGeom prst="rect">
-            <a:avLst/>
-          </a:prstGeom>
-          <a:noFill/>
-        </p:spPr>
-        <p:txBody>
-          <a:bodyPr wrap="square" anchor="ctr">
-            <a:spAutoFit/>
-          </a:bodyPr>
-          <a:lstStyle/>
-          <a:p>
-            <a:pPr algn="ctr">
-              <a:lnSpc>
-                <a:spcPct val="100000"/>
-              </a:lnSpc>
-            </a:pPr>
-            <a:r>
-              <a:rPr sz="1800" b="1">
-                <a:solidFill>
-                  <a:srgbClr val="04210F"/>
-                </a:solidFill>
-                <a:latin typeface="Calibri"/>
-              </a:rPr>
-              <a:t>Month 3</a:t>
-            </a:r>
-          </a:p>
-        </p:txBody>
-      </p:sp>
-      <p:sp>
-        <p:nvSpPr>
-          <p:cNvPr id="23" name="TextBox 22"/>
-          <p:cNvSpPr txBox="1"/>
-          <p:nvPr/>
-        </p:nvSpPr>
-        <p:spPr>
-          <a:xfrm>
-            <a:off x="8412480" y="3108960"/>
-            <a:ext cx="2926080" cy="1371600"/>
-          </a:xfrm>
-          <a:prstGeom prst="rect">
-            <a:avLst/>
-          </a:prstGeom>
-          <a:noFill/>
-        </p:spPr>
-        <p:txBody>
-          <a:bodyPr wrap="square" anchor="t">
-            <a:spAutoFit/>
-          </a:bodyPr>
-          <a:lstStyle/>
-          <a:p>
-            <a:pPr algn="l">
-              <a:lnSpc>
-                <a:spcPct val="120000"/>
-              </a:lnSpc>
-            </a:pPr>
-            <a:r>
-              <a:rPr sz="1500" b="0">
-                <a:solidFill>
-                  <a:srgbClr val="9AA6B4"/>
-                </a:solidFill>
-                <a:latin typeface="Calibri"/>
-              </a:rPr>
-              <a:t>Authority push, review growth, measure &amp; iterate</a:t>
-            </a:r>
-          </a:p>
-        </p:txBody>
-      </p:sp>
-      <p:sp>
-        <p:nvSpPr>
-          <p:cNvPr id="24" name="TextBox 23"/>
-          <p:cNvSpPr txBox="1"/>
-          <p:nvPr/>
-        </p:nvSpPr>
-        <p:spPr>
-          <a:xfrm>
-            <a:off x="658368" y="5074920"/>
-            <a:ext cx="10881360" cy="548640"/>
-          </a:xfrm>
-          <a:prstGeom prst="rect">
-            <a:avLst/>
-          </a:prstGeom>
-          <a:noFill/>
-        </p:spPr>
-        <p:txBody>
-          <a:bodyPr wrap="square" anchor="t">
-            <a:spAutoFit/>
-          </a:bodyPr>
-          <a:lstStyle/>
-          <a:p>
-            <a:pPr algn="l">
-              <a:lnSpc>
-                <a:spcPct val="100000"/>
-              </a:lnSpc>
-            </a:pPr>
-            <a:r>
-              <a:rPr sz="1700" b="0">
-                <a:solidFill>
-                  <a:srgbClr val="9AA6B4"/>
-                </a:solidFill>
-                <a:latin typeface="Calibri"/>
-              </a:rPr>
-              <a:t>Goal:  </a:t>
-            </a:r>
-            <a:r>
-              <a:rPr sz="1700" b="1">
-                <a:solidFill>
-                  <a:srgbClr val="4ADE80"/>
-                </a:solidFill>
-                <a:latin typeface="Calibri"/>
-              </a:rPr>
-              <a:t>500+ monthly organic visits within 6 months</a:t>
-            </a:r>
-            <a:r>
-              <a:rPr sz="1400" b="0">
-                <a:solidFill>
-                  <a:srgbClr val="9AA6B4"/>
-                </a:solidFill>
-                <a:latin typeface="Calibri"/>
-              </a:rPr>
-              <a:t>   — backed by our 90-day score guarantee.</a:t>
-            </a:r>
-          </a:p>
-        </p:txBody>
-      </p:sp>
+        </p:spPr>
+      </p:pic>
     </p:spTree>
   </p:cSld>
   <p:clrMapOvr>
@@ -5390,7 +5056,7 @@
                 </a:solidFill>
                 <a:latin typeface="Calibri"/>
               </a:rPr>
-              <a:t>THE TRAJECTORY</a:t>
+              <a:t>THE PLAN</a:t>
             </a:r>
           </a:p>
         </p:txBody>
@@ -5429,7 +5095,7 @@
                 </a:solidFill>
                 <a:latin typeface="Calibri"/>
               </a:rPr>
-              <a:t>Projected Organic Growth</a:t>
+              <a:t>Your 90-Day Roadmap</a:t>
             </a:r>
           </a:p>
         </p:txBody>
@@ -5582,23 +5248,25 @@
       </p:sp>
       <p:sp>
         <p:nvSpPr>
-          <p:cNvPr id="12" name="Rectangle 11"/>
+          <p:cNvPr id="12" name="Rounded Rectangle 11"/>
           <p:cNvSpPr/>
           <p:nvPr/>
         </p:nvSpPr>
         <p:spPr>
           <a:xfrm>
-            <a:off x="1143000" y="5303520"/>
-            <a:ext cx="9875519" cy="18288"/>
-          </a:xfrm>
-          <a:prstGeom prst="rect">
+            <a:off x="640080" y="2194560"/>
+            <a:ext cx="3474720" cy="2468880"/>
+          </a:xfrm>
+          <a:prstGeom prst="roundRect">
             <a:avLst/>
           </a:prstGeom>
           <a:solidFill>
-            <a:srgbClr val="232C39"/>
+            <a:srgbClr val="121822"/>
           </a:solidFill>
-          <a:ln>
-            <a:noFill/>
+          <a:ln w="9525">
+            <a:solidFill>
+              <a:srgbClr val="232C39"/>
+            </a:solidFill>
           </a:ln>
           <a:effectLst/>
         </p:spPr>
@@ -5626,16 +5294,16 @@
       </p:sp>
       <p:sp>
         <p:nvSpPr>
-          <p:cNvPr id="13" name="Rectangle 12"/>
+          <p:cNvPr id="13" name="Rounded Rectangle 12"/>
           <p:cNvSpPr/>
           <p:nvPr/>
         </p:nvSpPr>
         <p:spPr>
           <a:xfrm>
-            <a:off x="1188720" y="2895055"/>
-            <a:ext cx="9784080" cy="22860"/>
-          </a:xfrm>
-          <a:prstGeom prst="rect">
+            <a:off x="640080" y="2194560"/>
+            <a:ext cx="3474720" cy="640080"/>
+          </a:xfrm>
+          <a:prstGeom prst="roundRect">
             <a:avLst/>
           </a:prstGeom>
           <a:solidFill>
@@ -5676,8 +5344,47 @@
         </p:nvSpPr>
         <p:spPr>
           <a:xfrm>
-            <a:off x="1188720" y="2492719"/>
-            <a:ext cx="2743200" cy="292608"/>
+            <a:off x="640080" y="2240280"/>
+            <a:ext cx="3474720" cy="548640"/>
+          </a:xfrm>
+          <a:prstGeom prst="rect">
+            <a:avLst/>
+          </a:prstGeom>
+          <a:noFill/>
+        </p:spPr>
+        <p:txBody>
+          <a:bodyPr wrap="square" anchor="ctr">
+            <a:spAutoFit/>
+          </a:bodyPr>
+          <a:lstStyle/>
+          <a:p>
+            <a:pPr algn="ctr">
+              <a:lnSpc>
+                <a:spcPct val="100000"/>
+              </a:lnSpc>
+            </a:pPr>
+            <a:r>
+              <a:rPr sz="1800" b="1">
+                <a:solidFill>
+                  <a:srgbClr val="04210F"/>
+                </a:solidFill>
+                <a:latin typeface="Calibri"/>
+              </a:rPr>
+              <a:t>Month 1  ✓</a:t>
+            </a:r>
+          </a:p>
+        </p:txBody>
+      </p:sp>
+      <p:sp>
+        <p:nvSpPr>
+          <p:cNvPr id="15" name="TextBox 14"/>
+          <p:cNvSpPr txBox="1"/>
+          <p:nvPr/>
+        </p:nvSpPr>
+        <p:spPr>
+          <a:xfrm>
+            <a:off x="914400" y="3108960"/>
+            <a:ext cx="2926080" cy="1371600"/>
           </a:xfrm>
           <a:prstGeom prst="rect">
             <a:avLst/>
@@ -5692,40 +5399,42 @@
           <a:p>
             <a:pPr algn="l">
               <a:lnSpc>
-                <a:spcPct val="100000"/>
-              </a:lnSpc>
-            </a:pPr>
-            <a:r>
-              <a:rPr sz="1100" b="1">
-                <a:solidFill>
-                  <a:srgbClr val="4ADE80"/>
-                </a:solidFill>
-                <a:latin typeface="Calibri"/>
-              </a:rPr>
-              <a:t>Goal: 520+</a:t>
-            </a:r>
-          </a:p>
-        </p:txBody>
-      </p:sp>
-      <p:sp>
-        <p:nvSpPr>
-          <p:cNvPr id="15" name="Rectangle 14"/>
+                <a:spcPct val="120000"/>
+              </a:lnSpc>
+            </a:pPr>
+            <a:r>
+              <a:rPr sz="1500" b="0">
+                <a:solidFill>
+                  <a:srgbClr val="9AA6B4"/>
+                </a:solidFill>
+                <a:latin typeface="Calibri"/>
+              </a:rPr>
+              <a:t>Technical foundation, Google Business Profile, homepage rebuild, service &amp; location landing pages</a:t>
+            </a:r>
+          </a:p>
+        </p:txBody>
+      </p:sp>
+      <p:sp>
+        <p:nvSpPr>
+          <p:cNvPr id="16" name="Rounded Rectangle 15"/>
           <p:cNvSpPr/>
           <p:nvPr/>
         </p:nvSpPr>
         <p:spPr>
           <a:xfrm>
-            <a:off x="1188720" y="4696772"/>
-            <a:ext cx="1225295" cy="606747"/>
-          </a:xfrm>
-          <a:prstGeom prst="rect">
+            <a:off x="4389120" y="2194560"/>
+            <a:ext cx="3474720" cy="2468880"/>
+          </a:xfrm>
+          <a:prstGeom prst="roundRect">
             <a:avLst/>
           </a:prstGeom>
           <a:solidFill>
-            <a:srgbClr val="3A4655"/>
+            <a:srgbClr val="121822"/>
           </a:solidFill>
-          <a:ln>
-            <a:noFill/>
+          <a:ln w="9525">
+            <a:solidFill>
+              <a:srgbClr val="232C39"/>
+            </a:solidFill>
           </a:ln>
           <a:effectLst/>
         </p:spPr>
@@ -5753,704 +5462,16 @@
       </p:sp>
       <p:sp>
         <p:nvSpPr>
-          <p:cNvPr id="16" name="TextBox 15"/>
-          <p:cNvSpPr txBox="1"/>
-          <p:nvPr/>
-        </p:nvSpPr>
-        <p:spPr>
-          <a:xfrm>
-            <a:off x="1005840" y="4312724"/>
-            <a:ext cx="1591055" cy="320040"/>
-          </a:xfrm>
-          <a:prstGeom prst="rect">
-            <a:avLst/>
-          </a:prstGeom>
-          <a:noFill/>
-        </p:spPr>
-        <p:txBody>
-          <a:bodyPr wrap="square" anchor="t">
-            <a:spAutoFit/>
-          </a:bodyPr>
-          <a:lstStyle/>
-          <a:p>
-            <a:pPr algn="ctr">
-              <a:lnSpc>
-                <a:spcPct val="100000"/>
-              </a:lnSpc>
-            </a:pPr>
-            <a:r>
-              <a:rPr sz="1200" b="1">
-                <a:solidFill>
-                  <a:srgbClr val="FFFFFF"/>
-                </a:solidFill>
-                <a:latin typeface="Calibri"/>
-              </a:rPr>
-              <a:t>131</a:t>
-            </a:r>
-          </a:p>
-        </p:txBody>
-      </p:sp>
-      <p:sp>
-        <p:nvSpPr>
-          <p:cNvPr id="17" name="TextBox 16"/>
-          <p:cNvSpPr txBox="1"/>
-          <p:nvPr/>
-        </p:nvSpPr>
-        <p:spPr>
-          <a:xfrm>
-            <a:off x="1005840" y="5376672"/>
-            <a:ext cx="1591055" cy="274320"/>
-          </a:xfrm>
-          <a:prstGeom prst="rect">
-            <a:avLst/>
-          </a:prstGeom>
-          <a:noFill/>
-        </p:spPr>
-        <p:txBody>
-          <a:bodyPr wrap="square" anchor="t">
-            <a:spAutoFit/>
-          </a:bodyPr>
-          <a:lstStyle/>
-          <a:p>
-            <a:pPr algn="ctr">
-              <a:lnSpc>
-                <a:spcPct val="100000"/>
-              </a:lnSpc>
-            </a:pPr>
-            <a:r>
-              <a:rPr sz="1100" b="0">
-                <a:solidFill>
-                  <a:srgbClr val="9AA6B4"/>
-                </a:solidFill>
-                <a:latin typeface="Calibri"/>
-              </a:rPr>
-              <a:t>Now</a:t>
-            </a:r>
-          </a:p>
-        </p:txBody>
-      </p:sp>
-      <p:sp>
-        <p:nvSpPr>
-          <p:cNvPr id="18" name="Rectangle 17"/>
+          <p:cNvPr id="17" name="Rounded Rectangle 16"/>
           <p:cNvSpPr/>
           <p:nvPr/>
         </p:nvSpPr>
         <p:spPr>
           <a:xfrm>
-            <a:off x="2615184" y="4395714"/>
-            <a:ext cx="1225295" cy="907805"/>
-          </a:xfrm>
-          <a:prstGeom prst="rect">
-            <a:avLst/>
-          </a:prstGeom>
-          <a:solidFill>
-            <a:srgbClr val="3A4655"/>
-          </a:solidFill>
-          <a:ln>
-            <a:noFill/>
-          </a:ln>
-          <a:effectLst/>
-        </p:spPr>
-        <p:style>
-          <a:lnRef idx="1">
-            <a:schemeClr val="accent1"/>
-          </a:lnRef>
-          <a:fillRef idx="3">
-            <a:schemeClr val="accent1"/>
-          </a:fillRef>
-          <a:effectRef idx="2">
-            <a:schemeClr val="accent1"/>
-          </a:effectRef>
-          <a:fontRef idx="minor">
-            <a:schemeClr val="lt1"/>
-          </a:fontRef>
-        </p:style>
-        <p:txBody>
-          <a:bodyPr rtlCol="0" anchor="ctr"/>
-          <a:lstStyle/>
-          <a:p>
-            <a:pPr algn="ctr"/>
-          </a:p>
-        </p:txBody>
-      </p:sp>
-      <p:sp>
-        <p:nvSpPr>
-          <p:cNvPr id="19" name="TextBox 18"/>
-          <p:cNvSpPr txBox="1"/>
-          <p:nvPr/>
-        </p:nvSpPr>
-        <p:spPr>
-          <a:xfrm>
-            <a:off x="2432303" y="4011666"/>
-            <a:ext cx="1591055" cy="320040"/>
-          </a:xfrm>
-          <a:prstGeom prst="rect">
-            <a:avLst/>
-          </a:prstGeom>
-          <a:noFill/>
-        </p:spPr>
-        <p:txBody>
-          <a:bodyPr wrap="square" anchor="t">
-            <a:spAutoFit/>
-          </a:bodyPr>
-          <a:lstStyle/>
-          <a:p>
-            <a:pPr algn="ctr">
-              <a:lnSpc>
-                <a:spcPct val="100000"/>
-              </a:lnSpc>
-            </a:pPr>
-            <a:r>
-              <a:rPr sz="1200" b="1">
-                <a:solidFill>
-                  <a:srgbClr val="FFFFFF"/>
-                </a:solidFill>
-                <a:latin typeface="Calibri"/>
-              </a:rPr>
-              <a:t>196</a:t>
-            </a:r>
-          </a:p>
-        </p:txBody>
-      </p:sp>
-      <p:sp>
-        <p:nvSpPr>
-          <p:cNvPr id="20" name="TextBox 19"/>
-          <p:cNvSpPr txBox="1"/>
-          <p:nvPr/>
-        </p:nvSpPr>
-        <p:spPr>
-          <a:xfrm>
-            <a:off x="2432303" y="5376672"/>
-            <a:ext cx="1591055" cy="274320"/>
-          </a:xfrm>
-          <a:prstGeom prst="rect">
-            <a:avLst/>
-          </a:prstGeom>
-          <a:noFill/>
-        </p:spPr>
-        <p:txBody>
-          <a:bodyPr wrap="square" anchor="t">
-            <a:spAutoFit/>
-          </a:bodyPr>
-          <a:lstStyle/>
-          <a:p>
-            <a:pPr algn="ctr">
-              <a:lnSpc>
-                <a:spcPct val="100000"/>
-              </a:lnSpc>
-            </a:pPr>
-            <a:r>
-              <a:rPr sz="1100" b="0">
-                <a:solidFill>
-                  <a:srgbClr val="9AA6B4"/>
-                </a:solidFill>
-                <a:latin typeface="Calibri"/>
-              </a:rPr>
-              <a:t>Mo 1</a:t>
-            </a:r>
-          </a:p>
-        </p:txBody>
-      </p:sp>
-      <p:sp>
-        <p:nvSpPr>
-          <p:cNvPr id="21" name="Rectangle 20"/>
-          <p:cNvSpPr/>
-          <p:nvPr/>
-        </p:nvSpPr>
-        <p:spPr>
-          <a:xfrm>
-            <a:off x="4041648" y="4094656"/>
-            <a:ext cx="1225295" cy="1208863"/>
-          </a:xfrm>
-          <a:prstGeom prst="rect">
-            <a:avLst/>
-          </a:prstGeom>
-          <a:solidFill>
-            <a:srgbClr val="3A4655"/>
-          </a:solidFill>
-          <a:ln>
-            <a:noFill/>
-          </a:ln>
-          <a:effectLst/>
-        </p:spPr>
-        <p:style>
-          <a:lnRef idx="1">
-            <a:schemeClr val="accent1"/>
-          </a:lnRef>
-          <a:fillRef idx="3">
-            <a:schemeClr val="accent1"/>
-          </a:fillRef>
-          <a:effectRef idx="2">
-            <a:schemeClr val="accent1"/>
-          </a:effectRef>
-          <a:fontRef idx="minor">
-            <a:schemeClr val="lt1"/>
-          </a:fontRef>
-        </p:style>
-        <p:txBody>
-          <a:bodyPr rtlCol="0" anchor="ctr"/>
-          <a:lstStyle/>
-          <a:p>
-            <a:pPr algn="ctr"/>
-          </a:p>
-        </p:txBody>
-      </p:sp>
-      <p:sp>
-        <p:nvSpPr>
-          <p:cNvPr id="22" name="TextBox 21"/>
-          <p:cNvSpPr txBox="1"/>
-          <p:nvPr/>
-        </p:nvSpPr>
-        <p:spPr>
-          <a:xfrm>
-            <a:off x="3858768" y="3710608"/>
-            <a:ext cx="1591055" cy="320040"/>
-          </a:xfrm>
-          <a:prstGeom prst="rect">
-            <a:avLst/>
-          </a:prstGeom>
-          <a:noFill/>
-        </p:spPr>
-        <p:txBody>
-          <a:bodyPr wrap="square" anchor="t">
-            <a:spAutoFit/>
-          </a:bodyPr>
-          <a:lstStyle/>
-          <a:p>
-            <a:pPr algn="ctr">
-              <a:lnSpc>
-                <a:spcPct val="100000"/>
-              </a:lnSpc>
-            </a:pPr>
-            <a:r>
-              <a:rPr sz="1200" b="1">
-                <a:solidFill>
-                  <a:srgbClr val="FFFFFF"/>
-                </a:solidFill>
-                <a:latin typeface="Calibri"/>
-              </a:rPr>
-              <a:t>261</a:t>
-            </a:r>
-          </a:p>
-        </p:txBody>
-      </p:sp>
-      <p:sp>
-        <p:nvSpPr>
-          <p:cNvPr id="23" name="TextBox 22"/>
-          <p:cNvSpPr txBox="1"/>
-          <p:nvPr/>
-        </p:nvSpPr>
-        <p:spPr>
-          <a:xfrm>
-            <a:off x="3858768" y="5376672"/>
-            <a:ext cx="1591055" cy="274320"/>
-          </a:xfrm>
-          <a:prstGeom prst="rect">
-            <a:avLst/>
-          </a:prstGeom>
-          <a:noFill/>
-        </p:spPr>
-        <p:txBody>
-          <a:bodyPr wrap="square" anchor="t">
-            <a:spAutoFit/>
-          </a:bodyPr>
-          <a:lstStyle/>
-          <a:p>
-            <a:pPr algn="ctr">
-              <a:lnSpc>
-                <a:spcPct val="100000"/>
-              </a:lnSpc>
-            </a:pPr>
-            <a:r>
-              <a:rPr sz="1100" b="0">
-                <a:solidFill>
-                  <a:srgbClr val="9AA6B4"/>
-                </a:solidFill>
-                <a:latin typeface="Calibri"/>
-              </a:rPr>
-              <a:t>Mo 2</a:t>
-            </a:r>
-          </a:p>
-        </p:txBody>
-      </p:sp>
-      <p:sp>
-        <p:nvSpPr>
-          <p:cNvPr id="24" name="Rectangle 23"/>
-          <p:cNvSpPr/>
-          <p:nvPr/>
-        </p:nvSpPr>
-        <p:spPr>
-          <a:xfrm>
-            <a:off x="5468112" y="3793598"/>
-            <a:ext cx="1225295" cy="1509921"/>
-          </a:xfrm>
-          <a:prstGeom prst="rect">
-            <a:avLst/>
-          </a:prstGeom>
-          <a:solidFill>
-            <a:srgbClr val="3A4655"/>
-          </a:solidFill>
-          <a:ln>
-            <a:noFill/>
-          </a:ln>
-          <a:effectLst/>
-        </p:spPr>
-        <p:style>
-          <a:lnRef idx="1">
-            <a:schemeClr val="accent1"/>
-          </a:lnRef>
-          <a:fillRef idx="3">
-            <a:schemeClr val="accent1"/>
-          </a:fillRef>
-          <a:effectRef idx="2">
-            <a:schemeClr val="accent1"/>
-          </a:effectRef>
-          <a:fontRef idx="minor">
-            <a:schemeClr val="lt1"/>
-          </a:fontRef>
-        </p:style>
-        <p:txBody>
-          <a:bodyPr rtlCol="0" anchor="ctr"/>
-          <a:lstStyle/>
-          <a:p>
-            <a:pPr algn="ctr"/>
-          </a:p>
-        </p:txBody>
-      </p:sp>
-      <p:sp>
-        <p:nvSpPr>
-          <p:cNvPr id="25" name="TextBox 24"/>
-          <p:cNvSpPr txBox="1"/>
-          <p:nvPr/>
-        </p:nvSpPr>
-        <p:spPr>
-          <a:xfrm>
-            <a:off x="5285231" y="3409550"/>
-            <a:ext cx="1591055" cy="320040"/>
-          </a:xfrm>
-          <a:prstGeom prst="rect">
-            <a:avLst/>
-          </a:prstGeom>
-          <a:noFill/>
-        </p:spPr>
-        <p:txBody>
-          <a:bodyPr wrap="square" anchor="t">
-            <a:spAutoFit/>
-          </a:bodyPr>
-          <a:lstStyle/>
-          <a:p>
-            <a:pPr algn="ctr">
-              <a:lnSpc>
-                <a:spcPct val="100000"/>
-              </a:lnSpc>
-            </a:pPr>
-            <a:r>
-              <a:rPr sz="1200" b="1">
-                <a:solidFill>
-                  <a:srgbClr val="FFFFFF"/>
-                </a:solidFill>
-                <a:latin typeface="Calibri"/>
-              </a:rPr>
-              <a:t>326</a:t>
-            </a:r>
-          </a:p>
-        </p:txBody>
-      </p:sp>
-      <p:sp>
-        <p:nvSpPr>
-          <p:cNvPr id="26" name="TextBox 25"/>
-          <p:cNvSpPr txBox="1"/>
-          <p:nvPr/>
-        </p:nvSpPr>
-        <p:spPr>
-          <a:xfrm>
-            <a:off x="5285231" y="5376672"/>
-            <a:ext cx="1591055" cy="274320"/>
-          </a:xfrm>
-          <a:prstGeom prst="rect">
-            <a:avLst/>
-          </a:prstGeom>
-          <a:noFill/>
-        </p:spPr>
-        <p:txBody>
-          <a:bodyPr wrap="square" anchor="t">
-            <a:spAutoFit/>
-          </a:bodyPr>
-          <a:lstStyle/>
-          <a:p>
-            <a:pPr algn="ctr">
-              <a:lnSpc>
-                <a:spcPct val="100000"/>
-              </a:lnSpc>
-            </a:pPr>
-            <a:r>
-              <a:rPr sz="1100" b="0">
-                <a:solidFill>
-                  <a:srgbClr val="9AA6B4"/>
-                </a:solidFill>
-                <a:latin typeface="Calibri"/>
-              </a:rPr>
-              <a:t>Mo 3</a:t>
-            </a:r>
-          </a:p>
-        </p:txBody>
-      </p:sp>
-      <p:sp>
-        <p:nvSpPr>
-          <p:cNvPr id="27" name="Rectangle 26"/>
-          <p:cNvSpPr/>
-          <p:nvPr/>
-        </p:nvSpPr>
-        <p:spPr>
-          <a:xfrm>
-            <a:off x="6894575" y="3497171"/>
-            <a:ext cx="1225295" cy="1806348"/>
-          </a:xfrm>
-          <a:prstGeom prst="rect">
-            <a:avLst/>
-          </a:prstGeom>
-          <a:solidFill>
-            <a:srgbClr val="3A4655"/>
-          </a:solidFill>
-          <a:ln>
-            <a:noFill/>
-          </a:ln>
-          <a:effectLst/>
-        </p:spPr>
-        <p:style>
-          <a:lnRef idx="1">
-            <a:schemeClr val="accent1"/>
-          </a:lnRef>
-          <a:fillRef idx="3">
-            <a:schemeClr val="accent1"/>
-          </a:fillRef>
-          <a:effectRef idx="2">
-            <a:schemeClr val="accent1"/>
-          </a:effectRef>
-          <a:fontRef idx="minor">
-            <a:schemeClr val="lt1"/>
-          </a:fontRef>
-        </p:style>
-        <p:txBody>
-          <a:bodyPr rtlCol="0" anchor="ctr"/>
-          <a:lstStyle/>
-          <a:p>
-            <a:pPr algn="ctr"/>
-          </a:p>
-        </p:txBody>
-      </p:sp>
-      <p:sp>
-        <p:nvSpPr>
-          <p:cNvPr id="28" name="TextBox 27"/>
-          <p:cNvSpPr txBox="1"/>
-          <p:nvPr/>
-        </p:nvSpPr>
-        <p:spPr>
-          <a:xfrm>
-            <a:off x="6711695" y="3113123"/>
-            <a:ext cx="1591055" cy="320040"/>
-          </a:xfrm>
-          <a:prstGeom prst="rect">
-            <a:avLst/>
-          </a:prstGeom>
-          <a:noFill/>
-        </p:spPr>
-        <p:txBody>
-          <a:bodyPr wrap="square" anchor="t">
-            <a:spAutoFit/>
-          </a:bodyPr>
-          <a:lstStyle/>
-          <a:p>
-            <a:pPr algn="ctr">
-              <a:lnSpc>
-                <a:spcPct val="100000"/>
-              </a:lnSpc>
-            </a:pPr>
-            <a:r>
-              <a:rPr sz="1200" b="1">
-                <a:solidFill>
-                  <a:srgbClr val="FFFFFF"/>
-                </a:solidFill>
-                <a:latin typeface="Calibri"/>
-              </a:rPr>
-              <a:t>390</a:t>
-            </a:r>
-          </a:p>
-        </p:txBody>
-      </p:sp>
-      <p:sp>
-        <p:nvSpPr>
-          <p:cNvPr id="29" name="TextBox 28"/>
-          <p:cNvSpPr txBox="1"/>
-          <p:nvPr/>
-        </p:nvSpPr>
-        <p:spPr>
-          <a:xfrm>
-            <a:off x="6711695" y="5376672"/>
-            <a:ext cx="1591055" cy="274320"/>
-          </a:xfrm>
-          <a:prstGeom prst="rect">
-            <a:avLst/>
-          </a:prstGeom>
-          <a:noFill/>
-        </p:spPr>
-        <p:txBody>
-          <a:bodyPr wrap="square" anchor="t">
-            <a:spAutoFit/>
-          </a:bodyPr>
-          <a:lstStyle/>
-          <a:p>
-            <a:pPr algn="ctr">
-              <a:lnSpc>
-                <a:spcPct val="100000"/>
-              </a:lnSpc>
-            </a:pPr>
-            <a:r>
-              <a:rPr sz="1100" b="0">
-                <a:solidFill>
-                  <a:srgbClr val="9AA6B4"/>
-                </a:solidFill>
-                <a:latin typeface="Calibri"/>
-              </a:rPr>
-              <a:t>Mo 4</a:t>
-            </a:r>
-          </a:p>
-        </p:txBody>
-      </p:sp>
-      <p:sp>
-        <p:nvSpPr>
-          <p:cNvPr id="30" name="Rectangle 29"/>
-          <p:cNvSpPr/>
-          <p:nvPr/>
-        </p:nvSpPr>
-        <p:spPr>
-          <a:xfrm>
-            <a:off x="8321040" y="3196113"/>
-            <a:ext cx="1225295" cy="2107406"/>
-          </a:xfrm>
-          <a:prstGeom prst="rect">
-            <a:avLst/>
-          </a:prstGeom>
-          <a:solidFill>
-            <a:srgbClr val="3A4655"/>
-          </a:solidFill>
-          <a:ln>
-            <a:noFill/>
-          </a:ln>
-          <a:effectLst/>
-        </p:spPr>
-        <p:style>
-          <a:lnRef idx="1">
-            <a:schemeClr val="accent1"/>
-          </a:lnRef>
-          <a:fillRef idx="3">
-            <a:schemeClr val="accent1"/>
-          </a:fillRef>
-          <a:effectRef idx="2">
-            <a:schemeClr val="accent1"/>
-          </a:effectRef>
-          <a:fontRef idx="minor">
-            <a:schemeClr val="lt1"/>
-          </a:fontRef>
-        </p:style>
-        <p:txBody>
-          <a:bodyPr rtlCol="0" anchor="ctr"/>
-          <a:lstStyle/>
-          <a:p>
-            <a:pPr algn="ctr"/>
-          </a:p>
-        </p:txBody>
-      </p:sp>
-      <p:sp>
-        <p:nvSpPr>
-          <p:cNvPr id="31" name="TextBox 30"/>
-          <p:cNvSpPr txBox="1"/>
-          <p:nvPr/>
-        </p:nvSpPr>
-        <p:spPr>
-          <a:xfrm>
-            <a:off x="8138160" y="2812065"/>
-            <a:ext cx="1591055" cy="320040"/>
-          </a:xfrm>
-          <a:prstGeom prst="rect">
-            <a:avLst/>
-          </a:prstGeom>
-          <a:noFill/>
-        </p:spPr>
-        <p:txBody>
-          <a:bodyPr wrap="square" anchor="t">
-            <a:spAutoFit/>
-          </a:bodyPr>
-          <a:lstStyle/>
-          <a:p>
-            <a:pPr algn="ctr">
-              <a:lnSpc>
-                <a:spcPct val="100000"/>
-              </a:lnSpc>
-            </a:pPr>
-            <a:r>
-              <a:rPr sz="1200" b="1">
-                <a:solidFill>
-                  <a:srgbClr val="FFFFFF"/>
-                </a:solidFill>
-                <a:latin typeface="Calibri"/>
-              </a:rPr>
-              <a:t>455</a:t>
-            </a:r>
-          </a:p>
-        </p:txBody>
-      </p:sp>
-      <p:sp>
-        <p:nvSpPr>
-          <p:cNvPr id="32" name="TextBox 31"/>
-          <p:cNvSpPr txBox="1"/>
-          <p:nvPr/>
-        </p:nvSpPr>
-        <p:spPr>
-          <a:xfrm>
-            <a:off x="8138160" y="5376672"/>
-            <a:ext cx="1591055" cy="274320"/>
-          </a:xfrm>
-          <a:prstGeom prst="rect">
-            <a:avLst/>
-          </a:prstGeom>
-          <a:noFill/>
-        </p:spPr>
-        <p:txBody>
-          <a:bodyPr wrap="square" anchor="t">
-            <a:spAutoFit/>
-          </a:bodyPr>
-          <a:lstStyle/>
-          <a:p>
-            <a:pPr algn="ctr">
-              <a:lnSpc>
-                <a:spcPct val="100000"/>
-              </a:lnSpc>
-            </a:pPr>
-            <a:r>
-              <a:rPr sz="1100" b="0">
-                <a:solidFill>
-                  <a:srgbClr val="9AA6B4"/>
-                </a:solidFill>
-                <a:latin typeface="Calibri"/>
-              </a:rPr>
-              <a:t>Mo 5</a:t>
-            </a:r>
-          </a:p>
-        </p:txBody>
-      </p:sp>
-      <p:sp>
-        <p:nvSpPr>
-          <p:cNvPr id="33" name="Rectangle 32"/>
-          <p:cNvSpPr/>
-          <p:nvPr/>
-        </p:nvSpPr>
-        <p:spPr>
-          <a:xfrm>
-            <a:off x="9747504" y="2895055"/>
-            <a:ext cx="1225295" cy="2408464"/>
-          </a:xfrm>
-          <a:prstGeom prst="rect">
+            <a:off x="4389120" y="2194560"/>
+            <a:ext cx="3474720" cy="640080"/>
+          </a:xfrm>
+          <a:prstGeom prst="roundRect">
             <a:avLst/>
           </a:prstGeom>
           <a:solidFill>
@@ -6485,14 +5506,53 @@
       </p:sp>
       <p:sp>
         <p:nvSpPr>
-          <p:cNvPr id="34" name="TextBox 33"/>
+          <p:cNvPr id="18" name="TextBox 17"/>
           <p:cNvSpPr txBox="1"/>
           <p:nvPr/>
         </p:nvSpPr>
         <p:spPr>
           <a:xfrm>
-            <a:off x="9564624" y="2511007"/>
-            <a:ext cx="1591055" cy="320040"/>
+            <a:off x="4389120" y="2240280"/>
+            <a:ext cx="3474720" cy="548640"/>
+          </a:xfrm>
+          <a:prstGeom prst="rect">
+            <a:avLst/>
+          </a:prstGeom>
+          <a:noFill/>
+        </p:spPr>
+        <p:txBody>
+          <a:bodyPr wrap="square" anchor="ctr">
+            <a:spAutoFit/>
+          </a:bodyPr>
+          <a:lstStyle/>
+          <a:p>
+            <a:pPr algn="ctr">
+              <a:lnSpc>
+                <a:spcPct val="100000"/>
+              </a:lnSpc>
+            </a:pPr>
+            <a:r>
+              <a:rPr sz="1800" b="1">
+                <a:solidFill>
+                  <a:srgbClr val="04210F"/>
+                </a:solidFill>
+                <a:latin typeface="Calibri"/>
+              </a:rPr>
+              <a:t>Month 2</a:t>
+            </a:r>
+          </a:p>
+        </p:txBody>
+      </p:sp>
+      <p:sp>
+        <p:nvSpPr>
+          <p:cNvPr id="19" name="TextBox 18"/>
+          <p:cNvSpPr txBox="1"/>
+          <p:nvPr/>
+        </p:nvSpPr>
+        <p:spPr>
+          <a:xfrm>
+            <a:off x="4663440" y="3108960"/>
+            <a:ext cx="2926080" cy="1371600"/>
           </a:xfrm>
           <a:prstGeom prst="rect">
             <a:avLst/>
@@ -6505,33 +5565,162 @@
           </a:bodyPr>
           <a:lstStyle/>
           <a:p>
+            <a:pPr algn="l">
+              <a:lnSpc>
+                <a:spcPct val="120000"/>
+              </a:lnSpc>
+            </a:pPr>
+            <a:r>
+              <a:rPr sz="1500" b="0">
+                <a:solidFill>
+                  <a:srgbClr val="9AA6B4"/>
+                </a:solidFill>
+                <a:latin typeface="Calibri"/>
+              </a:rPr>
+              <a:t>Authority backlinks (raise Domain Authority), on-page depth, content cadence</a:t>
+            </a:r>
+          </a:p>
+        </p:txBody>
+      </p:sp>
+      <p:sp>
+        <p:nvSpPr>
+          <p:cNvPr id="20" name="Rounded Rectangle 19"/>
+          <p:cNvSpPr/>
+          <p:nvPr/>
+        </p:nvSpPr>
+        <p:spPr>
+          <a:xfrm>
+            <a:off x="8138159" y="2194560"/>
+            <a:ext cx="3474720" cy="2468880"/>
+          </a:xfrm>
+          <a:prstGeom prst="roundRect">
+            <a:avLst/>
+          </a:prstGeom>
+          <a:solidFill>
+            <a:srgbClr val="121822"/>
+          </a:solidFill>
+          <a:ln w="9525">
+            <a:solidFill>
+              <a:srgbClr val="232C39"/>
+            </a:solidFill>
+          </a:ln>
+          <a:effectLst/>
+        </p:spPr>
+        <p:style>
+          <a:lnRef idx="1">
+            <a:schemeClr val="accent1"/>
+          </a:lnRef>
+          <a:fillRef idx="3">
+            <a:schemeClr val="accent1"/>
+          </a:fillRef>
+          <a:effectRef idx="2">
+            <a:schemeClr val="accent1"/>
+          </a:effectRef>
+          <a:fontRef idx="minor">
+            <a:schemeClr val="lt1"/>
+          </a:fontRef>
+        </p:style>
+        <p:txBody>
+          <a:bodyPr rtlCol="0" anchor="ctr"/>
+          <a:lstStyle/>
+          <a:p>
+            <a:pPr algn="ctr"/>
+          </a:p>
+        </p:txBody>
+      </p:sp>
+      <p:sp>
+        <p:nvSpPr>
+          <p:cNvPr id="21" name="Rounded Rectangle 20"/>
+          <p:cNvSpPr/>
+          <p:nvPr/>
+        </p:nvSpPr>
+        <p:spPr>
+          <a:xfrm>
+            <a:off x="8138159" y="2194560"/>
+            <a:ext cx="3474720" cy="640080"/>
+          </a:xfrm>
+          <a:prstGeom prst="roundRect">
+            <a:avLst/>
+          </a:prstGeom>
+          <a:solidFill>
+            <a:srgbClr val="4ADE80"/>
+          </a:solidFill>
+          <a:ln>
+            <a:noFill/>
+          </a:ln>
+          <a:effectLst/>
+        </p:spPr>
+        <p:style>
+          <a:lnRef idx="1">
+            <a:schemeClr val="accent1"/>
+          </a:lnRef>
+          <a:fillRef idx="3">
+            <a:schemeClr val="accent1"/>
+          </a:fillRef>
+          <a:effectRef idx="2">
+            <a:schemeClr val="accent1"/>
+          </a:effectRef>
+          <a:fontRef idx="minor">
+            <a:schemeClr val="lt1"/>
+          </a:fontRef>
+        </p:style>
+        <p:txBody>
+          <a:bodyPr rtlCol="0" anchor="ctr"/>
+          <a:lstStyle/>
+          <a:p>
+            <a:pPr algn="ctr"/>
+          </a:p>
+        </p:txBody>
+      </p:sp>
+      <p:sp>
+        <p:nvSpPr>
+          <p:cNvPr id="22" name="TextBox 21"/>
+          <p:cNvSpPr txBox="1"/>
+          <p:nvPr/>
+        </p:nvSpPr>
+        <p:spPr>
+          <a:xfrm>
+            <a:off x="8138159" y="2240280"/>
+            <a:ext cx="3474720" cy="548640"/>
+          </a:xfrm>
+          <a:prstGeom prst="rect">
+            <a:avLst/>
+          </a:prstGeom>
+          <a:noFill/>
+        </p:spPr>
+        <p:txBody>
+          <a:bodyPr wrap="square" anchor="ctr">
+            <a:spAutoFit/>
+          </a:bodyPr>
+          <a:lstStyle/>
+          <a:p>
             <a:pPr algn="ctr">
               <a:lnSpc>
                 <a:spcPct val="100000"/>
               </a:lnSpc>
             </a:pPr>
             <a:r>
-              <a:rPr sz="1200" b="1">
-                <a:solidFill>
-                  <a:srgbClr val="4ADE80"/>
-                </a:solidFill>
-                <a:latin typeface="Calibri"/>
-              </a:rPr>
-              <a:t>520</a:t>
-            </a:r>
-          </a:p>
-        </p:txBody>
-      </p:sp>
-      <p:sp>
-        <p:nvSpPr>
-          <p:cNvPr id="35" name="TextBox 34"/>
+              <a:rPr sz="1800" b="1">
+                <a:solidFill>
+                  <a:srgbClr val="04210F"/>
+                </a:solidFill>
+                <a:latin typeface="Calibri"/>
+              </a:rPr>
+              <a:t>Month 3</a:t>
+            </a:r>
+          </a:p>
+        </p:txBody>
+      </p:sp>
+      <p:sp>
+        <p:nvSpPr>
+          <p:cNvPr id="23" name="TextBox 22"/>
           <p:cNvSpPr txBox="1"/>
           <p:nvPr/>
         </p:nvSpPr>
         <p:spPr>
           <a:xfrm>
-            <a:off x="9564624" y="5376672"/>
-            <a:ext cx="1591055" cy="274320"/>
+            <a:off x="8412480" y="3108960"/>
+            <a:ext cx="2926080" cy="1371600"/>
           </a:xfrm>
           <a:prstGeom prst="rect">
             <a:avLst/>
@@ -6544,32 +5733,32 @@
           </a:bodyPr>
           <a:lstStyle/>
           <a:p>
-            <a:pPr algn="ctr">
-              <a:lnSpc>
-                <a:spcPct val="100000"/>
-              </a:lnSpc>
-            </a:pPr>
-            <a:r>
-              <a:rPr sz="1100" b="0">
+            <a:pPr algn="l">
+              <a:lnSpc>
+                <a:spcPct val="120000"/>
+              </a:lnSpc>
+            </a:pPr>
+            <a:r>
+              <a:rPr sz="1500" b="0">
                 <a:solidFill>
                   <a:srgbClr val="9AA6B4"/>
                 </a:solidFill>
                 <a:latin typeface="Calibri"/>
               </a:rPr>
-              <a:t>Mo 6</a:t>
-            </a:r>
-          </a:p>
-        </p:txBody>
-      </p:sp>
-      <p:sp>
-        <p:nvSpPr>
-          <p:cNvPr id="36" name="TextBox 35"/>
+              <a:t>Authority push, review growth, measure &amp; iterate</a:t>
+            </a:r>
+          </a:p>
+        </p:txBody>
+      </p:sp>
+      <p:sp>
+        <p:nvSpPr>
+          <p:cNvPr id="24" name="TextBox 23"/>
           <p:cNvSpPr txBox="1"/>
           <p:nvPr/>
         </p:nvSpPr>
         <p:spPr>
           <a:xfrm>
-            <a:off x="658368" y="5806440"/>
+            <a:off x="658368" y="5074920"/>
             <a:ext cx="10881360" cy="548640"/>
           </a:xfrm>
           <a:prstGeom prst="rect">
@@ -6585,17 +5774,35 @@
           <a:p>
             <a:pPr algn="l">
               <a:lnSpc>
-                <a:spcPct val="115000"/>
-              </a:lnSpc>
-            </a:pPr>
-            <a:r>
-              <a:rPr sz="1250" b="0">
-                <a:solidFill>
-                  <a:srgbClr val="5E6A79"/>
-                </a:solidFill>
-                <a:latin typeface="Calibri"/>
-              </a:rPr>
-              <a:t>Illustrative trajectory toward the 500+ monthly-visit goal as on-page, local, and authority work compound — not a guarantee. Backed by our 90-day score-improvement guarantee.</a:t>
+                <a:spcPct val="100000"/>
+              </a:lnSpc>
+            </a:pPr>
+            <a:r>
+              <a:rPr sz="1700" b="0">
+                <a:solidFill>
+                  <a:srgbClr val="9AA6B4"/>
+                </a:solidFill>
+                <a:latin typeface="Calibri"/>
+              </a:rPr>
+              <a:t>Goal:  </a:t>
+            </a:r>
+            <a:r>
+              <a:rPr sz="1700" b="1">
+                <a:solidFill>
+                  <a:srgbClr val="4ADE80"/>
+                </a:solidFill>
+                <a:latin typeface="Calibri"/>
+              </a:rPr>
+              <a:t>500+ monthly organic visits within 6 months</a:t>
+            </a:r>
+            <a:r>
+              <a:rPr sz="1400" b="0">
+                <a:solidFill>
+                  <a:srgbClr val="9AA6B4"/>
+                </a:solidFill>
+                <a:latin typeface="Calibri"/>
+              </a:rPr>
+              <a:t>   — backed by our 90-day score guarantee.</a:t>
             </a:r>
           </a:p>
         </p:txBody>
@@ -6712,55 +5919,7 @@
       </p:sp>
       <p:sp>
         <p:nvSpPr>
-          <p:cNvPr id="4" name="Oval 3"/>
-          <p:cNvSpPr/>
-          <p:nvPr/>
-        </p:nvSpPr>
-        <p:spPr>
-          <a:xfrm>
-            <a:off x="8503920" y="3749039"/>
-            <a:ext cx="6400800" cy="6400800"/>
-          </a:xfrm>
-          <a:prstGeom prst="ellipse">
-            <a:avLst/>
-          </a:prstGeom>
-          <a:solidFill>
-            <a:srgbClr val="4ADE80">
-              <a:alpha val="12000"/>
-            </a:srgbClr>
-          </a:solidFill>
-          <a:ln>
-            <a:noFill/>
-          </a:ln>
-          <a:effectLst>
-            <a:softEdge rad="1645920"/>
-          </a:effectLst>
-        </p:spPr>
-        <p:style>
-          <a:lnRef idx="1">
-            <a:schemeClr val="accent1"/>
-          </a:lnRef>
-          <a:fillRef idx="3">
-            <a:schemeClr val="accent1"/>
-          </a:fillRef>
-          <a:effectRef idx="2">
-            <a:schemeClr val="accent1"/>
-          </a:effectRef>
-          <a:fontRef idx="minor">
-            <a:schemeClr val="lt1"/>
-          </a:fontRef>
-        </p:style>
-        <p:txBody>
-          <a:bodyPr rtlCol="0" anchor="ctr"/>
-          <a:lstStyle/>
-          <a:p>
-            <a:pPr algn="ctr"/>
-          </a:p>
-        </p:txBody>
-      </p:sp>
-      <p:sp>
-        <p:nvSpPr>
-          <p:cNvPr id="5" name="Rectangle 4"/>
+          <p:cNvPr id="4" name="Rectangle 3"/>
           <p:cNvSpPr/>
           <p:nvPr/>
         </p:nvSpPr>
@@ -6804,14 +5963,58 @@
       </p:sp>
       <p:sp>
         <p:nvSpPr>
+          <p:cNvPr id="5" name="Rectangle 4"/>
+          <p:cNvSpPr/>
+          <p:nvPr/>
+        </p:nvSpPr>
+        <p:spPr>
+          <a:xfrm>
+            <a:off x="658368" y="566928"/>
+            <a:ext cx="201168" cy="201168"/>
+          </a:xfrm>
+          <a:prstGeom prst="rect">
+            <a:avLst/>
+          </a:prstGeom>
+          <a:solidFill>
+            <a:srgbClr val="4ADE80"/>
+          </a:solidFill>
+          <a:ln>
+            <a:noFill/>
+          </a:ln>
+          <a:effectLst/>
+        </p:spPr>
+        <p:style>
+          <a:lnRef idx="1">
+            <a:schemeClr val="accent1"/>
+          </a:lnRef>
+          <a:fillRef idx="3">
+            <a:schemeClr val="accent1"/>
+          </a:fillRef>
+          <a:effectRef idx="2">
+            <a:schemeClr val="accent1"/>
+          </a:effectRef>
+          <a:fontRef idx="minor">
+            <a:schemeClr val="lt1"/>
+          </a:fontRef>
+        </p:style>
+        <p:txBody>
+          <a:bodyPr rtlCol="0" anchor="ctr"/>
+          <a:lstStyle/>
+          <a:p>
+            <a:pPr algn="ctr"/>
+          </a:p>
+        </p:txBody>
+      </p:sp>
+      <p:sp>
+        <p:nvSpPr>
           <p:cNvPr id="6" name="TextBox 5"/>
           <p:cNvSpPr txBox="1"/>
           <p:nvPr/>
         </p:nvSpPr>
         <p:spPr>
           <a:xfrm>
-            <a:off x="640080" y="1920240"/>
-            <a:ext cx="10972800" cy="457200"/>
+            <a:off x="960120" y="502920"/>
+            <a:ext cx="10058400" cy="365760"/>
           </a:xfrm>
           <a:prstGeom prst="rect">
             <a:avLst/>
@@ -6824,19 +6027,19 @@
           </a:bodyPr>
           <a:lstStyle/>
           <a:p>
-            <a:pPr algn="ctr">
+            <a:pPr algn="l">
               <a:lnSpc>
                 <a:spcPct val="100000"/>
               </a:lnSpc>
             </a:pPr>
             <a:r>
-              <a:rPr sz="1500" b="1">
+              <a:rPr sz="1300" b="1">
                 <a:solidFill>
                   <a:srgbClr val="4ADE80"/>
                 </a:solidFill>
                 <a:latin typeface="Calibri"/>
               </a:rPr>
-              <a:t>OUR PROMISE</a:t>
+              <a:t>THE TRAJECTORY</a:t>
             </a:r>
           </a:p>
         </p:txBody>
@@ -6849,8 +6052,8 @@
         </p:nvSpPr>
         <p:spPr>
           <a:xfrm>
-            <a:off x="914400" y="2468880"/>
-            <a:ext cx="10332720" cy="1097280"/>
+            <a:off x="621792" y="896112"/>
+            <a:ext cx="10972800" cy="914400"/>
           </a:xfrm>
           <a:prstGeom prst="rect">
             <a:avLst/>
@@ -6863,33 +6066,267 @@
           </a:bodyPr>
           <a:lstStyle/>
           <a:p>
-            <a:pPr algn="ctr">
+            <a:pPr algn="l">
               <a:lnSpc>
                 <a:spcPct val="100000"/>
               </a:lnSpc>
             </a:pPr>
             <a:r>
-              <a:rPr sz="3400" b="1">
+              <a:rPr sz="3200" b="1">
                 <a:solidFill>
                   <a:srgbClr val="FFFFFF"/>
                 </a:solidFill>
                 <a:latin typeface="Calibri"/>
               </a:rPr>
-              <a:t>The 90-Day Results-or-Refund Guarantee</a:t>
-            </a:r>
-          </a:p>
-        </p:txBody>
-      </p:sp>
-      <p:sp>
-        <p:nvSpPr>
-          <p:cNvPr id="8" name="TextBox 7"/>
+              <a:t>Projected Organic Growth</a:t>
+            </a:r>
+          </a:p>
+        </p:txBody>
+      </p:sp>
+      <p:sp>
+        <p:nvSpPr>
+          <p:cNvPr id="8" name="Rectangle 7"/>
+          <p:cNvSpPr/>
+          <p:nvPr/>
+        </p:nvSpPr>
+        <p:spPr>
+          <a:xfrm>
+            <a:off x="676656" y="1627632"/>
+            <a:ext cx="731520" cy="50292"/>
+          </a:xfrm>
+          <a:prstGeom prst="rect">
+            <a:avLst/>
+          </a:prstGeom>
+          <a:solidFill>
+            <a:srgbClr val="4ADE80"/>
+          </a:solidFill>
+          <a:ln>
+            <a:noFill/>
+          </a:ln>
+          <a:effectLst/>
+        </p:spPr>
+        <p:style>
+          <a:lnRef idx="1">
+            <a:schemeClr val="accent1"/>
+          </a:lnRef>
+          <a:fillRef idx="3">
+            <a:schemeClr val="accent1"/>
+          </a:fillRef>
+          <a:effectRef idx="2">
+            <a:schemeClr val="accent1"/>
+          </a:effectRef>
+          <a:fontRef idx="minor">
+            <a:schemeClr val="lt1"/>
+          </a:fontRef>
+        </p:style>
+        <p:txBody>
+          <a:bodyPr rtlCol="0" anchor="ctr"/>
+          <a:lstStyle/>
+          <a:p>
+            <a:pPr algn="ctr"/>
+          </a:p>
+        </p:txBody>
+      </p:sp>
+      <p:pic>
+        <p:nvPicPr>
+          <p:cNvPr id="9" name="Picture 8" descr="practicerank-logo-360.png"/>
+          <p:cNvPicPr>
+            <a:picLocks noChangeAspect="1"/>
+          </p:cNvPicPr>
+          <p:nvPr/>
+        </p:nvPicPr>
+        <p:blipFill>
+          <a:blip r:embed="rId2"/>
+          <a:stretch>
+            <a:fillRect/>
+          </a:stretch>
+        </p:blipFill>
+        <p:spPr>
+          <a:xfrm>
+            <a:off x="640080" y="6419088"/>
+            <a:ext cx="237744" cy="237744"/>
+          </a:xfrm>
+          <a:prstGeom prst="rect">
+            <a:avLst/>
+          </a:prstGeom>
+        </p:spPr>
+      </p:pic>
+      <p:sp>
+        <p:nvSpPr>
+          <p:cNvPr id="10" name="TextBox 9"/>
           <p:cNvSpPr txBox="1"/>
           <p:nvPr/>
         </p:nvSpPr>
         <p:spPr>
           <a:xfrm>
-            <a:off x="1371600" y="3749039"/>
-            <a:ext cx="9418320" cy="1280160"/>
+            <a:off x="960120" y="6400800"/>
+            <a:ext cx="3657600" cy="274320"/>
+          </a:xfrm>
+          <a:prstGeom prst="rect">
+            <a:avLst/>
+          </a:prstGeom>
+          <a:noFill/>
+        </p:spPr>
+        <p:txBody>
+          <a:bodyPr wrap="square" anchor="ctr">
+            <a:spAutoFit/>
+          </a:bodyPr>
+          <a:lstStyle/>
+          <a:p>
+            <a:pPr algn="l">
+              <a:lnSpc>
+                <a:spcPct val="100000"/>
+              </a:lnSpc>
+            </a:pPr>
+            <a:r>
+              <a:rPr sz="900" b="0">
+                <a:solidFill>
+                  <a:srgbClr val="5E6A79"/>
+                </a:solidFill>
+                <a:latin typeface="Calibri"/>
+              </a:rPr>
+              <a:t>practicerank.ai</a:t>
+            </a:r>
+          </a:p>
+        </p:txBody>
+      </p:sp>
+      <p:sp>
+        <p:nvSpPr>
+          <p:cNvPr id="11" name="TextBox 10"/>
+          <p:cNvSpPr txBox="1"/>
+          <p:nvPr/>
+        </p:nvSpPr>
+        <p:spPr>
+          <a:xfrm>
+            <a:off x="10561320" y="6400800"/>
+            <a:ext cx="1005840" cy="274320"/>
+          </a:xfrm>
+          <a:prstGeom prst="rect">
+            <a:avLst/>
+          </a:prstGeom>
+          <a:noFill/>
+        </p:spPr>
+        <p:txBody>
+          <a:bodyPr wrap="square" anchor="ctr">
+            <a:spAutoFit/>
+          </a:bodyPr>
+          <a:lstStyle/>
+          <a:p>
+            <a:pPr algn="r">
+              <a:lnSpc>
+                <a:spcPct val="100000"/>
+              </a:lnSpc>
+            </a:pPr>
+            <a:r>
+              <a:rPr sz="900" b="0">
+                <a:solidFill>
+                  <a:srgbClr val="5E6A79"/>
+                </a:solidFill>
+                <a:latin typeface="Calibri"/>
+              </a:rPr>
+              <a:t>13</a:t>
+            </a:r>
+          </a:p>
+        </p:txBody>
+      </p:sp>
+      <p:sp>
+        <p:nvSpPr>
+          <p:cNvPr id="12" name="Rectangle 11"/>
+          <p:cNvSpPr/>
+          <p:nvPr/>
+        </p:nvSpPr>
+        <p:spPr>
+          <a:xfrm>
+            <a:off x="1143000" y="5303520"/>
+            <a:ext cx="9875519" cy="18288"/>
+          </a:xfrm>
+          <a:prstGeom prst="rect">
+            <a:avLst/>
+          </a:prstGeom>
+          <a:solidFill>
+            <a:srgbClr val="232C39"/>
+          </a:solidFill>
+          <a:ln>
+            <a:noFill/>
+          </a:ln>
+          <a:effectLst/>
+        </p:spPr>
+        <p:style>
+          <a:lnRef idx="1">
+            <a:schemeClr val="accent1"/>
+          </a:lnRef>
+          <a:fillRef idx="3">
+            <a:schemeClr val="accent1"/>
+          </a:fillRef>
+          <a:effectRef idx="2">
+            <a:schemeClr val="accent1"/>
+          </a:effectRef>
+          <a:fontRef idx="minor">
+            <a:schemeClr val="lt1"/>
+          </a:fontRef>
+        </p:style>
+        <p:txBody>
+          <a:bodyPr rtlCol="0" anchor="ctr"/>
+          <a:lstStyle/>
+          <a:p>
+            <a:pPr algn="ctr"/>
+          </a:p>
+        </p:txBody>
+      </p:sp>
+      <p:sp>
+        <p:nvSpPr>
+          <p:cNvPr id="13" name="Rectangle 12"/>
+          <p:cNvSpPr/>
+          <p:nvPr/>
+        </p:nvSpPr>
+        <p:spPr>
+          <a:xfrm>
+            <a:off x="1188720" y="2895055"/>
+            <a:ext cx="9784080" cy="22860"/>
+          </a:xfrm>
+          <a:prstGeom prst="rect">
+            <a:avLst/>
+          </a:prstGeom>
+          <a:solidFill>
+            <a:srgbClr val="4ADE80"/>
+          </a:solidFill>
+          <a:ln>
+            <a:noFill/>
+          </a:ln>
+          <a:effectLst/>
+        </p:spPr>
+        <p:style>
+          <a:lnRef idx="1">
+            <a:schemeClr val="accent1"/>
+          </a:lnRef>
+          <a:fillRef idx="3">
+            <a:schemeClr val="accent1"/>
+          </a:fillRef>
+          <a:effectRef idx="2">
+            <a:schemeClr val="accent1"/>
+          </a:effectRef>
+          <a:fontRef idx="minor">
+            <a:schemeClr val="lt1"/>
+          </a:fontRef>
+        </p:style>
+        <p:txBody>
+          <a:bodyPr rtlCol="0" anchor="ctr"/>
+          <a:lstStyle/>
+          <a:p>
+            <a:pPr algn="ctr"/>
+          </a:p>
+        </p:txBody>
+      </p:sp>
+      <p:sp>
+        <p:nvSpPr>
+          <p:cNvPr id="14" name="TextBox 13"/>
+          <p:cNvSpPr txBox="1"/>
+          <p:nvPr/>
+        </p:nvSpPr>
+        <p:spPr>
+          <a:xfrm>
+            <a:off x="1188720" y="2492719"/>
+            <a:ext cx="2743200" cy="292608"/>
           </a:xfrm>
           <a:prstGeom prst="rect">
             <a:avLst/>
@@ -6902,19 +6339,912 @@
           </a:bodyPr>
           <a:lstStyle/>
           <a:p>
+            <a:pPr algn="l">
+              <a:lnSpc>
+                <a:spcPct val="100000"/>
+              </a:lnSpc>
+            </a:pPr>
+            <a:r>
+              <a:rPr sz="1100" b="1">
+                <a:solidFill>
+                  <a:srgbClr val="4ADE80"/>
+                </a:solidFill>
+                <a:latin typeface="Calibri"/>
+              </a:rPr>
+              <a:t>Goal: 520+</a:t>
+            </a:r>
+          </a:p>
+        </p:txBody>
+      </p:sp>
+      <p:sp>
+        <p:nvSpPr>
+          <p:cNvPr id="15" name="Rectangle 14"/>
+          <p:cNvSpPr/>
+          <p:nvPr/>
+        </p:nvSpPr>
+        <p:spPr>
+          <a:xfrm>
+            <a:off x="1188720" y="4696772"/>
+            <a:ext cx="1225295" cy="606747"/>
+          </a:xfrm>
+          <a:prstGeom prst="rect">
+            <a:avLst/>
+          </a:prstGeom>
+          <a:solidFill>
+            <a:srgbClr val="3A4655"/>
+          </a:solidFill>
+          <a:ln>
+            <a:noFill/>
+          </a:ln>
+          <a:effectLst/>
+        </p:spPr>
+        <p:style>
+          <a:lnRef idx="1">
+            <a:schemeClr val="accent1"/>
+          </a:lnRef>
+          <a:fillRef idx="3">
+            <a:schemeClr val="accent1"/>
+          </a:fillRef>
+          <a:effectRef idx="2">
+            <a:schemeClr val="accent1"/>
+          </a:effectRef>
+          <a:fontRef idx="minor">
+            <a:schemeClr val="lt1"/>
+          </a:fontRef>
+        </p:style>
+        <p:txBody>
+          <a:bodyPr rtlCol="0" anchor="ctr"/>
+          <a:lstStyle/>
+          <a:p>
+            <a:pPr algn="ctr"/>
+          </a:p>
+        </p:txBody>
+      </p:sp>
+      <p:sp>
+        <p:nvSpPr>
+          <p:cNvPr id="16" name="TextBox 15"/>
+          <p:cNvSpPr txBox="1"/>
+          <p:nvPr/>
+        </p:nvSpPr>
+        <p:spPr>
+          <a:xfrm>
+            <a:off x="1005840" y="4312724"/>
+            <a:ext cx="1591055" cy="320040"/>
+          </a:xfrm>
+          <a:prstGeom prst="rect">
+            <a:avLst/>
+          </a:prstGeom>
+          <a:noFill/>
+        </p:spPr>
+        <p:txBody>
+          <a:bodyPr wrap="square" anchor="t">
+            <a:spAutoFit/>
+          </a:bodyPr>
+          <a:lstStyle/>
+          <a:p>
             <a:pPr algn="ctr">
               <a:lnSpc>
-                <a:spcPct val="125000"/>
-              </a:lnSpc>
-            </a:pPr>
-            <a:r>
-              <a:rPr sz="1800" b="0">
+                <a:spcPct val="100000"/>
+              </a:lnSpc>
+            </a:pPr>
+            <a:r>
+              <a:rPr sz="1200" b="1">
+                <a:solidFill>
+                  <a:srgbClr val="FFFFFF"/>
+                </a:solidFill>
+                <a:latin typeface="Calibri"/>
+              </a:rPr>
+              <a:t>131</a:t>
+            </a:r>
+          </a:p>
+        </p:txBody>
+      </p:sp>
+      <p:sp>
+        <p:nvSpPr>
+          <p:cNvPr id="17" name="TextBox 16"/>
+          <p:cNvSpPr txBox="1"/>
+          <p:nvPr/>
+        </p:nvSpPr>
+        <p:spPr>
+          <a:xfrm>
+            <a:off x="1005840" y="5376672"/>
+            <a:ext cx="1591055" cy="274320"/>
+          </a:xfrm>
+          <a:prstGeom prst="rect">
+            <a:avLst/>
+          </a:prstGeom>
+          <a:noFill/>
+        </p:spPr>
+        <p:txBody>
+          <a:bodyPr wrap="square" anchor="t">
+            <a:spAutoFit/>
+          </a:bodyPr>
+          <a:lstStyle/>
+          <a:p>
+            <a:pPr algn="ctr">
+              <a:lnSpc>
+                <a:spcPct val="100000"/>
+              </a:lnSpc>
+            </a:pPr>
+            <a:r>
+              <a:rPr sz="1100" b="0">
                 <a:solidFill>
                   <a:srgbClr val="9AA6B4"/>
                 </a:solidFill>
                 <a:latin typeface="Calibri"/>
               </a:rPr>
-              <a:t>If your PracticeRank Score doesn't improve by 20+ points in 90 days, we refund your monthly fees — and you keep everything we built. Month-to-month. No long-term contracts.</a:t>
+              <a:t>Now</a:t>
+            </a:r>
+          </a:p>
+        </p:txBody>
+      </p:sp>
+      <p:sp>
+        <p:nvSpPr>
+          <p:cNvPr id="18" name="Rectangle 17"/>
+          <p:cNvSpPr/>
+          <p:nvPr/>
+        </p:nvSpPr>
+        <p:spPr>
+          <a:xfrm>
+            <a:off x="2615184" y="4395714"/>
+            <a:ext cx="1225295" cy="907805"/>
+          </a:xfrm>
+          <a:prstGeom prst="rect">
+            <a:avLst/>
+          </a:prstGeom>
+          <a:solidFill>
+            <a:srgbClr val="3A4655"/>
+          </a:solidFill>
+          <a:ln>
+            <a:noFill/>
+          </a:ln>
+          <a:effectLst/>
+        </p:spPr>
+        <p:style>
+          <a:lnRef idx="1">
+            <a:schemeClr val="accent1"/>
+          </a:lnRef>
+          <a:fillRef idx="3">
+            <a:schemeClr val="accent1"/>
+          </a:fillRef>
+          <a:effectRef idx="2">
+            <a:schemeClr val="accent1"/>
+          </a:effectRef>
+          <a:fontRef idx="minor">
+            <a:schemeClr val="lt1"/>
+          </a:fontRef>
+        </p:style>
+        <p:txBody>
+          <a:bodyPr rtlCol="0" anchor="ctr"/>
+          <a:lstStyle/>
+          <a:p>
+            <a:pPr algn="ctr"/>
+          </a:p>
+        </p:txBody>
+      </p:sp>
+      <p:sp>
+        <p:nvSpPr>
+          <p:cNvPr id="19" name="TextBox 18"/>
+          <p:cNvSpPr txBox="1"/>
+          <p:nvPr/>
+        </p:nvSpPr>
+        <p:spPr>
+          <a:xfrm>
+            <a:off x="2432303" y="4011666"/>
+            <a:ext cx="1591055" cy="320040"/>
+          </a:xfrm>
+          <a:prstGeom prst="rect">
+            <a:avLst/>
+          </a:prstGeom>
+          <a:noFill/>
+        </p:spPr>
+        <p:txBody>
+          <a:bodyPr wrap="square" anchor="t">
+            <a:spAutoFit/>
+          </a:bodyPr>
+          <a:lstStyle/>
+          <a:p>
+            <a:pPr algn="ctr">
+              <a:lnSpc>
+                <a:spcPct val="100000"/>
+              </a:lnSpc>
+            </a:pPr>
+            <a:r>
+              <a:rPr sz="1200" b="1">
+                <a:solidFill>
+                  <a:srgbClr val="FFFFFF"/>
+                </a:solidFill>
+                <a:latin typeface="Calibri"/>
+              </a:rPr>
+              <a:t>196</a:t>
+            </a:r>
+          </a:p>
+        </p:txBody>
+      </p:sp>
+      <p:sp>
+        <p:nvSpPr>
+          <p:cNvPr id="20" name="TextBox 19"/>
+          <p:cNvSpPr txBox="1"/>
+          <p:nvPr/>
+        </p:nvSpPr>
+        <p:spPr>
+          <a:xfrm>
+            <a:off x="2432303" y="5376672"/>
+            <a:ext cx="1591055" cy="274320"/>
+          </a:xfrm>
+          <a:prstGeom prst="rect">
+            <a:avLst/>
+          </a:prstGeom>
+          <a:noFill/>
+        </p:spPr>
+        <p:txBody>
+          <a:bodyPr wrap="square" anchor="t">
+            <a:spAutoFit/>
+          </a:bodyPr>
+          <a:lstStyle/>
+          <a:p>
+            <a:pPr algn="ctr">
+              <a:lnSpc>
+                <a:spcPct val="100000"/>
+              </a:lnSpc>
+            </a:pPr>
+            <a:r>
+              <a:rPr sz="1100" b="0">
+                <a:solidFill>
+                  <a:srgbClr val="9AA6B4"/>
+                </a:solidFill>
+                <a:latin typeface="Calibri"/>
+              </a:rPr>
+              <a:t>Mo 1</a:t>
+            </a:r>
+          </a:p>
+        </p:txBody>
+      </p:sp>
+      <p:sp>
+        <p:nvSpPr>
+          <p:cNvPr id="21" name="Rectangle 20"/>
+          <p:cNvSpPr/>
+          <p:nvPr/>
+        </p:nvSpPr>
+        <p:spPr>
+          <a:xfrm>
+            <a:off x="4041648" y="4094656"/>
+            <a:ext cx="1225295" cy="1208863"/>
+          </a:xfrm>
+          <a:prstGeom prst="rect">
+            <a:avLst/>
+          </a:prstGeom>
+          <a:solidFill>
+            <a:srgbClr val="3A4655"/>
+          </a:solidFill>
+          <a:ln>
+            <a:noFill/>
+          </a:ln>
+          <a:effectLst/>
+        </p:spPr>
+        <p:style>
+          <a:lnRef idx="1">
+            <a:schemeClr val="accent1"/>
+          </a:lnRef>
+          <a:fillRef idx="3">
+            <a:schemeClr val="accent1"/>
+          </a:fillRef>
+          <a:effectRef idx="2">
+            <a:schemeClr val="accent1"/>
+          </a:effectRef>
+          <a:fontRef idx="minor">
+            <a:schemeClr val="lt1"/>
+          </a:fontRef>
+        </p:style>
+        <p:txBody>
+          <a:bodyPr rtlCol="0" anchor="ctr"/>
+          <a:lstStyle/>
+          <a:p>
+            <a:pPr algn="ctr"/>
+          </a:p>
+        </p:txBody>
+      </p:sp>
+      <p:sp>
+        <p:nvSpPr>
+          <p:cNvPr id="22" name="TextBox 21"/>
+          <p:cNvSpPr txBox="1"/>
+          <p:nvPr/>
+        </p:nvSpPr>
+        <p:spPr>
+          <a:xfrm>
+            <a:off x="3858768" y="3710608"/>
+            <a:ext cx="1591055" cy="320040"/>
+          </a:xfrm>
+          <a:prstGeom prst="rect">
+            <a:avLst/>
+          </a:prstGeom>
+          <a:noFill/>
+        </p:spPr>
+        <p:txBody>
+          <a:bodyPr wrap="square" anchor="t">
+            <a:spAutoFit/>
+          </a:bodyPr>
+          <a:lstStyle/>
+          <a:p>
+            <a:pPr algn="ctr">
+              <a:lnSpc>
+                <a:spcPct val="100000"/>
+              </a:lnSpc>
+            </a:pPr>
+            <a:r>
+              <a:rPr sz="1200" b="1">
+                <a:solidFill>
+                  <a:srgbClr val="FFFFFF"/>
+                </a:solidFill>
+                <a:latin typeface="Calibri"/>
+              </a:rPr>
+              <a:t>261</a:t>
+            </a:r>
+          </a:p>
+        </p:txBody>
+      </p:sp>
+      <p:sp>
+        <p:nvSpPr>
+          <p:cNvPr id="23" name="TextBox 22"/>
+          <p:cNvSpPr txBox="1"/>
+          <p:nvPr/>
+        </p:nvSpPr>
+        <p:spPr>
+          <a:xfrm>
+            <a:off x="3858768" y="5376672"/>
+            <a:ext cx="1591055" cy="274320"/>
+          </a:xfrm>
+          <a:prstGeom prst="rect">
+            <a:avLst/>
+          </a:prstGeom>
+          <a:noFill/>
+        </p:spPr>
+        <p:txBody>
+          <a:bodyPr wrap="square" anchor="t">
+            <a:spAutoFit/>
+          </a:bodyPr>
+          <a:lstStyle/>
+          <a:p>
+            <a:pPr algn="ctr">
+              <a:lnSpc>
+                <a:spcPct val="100000"/>
+              </a:lnSpc>
+            </a:pPr>
+            <a:r>
+              <a:rPr sz="1100" b="0">
+                <a:solidFill>
+                  <a:srgbClr val="9AA6B4"/>
+                </a:solidFill>
+                <a:latin typeface="Calibri"/>
+              </a:rPr>
+              <a:t>Mo 2</a:t>
+            </a:r>
+          </a:p>
+        </p:txBody>
+      </p:sp>
+      <p:sp>
+        <p:nvSpPr>
+          <p:cNvPr id="24" name="Rectangle 23"/>
+          <p:cNvSpPr/>
+          <p:nvPr/>
+        </p:nvSpPr>
+        <p:spPr>
+          <a:xfrm>
+            <a:off x="5468112" y="3793598"/>
+            <a:ext cx="1225295" cy="1509921"/>
+          </a:xfrm>
+          <a:prstGeom prst="rect">
+            <a:avLst/>
+          </a:prstGeom>
+          <a:solidFill>
+            <a:srgbClr val="3A4655"/>
+          </a:solidFill>
+          <a:ln>
+            <a:noFill/>
+          </a:ln>
+          <a:effectLst/>
+        </p:spPr>
+        <p:style>
+          <a:lnRef idx="1">
+            <a:schemeClr val="accent1"/>
+          </a:lnRef>
+          <a:fillRef idx="3">
+            <a:schemeClr val="accent1"/>
+          </a:fillRef>
+          <a:effectRef idx="2">
+            <a:schemeClr val="accent1"/>
+          </a:effectRef>
+          <a:fontRef idx="minor">
+            <a:schemeClr val="lt1"/>
+          </a:fontRef>
+        </p:style>
+        <p:txBody>
+          <a:bodyPr rtlCol="0" anchor="ctr"/>
+          <a:lstStyle/>
+          <a:p>
+            <a:pPr algn="ctr"/>
+          </a:p>
+        </p:txBody>
+      </p:sp>
+      <p:sp>
+        <p:nvSpPr>
+          <p:cNvPr id="25" name="TextBox 24"/>
+          <p:cNvSpPr txBox="1"/>
+          <p:nvPr/>
+        </p:nvSpPr>
+        <p:spPr>
+          <a:xfrm>
+            <a:off x="5285231" y="3409550"/>
+            <a:ext cx="1591055" cy="320040"/>
+          </a:xfrm>
+          <a:prstGeom prst="rect">
+            <a:avLst/>
+          </a:prstGeom>
+          <a:noFill/>
+        </p:spPr>
+        <p:txBody>
+          <a:bodyPr wrap="square" anchor="t">
+            <a:spAutoFit/>
+          </a:bodyPr>
+          <a:lstStyle/>
+          <a:p>
+            <a:pPr algn="ctr">
+              <a:lnSpc>
+                <a:spcPct val="100000"/>
+              </a:lnSpc>
+            </a:pPr>
+            <a:r>
+              <a:rPr sz="1200" b="1">
+                <a:solidFill>
+                  <a:srgbClr val="FFFFFF"/>
+                </a:solidFill>
+                <a:latin typeface="Calibri"/>
+              </a:rPr>
+              <a:t>326</a:t>
+            </a:r>
+          </a:p>
+        </p:txBody>
+      </p:sp>
+      <p:sp>
+        <p:nvSpPr>
+          <p:cNvPr id="26" name="TextBox 25"/>
+          <p:cNvSpPr txBox="1"/>
+          <p:nvPr/>
+        </p:nvSpPr>
+        <p:spPr>
+          <a:xfrm>
+            <a:off x="5285231" y="5376672"/>
+            <a:ext cx="1591055" cy="274320"/>
+          </a:xfrm>
+          <a:prstGeom prst="rect">
+            <a:avLst/>
+          </a:prstGeom>
+          <a:noFill/>
+        </p:spPr>
+        <p:txBody>
+          <a:bodyPr wrap="square" anchor="t">
+            <a:spAutoFit/>
+          </a:bodyPr>
+          <a:lstStyle/>
+          <a:p>
+            <a:pPr algn="ctr">
+              <a:lnSpc>
+                <a:spcPct val="100000"/>
+              </a:lnSpc>
+            </a:pPr>
+            <a:r>
+              <a:rPr sz="1100" b="0">
+                <a:solidFill>
+                  <a:srgbClr val="9AA6B4"/>
+                </a:solidFill>
+                <a:latin typeface="Calibri"/>
+              </a:rPr>
+              <a:t>Mo 3</a:t>
+            </a:r>
+          </a:p>
+        </p:txBody>
+      </p:sp>
+      <p:sp>
+        <p:nvSpPr>
+          <p:cNvPr id="27" name="Rectangle 26"/>
+          <p:cNvSpPr/>
+          <p:nvPr/>
+        </p:nvSpPr>
+        <p:spPr>
+          <a:xfrm>
+            <a:off x="6894575" y="3497171"/>
+            <a:ext cx="1225295" cy="1806348"/>
+          </a:xfrm>
+          <a:prstGeom prst="rect">
+            <a:avLst/>
+          </a:prstGeom>
+          <a:solidFill>
+            <a:srgbClr val="3A4655"/>
+          </a:solidFill>
+          <a:ln>
+            <a:noFill/>
+          </a:ln>
+          <a:effectLst/>
+        </p:spPr>
+        <p:style>
+          <a:lnRef idx="1">
+            <a:schemeClr val="accent1"/>
+          </a:lnRef>
+          <a:fillRef idx="3">
+            <a:schemeClr val="accent1"/>
+          </a:fillRef>
+          <a:effectRef idx="2">
+            <a:schemeClr val="accent1"/>
+          </a:effectRef>
+          <a:fontRef idx="minor">
+            <a:schemeClr val="lt1"/>
+          </a:fontRef>
+        </p:style>
+        <p:txBody>
+          <a:bodyPr rtlCol="0" anchor="ctr"/>
+          <a:lstStyle/>
+          <a:p>
+            <a:pPr algn="ctr"/>
+          </a:p>
+        </p:txBody>
+      </p:sp>
+      <p:sp>
+        <p:nvSpPr>
+          <p:cNvPr id="28" name="TextBox 27"/>
+          <p:cNvSpPr txBox="1"/>
+          <p:nvPr/>
+        </p:nvSpPr>
+        <p:spPr>
+          <a:xfrm>
+            <a:off x="6711695" y="3113123"/>
+            <a:ext cx="1591055" cy="320040"/>
+          </a:xfrm>
+          <a:prstGeom prst="rect">
+            <a:avLst/>
+          </a:prstGeom>
+          <a:noFill/>
+        </p:spPr>
+        <p:txBody>
+          <a:bodyPr wrap="square" anchor="t">
+            <a:spAutoFit/>
+          </a:bodyPr>
+          <a:lstStyle/>
+          <a:p>
+            <a:pPr algn="ctr">
+              <a:lnSpc>
+                <a:spcPct val="100000"/>
+              </a:lnSpc>
+            </a:pPr>
+            <a:r>
+              <a:rPr sz="1200" b="1">
+                <a:solidFill>
+                  <a:srgbClr val="FFFFFF"/>
+                </a:solidFill>
+                <a:latin typeface="Calibri"/>
+              </a:rPr>
+              <a:t>390</a:t>
+            </a:r>
+          </a:p>
+        </p:txBody>
+      </p:sp>
+      <p:sp>
+        <p:nvSpPr>
+          <p:cNvPr id="29" name="TextBox 28"/>
+          <p:cNvSpPr txBox="1"/>
+          <p:nvPr/>
+        </p:nvSpPr>
+        <p:spPr>
+          <a:xfrm>
+            <a:off x="6711695" y="5376672"/>
+            <a:ext cx="1591055" cy="274320"/>
+          </a:xfrm>
+          <a:prstGeom prst="rect">
+            <a:avLst/>
+          </a:prstGeom>
+          <a:noFill/>
+        </p:spPr>
+        <p:txBody>
+          <a:bodyPr wrap="square" anchor="t">
+            <a:spAutoFit/>
+          </a:bodyPr>
+          <a:lstStyle/>
+          <a:p>
+            <a:pPr algn="ctr">
+              <a:lnSpc>
+                <a:spcPct val="100000"/>
+              </a:lnSpc>
+            </a:pPr>
+            <a:r>
+              <a:rPr sz="1100" b="0">
+                <a:solidFill>
+                  <a:srgbClr val="9AA6B4"/>
+                </a:solidFill>
+                <a:latin typeface="Calibri"/>
+              </a:rPr>
+              <a:t>Mo 4</a:t>
+            </a:r>
+          </a:p>
+        </p:txBody>
+      </p:sp>
+      <p:sp>
+        <p:nvSpPr>
+          <p:cNvPr id="30" name="Rectangle 29"/>
+          <p:cNvSpPr/>
+          <p:nvPr/>
+        </p:nvSpPr>
+        <p:spPr>
+          <a:xfrm>
+            <a:off x="8321040" y="3196113"/>
+            <a:ext cx="1225295" cy="2107406"/>
+          </a:xfrm>
+          <a:prstGeom prst="rect">
+            <a:avLst/>
+          </a:prstGeom>
+          <a:solidFill>
+            <a:srgbClr val="3A4655"/>
+          </a:solidFill>
+          <a:ln>
+            <a:noFill/>
+          </a:ln>
+          <a:effectLst/>
+        </p:spPr>
+        <p:style>
+          <a:lnRef idx="1">
+            <a:schemeClr val="accent1"/>
+          </a:lnRef>
+          <a:fillRef idx="3">
+            <a:schemeClr val="accent1"/>
+          </a:fillRef>
+          <a:effectRef idx="2">
+            <a:schemeClr val="accent1"/>
+          </a:effectRef>
+          <a:fontRef idx="minor">
+            <a:schemeClr val="lt1"/>
+          </a:fontRef>
+        </p:style>
+        <p:txBody>
+          <a:bodyPr rtlCol="0" anchor="ctr"/>
+          <a:lstStyle/>
+          <a:p>
+            <a:pPr algn="ctr"/>
+          </a:p>
+        </p:txBody>
+      </p:sp>
+      <p:sp>
+        <p:nvSpPr>
+          <p:cNvPr id="31" name="TextBox 30"/>
+          <p:cNvSpPr txBox="1"/>
+          <p:nvPr/>
+        </p:nvSpPr>
+        <p:spPr>
+          <a:xfrm>
+            <a:off x="8138160" y="2812065"/>
+            <a:ext cx="1591055" cy="320040"/>
+          </a:xfrm>
+          <a:prstGeom prst="rect">
+            <a:avLst/>
+          </a:prstGeom>
+          <a:noFill/>
+        </p:spPr>
+        <p:txBody>
+          <a:bodyPr wrap="square" anchor="t">
+            <a:spAutoFit/>
+          </a:bodyPr>
+          <a:lstStyle/>
+          <a:p>
+            <a:pPr algn="ctr">
+              <a:lnSpc>
+                <a:spcPct val="100000"/>
+              </a:lnSpc>
+            </a:pPr>
+            <a:r>
+              <a:rPr sz="1200" b="1">
+                <a:solidFill>
+                  <a:srgbClr val="FFFFFF"/>
+                </a:solidFill>
+                <a:latin typeface="Calibri"/>
+              </a:rPr>
+              <a:t>455</a:t>
+            </a:r>
+          </a:p>
+        </p:txBody>
+      </p:sp>
+      <p:sp>
+        <p:nvSpPr>
+          <p:cNvPr id="32" name="TextBox 31"/>
+          <p:cNvSpPr txBox="1"/>
+          <p:nvPr/>
+        </p:nvSpPr>
+        <p:spPr>
+          <a:xfrm>
+            <a:off x="8138160" y="5376672"/>
+            <a:ext cx="1591055" cy="274320"/>
+          </a:xfrm>
+          <a:prstGeom prst="rect">
+            <a:avLst/>
+          </a:prstGeom>
+          <a:noFill/>
+        </p:spPr>
+        <p:txBody>
+          <a:bodyPr wrap="square" anchor="t">
+            <a:spAutoFit/>
+          </a:bodyPr>
+          <a:lstStyle/>
+          <a:p>
+            <a:pPr algn="ctr">
+              <a:lnSpc>
+                <a:spcPct val="100000"/>
+              </a:lnSpc>
+            </a:pPr>
+            <a:r>
+              <a:rPr sz="1100" b="0">
+                <a:solidFill>
+                  <a:srgbClr val="9AA6B4"/>
+                </a:solidFill>
+                <a:latin typeface="Calibri"/>
+              </a:rPr>
+              <a:t>Mo 5</a:t>
+            </a:r>
+          </a:p>
+        </p:txBody>
+      </p:sp>
+      <p:sp>
+        <p:nvSpPr>
+          <p:cNvPr id="33" name="Rectangle 32"/>
+          <p:cNvSpPr/>
+          <p:nvPr/>
+        </p:nvSpPr>
+        <p:spPr>
+          <a:xfrm>
+            <a:off x="9747504" y="2895055"/>
+            <a:ext cx="1225295" cy="2408464"/>
+          </a:xfrm>
+          <a:prstGeom prst="rect">
+            <a:avLst/>
+          </a:prstGeom>
+          <a:solidFill>
+            <a:srgbClr val="4ADE80"/>
+          </a:solidFill>
+          <a:ln>
+            <a:noFill/>
+          </a:ln>
+          <a:effectLst/>
+        </p:spPr>
+        <p:style>
+          <a:lnRef idx="1">
+            <a:schemeClr val="accent1"/>
+          </a:lnRef>
+          <a:fillRef idx="3">
+            <a:schemeClr val="accent1"/>
+          </a:fillRef>
+          <a:effectRef idx="2">
+            <a:schemeClr val="accent1"/>
+          </a:effectRef>
+          <a:fontRef idx="minor">
+            <a:schemeClr val="lt1"/>
+          </a:fontRef>
+        </p:style>
+        <p:txBody>
+          <a:bodyPr rtlCol="0" anchor="ctr"/>
+          <a:lstStyle/>
+          <a:p>
+            <a:pPr algn="ctr"/>
+          </a:p>
+        </p:txBody>
+      </p:sp>
+      <p:sp>
+        <p:nvSpPr>
+          <p:cNvPr id="34" name="TextBox 33"/>
+          <p:cNvSpPr txBox="1"/>
+          <p:nvPr/>
+        </p:nvSpPr>
+        <p:spPr>
+          <a:xfrm>
+            <a:off x="9564624" y="2511007"/>
+            <a:ext cx="1591055" cy="320040"/>
+          </a:xfrm>
+          <a:prstGeom prst="rect">
+            <a:avLst/>
+          </a:prstGeom>
+          <a:noFill/>
+        </p:spPr>
+        <p:txBody>
+          <a:bodyPr wrap="square" anchor="t">
+            <a:spAutoFit/>
+          </a:bodyPr>
+          <a:lstStyle/>
+          <a:p>
+            <a:pPr algn="ctr">
+              <a:lnSpc>
+                <a:spcPct val="100000"/>
+              </a:lnSpc>
+            </a:pPr>
+            <a:r>
+              <a:rPr sz="1200" b="1">
+                <a:solidFill>
+                  <a:srgbClr val="4ADE80"/>
+                </a:solidFill>
+                <a:latin typeface="Calibri"/>
+              </a:rPr>
+              <a:t>520</a:t>
+            </a:r>
+          </a:p>
+        </p:txBody>
+      </p:sp>
+      <p:sp>
+        <p:nvSpPr>
+          <p:cNvPr id="35" name="TextBox 34"/>
+          <p:cNvSpPr txBox="1"/>
+          <p:nvPr/>
+        </p:nvSpPr>
+        <p:spPr>
+          <a:xfrm>
+            <a:off x="9564624" y="5376672"/>
+            <a:ext cx="1591055" cy="274320"/>
+          </a:xfrm>
+          <a:prstGeom prst="rect">
+            <a:avLst/>
+          </a:prstGeom>
+          <a:noFill/>
+        </p:spPr>
+        <p:txBody>
+          <a:bodyPr wrap="square" anchor="t">
+            <a:spAutoFit/>
+          </a:bodyPr>
+          <a:lstStyle/>
+          <a:p>
+            <a:pPr algn="ctr">
+              <a:lnSpc>
+                <a:spcPct val="100000"/>
+              </a:lnSpc>
+            </a:pPr>
+            <a:r>
+              <a:rPr sz="1100" b="0">
+                <a:solidFill>
+                  <a:srgbClr val="9AA6B4"/>
+                </a:solidFill>
+                <a:latin typeface="Calibri"/>
+              </a:rPr>
+              <a:t>Mo 6</a:t>
+            </a:r>
+          </a:p>
+        </p:txBody>
+      </p:sp>
+      <p:sp>
+        <p:nvSpPr>
+          <p:cNvPr id="36" name="TextBox 35"/>
+          <p:cNvSpPr txBox="1"/>
+          <p:nvPr/>
+        </p:nvSpPr>
+        <p:spPr>
+          <a:xfrm>
+            <a:off x="658368" y="5806440"/>
+            <a:ext cx="10881360" cy="548640"/>
+          </a:xfrm>
+          <a:prstGeom prst="rect">
+            <a:avLst/>
+          </a:prstGeom>
+          <a:noFill/>
+        </p:spPr>
+        <p:txBody>
+          <a:bodyPr wrap="square" anchor="t">
+            <a:spAutoFit/>
+          </a:bodyPr>
+          <a:lstStyle/>
+          <a:p>
+            <a:pPr algn="l">
+              <a:lnSpc>
+                <a:spcPct val="115000"/>
+              </a:lnSpc>
+            </a:pPr>
+            <a:r>
+              <a:rPr sz="1250" b="0">
+                <a:solidFill>
+                  <a:srgbClr val="5E6A79"/>
+                </a:solidFill>
+                <a:latin typeface="Calibri"/>
+              </a:rPr>
+              <a:t>Illustrative trajectory toward the 500+ monthly-visit goal as on-page, local, and authority work compound — not a guarantee. Backed by our 90-day score-improvement guarantee.</a:t>
             </a:r>
           </a:p>
         </p:txBody>
@@ -7121,6 +7451,325 @@
           </a:p>
         </p:txBody>
       </p:sp>
+      <p:sp>
+        <p:nvSpPr>
+          <p:cNvPr id="6" name="TextBox 5"/>
+          <p:cNvSpPr txBox="1"/>
+          <p:nvPr/>
+        </p:nvSpPr>
+        <p:spPr>
+          <a:xfrm>
+            <a:off x="640080" y="1920240"/>
+            <a:ext cx="10972800" cy="457200"/>
+          </a:xfrm>
+          <a:prstGeom prst="rect">
+            <a:avLst/>
+          </a:prstGeom>
+          <a:noFill/>
+        </p:spPr>
+        <p:txBody>
+          <a:bodyPr wrap="square" anchor="t">
+            <a:spAutoFit/>
+          </a:bodyPr>
+          <a:lstStyle/>
+          <a:p>
+            <a:pPr algn="ctr">
+              <a:lnSpc>
+                <a:spcPct val="100000"/>
+              </a:lnSpc>
+            </a:pPr>
+            <a:r>
+              <a:rPr sz="1500" b="1">
+                <a:solidFill>
+                  <a:srgbClr val="4ADE80"/>
+                </a:solidFill>
+                <a:latin typeface="Calibri"/>
+              </a:rPr>
+              <a:t>OUR PROMISE</a:t>
+            </a:r>
+          </a:p>
+        </p:txBody>
+      </p:sp>
+      <p:sp>
+        <p:nvSpPr>
+          <p:cNvPr id="7" name="TextBox 6"/>
+          <p:cNvSpPr txBox="1"/>
+          <p:nvPr/>
+        </p:nvSpPr>
+        <p:spPr>
+          <a:xfrm>
+            <a:off x="914400" y="2468880"/>
+            <a:ext cx="10332720" cy="1097280"/>
+          </a:xfrm>
+          <a:prstGeom prst="rect">
+            <a:avLst/>
+          </a:prstGeom>
+          <a:noFill/>
+        </p:spPr>
+        <p:txBody>
+          <a:bodyPr wrap="square" anchor="t">
+            <a:spAutoFit/>
+          </a:bodyPr>
+          <a:lstStyle/>
+          <a:p>
+            <a:pPr algn="ctr">
+              <a:lnSpc>
+                <a:spcPct val="100000"/>
+              </a:lnSpc>
+            </a:pPr>
+            <a:r>
+              <a:rPr sz="3400" b="1">
+                <a:solidFill>
+                  <a:srgbClr val="FFFFFF"/>
+                </a:solidFill>
+                <a:latin typeface="Calibri"/>
+              </a:rPr>
+              <a:t>The 90-Day Results-or-Refund Guarantee</a:t>
+            </a:r>
+          </a:p>
+        </p:txBody>
+      </p:sp>
+      <p:sp>
+        <p:nvSpPr>
+          <p:cNvPr id="8" name="TextBox 7"/>
+          <p:cNvSpPr txBox="1"/>
+          <p:nvPr/>
+        </p:nvSpPr>
+        <p:spPr>
+          <a:xfrm>
+            <a:off x="1371600" y="3749039"/>
+            <a:ext cx="9418320" cy="1280160"/>
+          </a:xfrm>
+          <a:prstGeom prst="rect">
+            <a:avLst/>
+          </a:prstGeom>
+          <a:noFill/>
+        </p:spPr>
+        <p:txBody>
+          <a:bodyPr wrap="square" anchor="t">
+            <a:spAutoFit/>
+          </a:bodyPr>
+          <a:lstStyle/>
+          <a:p>
+            <a:pPr algn="ctr">
+              <a:lnSpc>
+                <a:spcPct val="125000"/>
+              </a:lnSpc>
+            </a:pPr>
+            <a:r>
+              <a:rPr sz="1800" b="0">
+                <a:solidFill>
+                  <a:srgbClr val="9AA6B4"/>
+                </a:solidFill>
+                <a:latin typeface="Calibri"/>
+              </a:rPr>
+              <a:t>If your PracticeRank Score doesn't improve by 20+ points in 90 days, we refund your monthly fees — and you keep everything we built. Month-to-month. No long-term contracts.</a:t>
+            </a:r>
+          </a:p>
+        </p:txBody>
+      </p:sp>
+    </p:spTree>
+  </p:cSld>
+  <p:clrMapOvr>
+    <a:masterClrMapping/>
+  </p:clrMapOvr>
+</p:sld>
+</file>
+
+<file path=ppt/slides/slide15.xml><?xml version="1.0" encoding="utf-8"?>
+<p:sld xmlns:a="http://schemas.openxmlformats.org/drawingml/2006/main" xmlns:p="http://schemas.openxmlformats.org/presentationml/2006/main" xmlns:r="http://schemas.openxmlformats.org/officeDocument/2006/relationships">
+  <p:cSld>
+    <p:spTree>
+      <p:nvGrpSpPr>
+        <p:cNvPr id="1" name=""/>
+        <p:cNvGrpSpPr/>
+        <p:nvPr/>
+      </p:nvGrpSpPr>
+      <p:grpSpPr/>
+      <p:sp>
+        <p:nvSpPr>
+          <p:cNvPr id="2" name="Rectangle 1"/>
+          <p:cNvSpPr/>
+          <p:nvPr/>
+        </p:nvSpPr>
+        <p:spPr>
+          <a:xfrm>
+            <a:off x="0" y="0"/>
+            <a:ext cx="12191695" cy="6858000"/>
+          </a:xfrm>
+          <a:prstGeom prst="rect">
+            <a:avLst/>
+          </a:prstGeom>
+          <a:solidFill>
+            <a:srgbClr val="08080D"/>
+          </a:solidFill>
+          <a:ln>
+            <a:noFill/>
+          </a:ln>
+          <a:effectLst/>
+        </p:spPr>
+        <p:style>
+          <a:lnRef idx="1">
+            <a:schemeClr val="accent1"/>
+          </a:lnRef>
+          <a:fillRef idx="3">
+            <a:schemeClr val="accent1"/>
+          </a:fillRef>
+          <a:effectRef idx="2">
+            <a:schemeClr val="accent1"/>
+          </a:effectRef>
+          <a:fontRef idx="minor">
+            <a:schemeClr val="lt1"/>
+          </a:fontRef>
+        </p:style>
+        <p:txBody>
+          <a:bodyPr rtlCol="0" anchor="ctr"/>
+          <a:lstStyle/>
+          <a:p>
+            <a:pPr algn="ctr"/>
+          </a:p>
+        </p:txBody>
+      </p:sp>
+      <p:sp>
+        <p:nvSpPr>
+          <p:cNvPr id="3" name="Oval 2"/>
+          <p:cNvSpPr/>
+          <p:nvPr/>
+        </p:nvSpPr>
+        <p:spPr>
+          <a:xfrm>
+            <a:off x="-758952" y="-4251960"/>
+            <a:ext cx="13716000" cy="5943600"/>
+          </a:xfrm>
+          <a:prstGeom prst="ellipse">
+            <a:avLst/>
+          </a:prstGeom>
+          <a:solidFill>
+            <a:srgbClr val="16213E">
+              <a:alpha val="46000"/>
+            </a:srgbClr>
+          </a:solidFill>
+          <a:ln>
+            <a:noFill/>
+          </a:ln>
+          <a:effectLst>
+            <a:softEdge rad="1463040"/>
+          </a:effectLst>
+        </p:spPr>
+        <p:style>
+          <a:lnRef idx="1">
+            <a:schemeClr val="accent1"/>
+          </a:lnRef>
+          <a:fillRef idx="3">
+            <a:schemeClr val="accent1"/>
+          </a:fillRef>
+          <a:effectRef idx="2">
+            <a:schemeClr val="accent1"/>
+          </a:effectRef>
+          <a:fontRef idx="minor">
+            <a:schemeClr val="lt1"/>
+          </a:fontRef>
+        </p:style>
+        <p:txBody>
+          <a:bodyPr rtlCol="0" anchor="ctr"/>
+          <a:lstStyle/>
+          <a:p>
+            <a:pPr algn="ctr"/>
+          </a:p>
+        </p:txBody>
+      </p:sp>
+      <p:sp>
+        <p:nvSpPr>
+          <p:cNvPr id="4" name="Oval 3"/>
+          <p:cNvSpPr/>
+          <p:nvPr/>
+        </p:nvSpPr>
+        <p:spPr>
+          <a:xfrm>
+            <a:off x="8503920" y="3749039"/>
+            <a:ext cx="6400800" cy="6400800"/>
+          </a:xfrm>
+          <a:prstGeom prst="ellipse">
+            <a:avLst/>
+          </a:prstGeom>
+          <a:solidFill>
+            <a:srgbClr val="4ADE80">
+              <a:alpha val="12000"/>
+            </a:srgbClr>
+          </a:solidFill>
+          <a:ln>
+            <a:noFill/>
+          </a:ln>
+          <a:effectLst>
+            <a:softEdge rad="1645920"/>
+          </a:effectLst>
+        </p:spPr>
+        <p:style>
+          <a:lnRef idx="1">
+            <a:schemeClr val="accent1"/>
+          </a:lnRef>
+          <a:fillRef idx="3">
+            <a:schemeClr val="accent1"/>
+          </a:fillRef>
+          <a:effectRef idx="2">
+            <a:schemeClr val="accent1"/>
+          </a:effectRef>
+          <a:fontRef idx="minor">
+            <a:schemeClr val="lt1"/>
+          </a:fontRef>
+        </p:style>
+        <p:txBody>
+          <a:bodyPr rtlCol="0" anchor="ctr"/>
+          <a:lstStyle/>
+          <a:p>
+            <a:pPr algn="ctr"/>
+          </a:p>
+        </p:txBody>
+      </p:sp>
+      <p:sp>
+        <p:nvSpPr>
+          <p:cNvPr id="5" name="Rectangle 4"/>
+          <p:cNvSpPr/>
+          <p:nvPr/>
+        </p:nvSpPr>
+        <p:spPr>
+          <a:xfrm>
+            <a:off x="0" y="0"/>
+            <a:ext cx="12191695" cy="109728"/>
+          </a:xfrm>
+          <a:prstGeom prst="rect">
+            <a:avLst/>
+          </a:prstGeom>
+          <a:solidFill>
+            <a:srgbClr val="4ADE80"/>
+          </a:solidFill>
+          <a:ln>
+            <a:noFill/>
+          </a:ln>
+          <a:effectLst/>
+        </p:spPr>
+        <p:style>
+          <a:lnRef idx="1">
+            <a:schemeClr val="accent1"/>
+          </a:lnRef>
+          <a:fillRef idx="3">
+            <a:schemeClr val="accent1"/>
+          </a:fillRef>
+          <a:effectRef idx="2">
+            <a:schemeClr val="accent1"/>
+          </a:effectRef>
+          <a:fontRef idx="minor">
+            <a:schemeClr val="lt1"/>
+          </a:fontRef>
+        </p:style>
+        <p:txBody>
+          <a:bodyPr rtlCol="0" anchor="ctr"/>
+          <a:lstStyle/>
+          <a:p>
+            <a:pPr algn="ctr"/>
+          </a:p>
+        </p:txBody>
+      </p:sp>
       <p:pic>
         <p:nvPicPr>
           <p:cNvPr id="6" name="Picture 5" descr="practicerank-logo-360.png"/>
@@ -14913,7 +15562,7 @@
                 </a:solidFill>
                 <a:latin typeface="Calibri"/>
               </a:rPr>
-              <a:t>NEXT STEPS · 1 OF 2</a:t>
+              <a:t>PROOF OF MOMENTUM</a:t>
             </a:r>
           </a:p>
         </p:txBody>
@@ -14952,7 +15601,7 @@
                 </a:solidFill>
                 <a:latin typeface="Calibri"/>
               </a:rPr>
-              <a:t>Building Authority — High-Value Backlinks</a:t>
+              <a:t>Your PracticeRank Score — Already Climbing</a:t>
             </a:r>
           </a:p>
         </p:txBody>
@@ -15111,8 +15760,8 @@
         </p:nvSpPr>
         <p:spPr>
           <a:xfrm>
-            <a:off x="658368" y="1828800"/>
-            <a:ext cx="10881360" cy="548640"/>
+            <a:off x="658368" y="1783080"/>
+            <a:ext cx="10881360" cy="640080"/>
           </a:xfrm>
           <a:prstGeom prst="rect">
             <a:avLst/>
@@ -15127,208 +15776,593 @@
           <a:p>
             <a:pPr algn="l">
               <a:lnSpc>
-                <a:spcPct val="100000"/>
-              </a:lnSpc>
-            </a:pPr>
-            <a:r>
-              <a:rPr sz="1600" b="0">
+                <a:spcPct val="118000"/>
+              </a:lnSpc>
+            </a:pPr>
+            <a:r>
+              <a:rPr sz="1500" b="0">
                 <a:solidFill>
                   <a:srgbClr val="9AA6B4"/>
                 </a:solidFill>
                 <a:latin typeface="Calibri"/>
               </a:rPr>
-              <a:t>Quality over volume: a few strong, locally-relevant links that lift rankings AND AI recommendations.</a:t>
-            </a:r>
-          </a:p>
-        </p:txBody>
-      </p:sp>
-      <p:sp>
-        <p:nvSpPr>
-          <p:cNvPr id="13" name="TextBox 12"/>
-          <p:cNvSpPr txBox="1"/>
-          <p:nvPr/>
-        </p:nvSpPr>
-        <p:spPr>
-          <a:xfrm>
-            <a:off x="822960" y="2697480"/>
-            <a:ext cx="6583680" cy="4572000"/>
-          </a:xfrm>
-          <a:prstGeom prst="rect">
-            <a:avLst/>
-          </a:prstGeom>
-          <a:noFill/>
-        </p:spPr>
-        <p:txBody>
-          <a:bodyPr wrap="square">
-            <a:spAutoFit/>
-          </a:bodyPr>
-          <a:lstStyle/>
-          <a:p>
-            <a:pPr>
-              <a:lnSpc>
-                <a:spcPct val="110000"/>
-              </a:lnSpc>
-              <a:spcAft>
-                <a:spcPts val="1000"/>
-              </a:spcAft>
-            </a:pPr>
-            <a:r>
-              <a:rPr b="1" sz="1500">
-                <a:solidFill>
-                  <a:srgbClr val="4ADE80"/>
-                </a:solidFill>
-              </a:rPr>
-              <a:t>—  </a:t>
-            </a:r>
-            <a:r>
-              <a:rPr sz="1500">
-                <a:solidFill>
-                  <a:srgbClr val="FFFFFF"/>
-                </a:solidFill>
-                <a:latin typeface="Calibri"/>
-              </a:rPr>
-              <a:t>Local citations + NAP consistency across the directories that matter</a:t>
-            </a:r>
-          </a:p>
-          <a:p>
-            <a:pPr>
-              <a:lnSpc>
-                <a:spcPct val="110000"/>
-              </a:lnSpc>
-              <a:spcAft>
-                <a:spcPts val="1000"/>
-              </a:spcAft>
-            </a:pPr>
-            <a:r>
-              <a:rPr b="1" sz="1500">
-                <a:solidFill>
-                  <a:srgbClr val="4ADE80"/>
-                </a:solidFill>
-              </a:rPr>
-              <a:t>—  </a:t>
-            </a:r>
-            <a:r>
-              <a:rPr sz="1500">
-                <a:solidFill>
-                  <a:srgbClr val="FFFFFF"/>
-                </a:solidFill>
-                <a:latin typeface="Calibri"/>
-              </a:rPr>
-              <a:t>Local press, community sponsorships &amp; events for authoritative mentions</a:t>
-            </a:r>
-          </a:p>
-          <a:p>
-            <a:pPr>
-              <a:lnSpc>
-                <a:spcPct val="110000"/>
-              </a:lnSpc>
-              <a:spcAft>
-                <a:spcPts val="1000"/>
-              </a:spcAft>
-            </a:pPr>
-            <a:r>
-              <a:rPr b="1" sz="1500">
-                <a:solidFill>
-                  <a:srgbClr val="4ADE80"/>
-                </a:solidFill>
-              </a:rPr>
-              <a:t>—  </a:t>
-            </a:r>
-            <a:r>
-              <a:rPr sz="1500">
-                <a:solidFill>
-                  <a:srgbClr val="FFFFFF"/>
-                </a:solidFill>
-                <a:latin typeface="Calibri"/>
-              </a:rPr>
-              <a:t>Partner, supplier &amp; association links relevant to your business</a:t>
-            </a:r>
-          </a:p>
-          <a:p>
-            <a:pPr>
-              <a:lnSpc>
-                <a:spcPct val="110000"/>
-              </a:lnSpc>
-              <a:spcAft>
-                <a:spcPts val="1000"/>
-              </a:spcAft>
-            </a:pPr>
-            <a:r>
-              <a:rPr b="1" sz="1500">
-                <a:solidFill>
-                  <a:srgbClr val="4ADE80"/>
-                </a:solidFill>
-              </a:rPr>
-              <a:t>—  </a:t>
-            </a:r>
-            <a:r>
-              <a:rPr sz="1500">
-                <a:solidFill>
-                  <a:srgbClr val="FFFFFF"/>
-                </a:solidFill>
-                <a:latin typeface="Calibri"/>
-              </a:rPr>
-              <a:t>“Best in {city}” roundups and local guides that AI assistants cite</a:t>
-            </a:r>
-          </a:p>
-          <a:p>
-            <a:pPr>
-              <a:lnSpc>
-                <a:spcPct val="110000"/>
-              </a:lnSpc>
-              <a:spcAft>
-                <a:spcPts val="1000"/>
-              </a:spcAft>
-            </a:pPr>
-            <a:r>
-              <a:rPr b="1" sz="1500">
-                <a:solidFill>
-                  <a:srgbClr val="4ADE80"/>
-                </a:solidFill>
-              </a:rPr>
-              <a:t>—  </a:t>
-            </a:r>
-            <a:r>
-              <a:rPr sz="1500">
-                <a:solidFill>
-                  <a:srgbClr val="FFFFFF"/>
-                </a:solidFill>
-                <a:latin typeface="Calibri"/>
-              </a:rPr>
-              <a:t>Steady cadence of high-authority links each month — no spam</a:t>
-            </a:r>
-          </a:p>
-        </p:txBody>
-      </p:sp>
-      <p:pic>
-        <p:nvPicPr>
-          <p:cNvPr id="14" name="Picture 13" descr="storefront.jpg"/>
-          <p:cNvPicPr>
-            <a:picLocks noChangeAspect="1"/>
-          </p:cNvPicPr>
-          <p:nvPr/>
-        </p:nvPicPr>
-        <p:blipFill>
-          <a:blip r:embed="rId3"/>
-          <a:stretch>
-            <a:fillRect/>
-          </a:stretch>
-        </p:blipFill>
-        <p:spPr>
-          <a:xfrm>
-            <a:off x="7589520" y="2697480"/>
-            <a:ext cx="3931920" cy="2624328"/>
-          </a:xfrm>
-          <a:prstGeom prst="rect">
-            <a:avLst/>
-          </a:prstGeom>
-          <a:ln w="12700">
+              <a:t>Your PracticeRank Score (0–100) is the one number we track and guarantee — your visibility across Google, Maps, reviews &amp; AI search.</a:t>
+            </a:r>
+          </a:p>
+        </p:txBody>
+      </p:sp>
+      <p:sp>
+        <p:nvSpPr>
+          <p:cNvPr id="13" name="Rounded Rectangle 12"/>
+          <p:cNvSpPr/>
+          <p:nvPr/>
+        </p:nvSpPr>
+        <p:spPr>
+          <a:xfrm>
+            <a:off x="822960" y="2743200"/>
+            <a:ext cx="3017520" cy="2057400"/>
+          </a:xfrm>
+          <a:prstGeom prst="roundRect">
+            <a:avLst/>
+          </a:prstGeom>
+          <a:solidFill>
+            <a:srgbClr val="121822"/>
+          </a:solidFill>
+          <a:ln w="9525">
             <a:solidFill>
               <a:srgbClr val="232C39"/>
             </a:solidFill>
           </a:ln>
-        </p:spPr>
-      </p:pic>
+          <a:effectLst/>
+        </p:spPr>
+        <p:style>
+          <a:lnRef idx="1">
+            <a:schemeClr val="accent1"/>
+          </a:lnRef>
+          <a:fillRef idx="3">
+            <a:schemeClr val="accent1"/>
+          </a:fillRef>
+          <a:effectRef idx="2">
+            <a:schemeClr val="accent1"/>
+          </a:effectRef>
+          <a:fontRef idx="minor">
+            <a:schemeClr val="lt1"/>
+          </a:fontRef>
+        </p:style>
+        <p:txBody>
+          <a:bodyPr rtlCol="0" anchor="ctr"/>
+          <a:lstStyle/>
+          <a:p>
+            <a:pPr algn="ctr"/>
+          </a:p>
+        </p:txBody>
+      </p:sp>
+      <p:sp>
+        <p:nvSpPr>
+          <p:cNvPr id="14" name="TextBox 13"/>
+          <p:cNvSpPr txBox="1"/>
+          <p:nvPr/>
+        </p:nvSpPr>
+        <p:spPr>
+          <a:xfrm>
+            <a:off x="822960" y="2944368"/>
+            <a:ext cx="3017520" cy="365760"/>
+          </a:xfrm>
+          <a:prstGeom prst="rect">
+            <a:avLst/>
+          </a:prstGeom>
+          <a:noFill/>
+        </p:spPr>
+        <p:txBody>
+          <a:bodyPr wrap="square" anchor="t">
+            <a:spAutoFit/>
+          </a:bodyPr>
+          <a:lstStyle/>
+          <a:p>
+            <a:pPr algn="ctr">
+              <a:lnSpc>
+                <a:spcPct val="100000"/>
+              </a:lnSpc>
+            </a:pPr>
+            <a:r>
+              <a:rPr sz="1200" b="1">
+                <a:solidFill>
+                  <a:srgbClr val="9AA6B4"/>
+                </a:solidFill>
+                <a:latin typeface="Calibri"/>
+              </a:rPr>
+              <a:t>WHERE YOU STARTED</a:t>
+            </a:r>
+          </a:p>
+        </p:txBody>
+      </p:sp>
+      <p:sp>
+        <p:nvSpPr>
+          <p:cNvPr id="15" name="TextBox 14"/>
+          <p:cNvSpPr txBox="1"/>
+          <p:nvPr/>
+        </p:nvSpPr>
+        <p:spPr>
+          <a:xfrm>
+            <a:off x="822960" y="3200400"/>
+            <a:ext cx="3017520" cy="1188720"/>
+          </a:xfrm>
+          <a:prstGeom prst="rect">
+            <a:avLst/>
+          </a:prstGeom>
+          <a:noFill/>
+        </p:spPr>
+        <p:txBody>
+          <a:bodyPr wrap="square" anchor="t">
+            <a:spAutoFit/>
+          </a:bodyPr>
+          <a:lstStyle/>
+          <a:p>
+            <a:pPr algn="ctr">
+              <a:lnSpc>
+                <a:spcPct val="100000"/>
+              </a:lnSpc>
+            </a:pPr>
+            <a:r>
+              <a:rPr sz="7800" b="1">
+                <a:solidFill>
+                  <a:srgbClr val="FFFFFF"/>
+                </a:solidFill>
+                <a:latin typeface="Calibri"/>
+              </a:rPr>
+              <a:t>65</a:t>
+            </a:r>
+          </a:p>
+        </p:txBody>
+      </p:sp>
+      <p:sp>
+        <p:nvSpPr>
+          <p:cNvPr id="16" name="TextBox 15"/>
+          <p:cNvSpPr txBox="1"/>
+          <p:nvPr/>
+        </p:nvSpPr>
+        <p:spPr>
+          <a:xfrm>
+            <a:off x="822960" y="4407408"/>
+            <a:ext cx="3017520" cy="274320"/>
+          </a:xfrm>
+          <a:prstGeom prst="rect">
+            <a:avLst/>
+          </a:prstGeom>
+          <a:noFill/>
+        </p:spPr>
+        <p:txBody>
+          <a:bodyPr wrap="square" anchor="t">
+            <a:spAutoFit/>
+          </a:bodyPr>
+          <a:lstStyle/>
+          <a:p>
+            <a:pPr algn="ctr">
+              <a:lnSpc>
+                <a:spcPct val="100000"/>
+              </a:lnSpc>
+            </a:pPr>
+            <a:r>
+              <a:rPr sz="1200" b="0">
+                <a:solidFill>
+                  <a:srgbClr val="5E6A79"/>
+                </a:solidFill>
+                <a:latin typeface="Calibri"/>
+              </a:rPr>
+              <a:t>May 27</a:t>
+            </a:r>
+          </a:p>
+        </p:txBody>
+      </p:sp>
+      <p:sp>
+        <p:nvSpPr>
+          <p:cNvPr id="17" name="TextBox 16"/>
+          <p:cNvSpPr txBox="1"/>
+          <p:nvPr/>
+        </p:nvSpPr>
+        <p:spPr>
+          <a:xfrm>
+            <a:off x="3931920" y="3246120"/>
+            <a:ext cx="1371600" cy="914400"/>
+          </a:xfrm>
+          <a:prstGeom prst="rect">
+            <a:avLst/>
+          </a:prstGeom>
+          <a:noFill/>
+        </p:spPr>
+        <p:txBody>
+          <a:bodyPr wrap="square" anchor="ctr">
+            <a:spAutoFit/>
+          </a:bodyPr>
+          <a:lstStyle/>
+          <a:p>
+            <a:pPr algn="ctr">
+              <a:lnSpc>
+                <a:spcPct val="100000"/>
+              </a:lnSpc>
+            </a:pPr>
+            <a:r>
+              <a:rPr sz="4600" b="0">
+                <a:solidFill>
+                  <a:srgbClr val="4ADE80"/>
+                </a:solidFill>
+                <a:latin typeface="Calibri"/>
+              </a:rPr>
+              <a:t>→</a:t>
+            </a:r>
+          </a:p>
+        </p:txBody>
+      </p:sp>
+      <p:sp>
+        <p:nvSpPr>
+          <p:cNvPr id="18" name="Rounded Rectangle 17"/>
+          <p:cNvSpPr/>
+          <p:nvPr/>
+        </p:nvSpPr>
+        <p:spPr>
+          <a:xfrm>
+            <a:off x="3977639" y="4160520"/>
+            <a:ext cx="1280160" cy="502920"/>
+          </a:xfrm>
+          <a:prstGeom prst="roundRect">
+            <a:avLst/>
+          </a:prstGeom>
+          <a:solidFill>
+            <a:srgbClr val="4ADE80"/>
+          </a:solidFill>
+          <a:ln>
+            <a:noFill/>
+          </a:ln>
+          <a:effectLst/>
+        </p:spPr>
+        <p:style>
+          <a:lnRef idx="1">
+            <a:schemeClr val="accent1"/>
+          </a:lnRef>
+          <a:fillRef idx="3">
+            <a:schemeClr val="accent1"/>
+          </a:fillRef>
+          <a:effectRef idx="2">
+            <a:schemeClr val="accent1"/>
+          </a:effectRef>
+          <a:fontRef idx="minor">
+            <a:schemeClr val="lt1"/>
+          </a:fontRef>
+        </p:style>
+        <p:txBody>
+          <a:bodyPr rtlCol="0" anchor="ctr"/>
+          <a:lstStyle/>
+          <a:p>
+            <a:pPr algn="ctr"/>
+          </a:p>
+        </p:txBody>
+      </p:sp>
+      <p:sp>
+        <p:nvSpPr>
+          <p:cNvPr id="19" name="TextBox 18"/>
+          <p:cNvSpPr txBox="1"/>
+          <p:nvPr/>
+        </p:nvSpPr>
+        <p:spPr>
+          <a:xfrm>
+            <a:off x="3977639" y="4178808"/>
+            <a:ext cx="1280160" cy="457200"/>
+          </a:xfrm>
+          <a:prstGeom prst="rect">
+            <a:avLst/>
+          </a:prstGeom>
+          <a:noFill/>
+        </p:spPr>
+        <p:txBody>
+          <a:bodyPr wrap="square" anchor="ctr">
+            <a:spAutoFit/>
+          </a:bodyPr>
+          <a:lstStyle/>
+          <a:p>
+            <a:pPr algn="ctr">
+              <a:lnSpc>
+                <a:spcPct val="100000"/>
+              </a:lnSpc>
+            </a:pPr>
+            <a:r>
+              <a:rPr sz="1700" b="1">
+                <a:solidFill>
+                  <a:srgbClr val="04210F"/>
+                </a:solidFill>
+                <a:latin typeface="Calibri"/>
+              </a:rPr>
+              <a:t>+14 pts</a:t>
+            </a:r>
+          </a:p>
+        </p:txBody>
+      </p:sp>
+      <p:sp>
+        <p:nvSpPr>
+          <p:cNvPr id="20" name="Rounded Rectangle 19"/>
+          <p:cNvSpPr/>
+          <p:nvPr/>
+        </p:nvSpPr>
+        <p:spPr>
+          <a:xfrm>
+            <a:off x="5349240" y="2743200"/>
+            <a:ext cx="3017520" cy="2057400"/>
+          </a:xfrm>
+          <a:prstGeom prst="roundRect">
+            <a:avLst/>
+          </a:prstGeom>
+          <a:solidFill>
+            <a:srgbClr val="121822"/>
+          </a:solidFill>
+          <a:ln w="12700">
+            <a:solidFill>
+              <a:srgbClr val="4ADE80"/>
+            </a:solidFill>
+          </a:ln>
+          <a:effectLst/>
+        </p:spPr>
+        <p:style>
+          <a:lnRef idx="1">
+            <a:schemeClr val="accent1"/>
+          </a:lnRef>
+          <a:fillRef idx="3">
+            <a:schemeClr val="accent1"/>
+          </a:fillRef>
+          <a:effectRef idx="2">
+            <a:schemeClr val="accent1"/>
+          </a:effectRef>
+          <a:fontRef idx="minor">
+            <a:schemeClr val="lt1"/>
+          </a:fontRef>
+        </p:style>
+        <p:txBody>
+          <a:bodyPr rtlCol="0" anchor="ctr"/>
+          <a:lstStyle/>
+          <a:p>
+            <a:pPr algn="ctr"/>
+          </a:p>
+        </p:txBody>
+      </p:sp>
+      <p:sp>
+        <p:nvSpPr>
+          <p:cNvPr id="21" name="TextBox 20"/>
+          <p:cNvSpPr txBox="1"/>
+          <p:nvPr/>
+        </p:nvSpPr>
+        <p:spPr>
+          <a:xfrm>
+            <a:off x="5349240" y="2944368"/>
+            <a:ext cx="3017520" cy="365760"/>
+          </a:xfrm>
+          <a:prstGeom prst="rect">
+            <a:avLst/>
+          </a:prstGeom>
+          <a:noFill/>
+        </p:spPr>
+        <p:txBody>
+          <a:bodyPr wrap="square" anchor="t">
+            <a:spAutoFit/>
+          </a:bodyPr>
+          <a:lstStyle/>
+          <a:p>
+            <a:pPr algn="ctr">
+              <a:lnSpc>
+                <a:spcPct val="100000"/>
+              </a:lnSpc>
+            </a:pPr>
+            <a:r>
+              <a:rPr sz="1200" b="1">
+                <a:solidFill>
+                  <a:srgbClr val="4ADE80"/>
+                </a:solidFill>
+                <a:latin typeface="Calibri"/>
+              </a:rPr>
+              <a:t>TODAY</a:t>
+            </a:r>
+          </a:p>
+        </p:txBody>
+      </p:sp>
+      <p:sp>
+        <p:nvSpPr>
+          <p:cNvPr id="22" name="TextBox 21"/>
+          <p:cNvSpPr txBox="1"/>
+          <p:nvPr/>
+        </p:nvSpPr>
+        <p:spPr>
+          <a:xfrm>
+            <a:off x="5349240" y="3200400"/>
+            <a:ext cx="3017520" cy="1188720"/>
+          </a:xfrm>
+          <a:prstGeom prst="rect">
+            <a:avLst/>
+          </a:prstGeom>
+          <a:noFill/>
+        </p:spPr>
+        <p:txBody>
+          <a:bodyPr wrap="square" anchor="t">
+            <a:spAutoFit/>
+          </a:bodyPr>
+          <a:lstStyle/>
+          <a:p>
+            <a:pPr algn="ctr">
+              <a:lnSpc>
+                <a:spcPct val="100000"/>
+              </a:lnSpc>
+            </a:pPr>
+            <a:r>
+              <a:rPr sz="7800" b="1">
+                <a:solidFill>
+                  <a:srgbClr val="4ADE80"/>
+                </a:solidFill>
+                <a:latin typeface="Calibri"/>
+              </a:rPr>
+              <a:t>79</a:t>
+            </a:r>
+          </a:p>
+        </p:txBody>
+      </p:sp>
+      <p:sp>
+        <p:nvSpPr>
+          <p:cNvPr id="23" name="TextBox 22"/>
+          <p:cNvSpPr txBox="1"/>
+          <p:nvPr/>
+        </p:nvSpPr>
+        <p:spPr>
+          <a:xfrm>
+            <a:off x="5349240" y="4407408"/>
+            <a:ext cx="3017520" cy="274320"/>
+          </a:xfrm>
+          <a:prstGeom prst="rect">
+            <a:avLst/>
+          </a:prstGeom>
+          <a:noFill/>
+        </p:spPr>
+        <p:txBody>
+          <a:bodyPr wrap="square" anchor="t">
+            <a:spAutoFit/>
+          </a:bodyPr>
+          <a:lstStyle/>
+          <a:p>
+            <a:pPr algn="ctr">
+              <a:lnSpc>
+                <a:spcPct val="100000"/>
+              </a:lnSpc>
+            </a:pPr>
+            <a:r>
+              <a:rPr sz="1200" b="0">
+                <a:solidFill>
+                  <a:srgbClr val="5E6A79"/>
+                </a:solidFill>
+                <a:latin typeface="Calibri"/>
+              </a:rPr>
+              <a:t>Jun 19  ·  and climbing</a:t>
+            </a:r>
+          </a:p>
+        </p:txBody>
+      </p:sp>
+      <p:sp>
+        <p:nvSpPr>
+          <p:cNvPr id="24" name="Rounded Rectangle 23"/>
+          <p:cNvSpPr/>
+          <p:nvPr/>
+        </p:nvSpPr>
+        <p:spPr>
+          <a:xfrm>
+            <a:off x="8778240" y="2743200"/>
+            <a:ext cx="2743200" cy="2057400"/>
+          </a:xfrm>
+          <a:prstGeom prst="roundRect">
+            <a:avLst/>
+          </a:prstGeom>
+          <a:solidFill>
+            <a:srgbClr val="16213E"/>
+          </a:solidFill>
+          <a:ln w="9525">
+            <a:solidFill>
+              <a:srgbClr val="232C39"/>
+            </a:solidFill>
+          </a:ln>
+          <a:effectLst/>
+        </p:spPr>
+        <p:style>
+          <a:lnRef idx="1">
+            <a:schemeClr val="accent1"/>
+          </a:lnRef>
+          <a:fillRef idx="3">
+            <a:schemeClr val="accent1"/>
+          </a:fillRef>
+          <a:effectRef idx="2">
+            <a:schemeClr val="accent1"/>
+          </a:effectRef>
+          <a:fontRef idx="minor">
+            <a:schemeClr val="lt1"/>
+          </a:fontRef>
+        </p:style>
+        <p:txBody>
+          <a:bodyPr rtlCol="0" anchor="ctr"/>
+          <a:lstStyle/>
+          <a:p>
+            <a:pPr algn="ctr"/>
+          </a:p>
+        </p:txBody>
+      </p:sp>
+      <p:sp>
+        <p:nvSpPr>
+          <p:cNvPr id="25" name="TextBox 24"/>
+          <p:cNvSpPr txBox="1"/>
+          <p:nvPr/>
+        </p:nvSpPr>
+        <p:spPr>
+          <a:xfrm>
+            <a:off x="9006840" y="2971800"/>
+            <a:ext cx="2331720" cy="1600200"/>
+          </a:xfrm>
+          <a:prstGeom prst="rect">
+            <a:avLst/>
+          </a:prstGeom>
+          <a:noFill/>
+        </p:spPr>
+        <p:txBody>
+          <a:bodyPr wrap="square" anchor="ctr">
+            <a:spAutoFit/>
+          </a:bodyPr>
+          <a:lstStyle/>
+          <a:p>
+            <a:pPr algn="l">
+              <a:lnSpc>
+                <a:spcPct val="122000"/>
+              </a:lnSpc>
+            </a:pPr>
+            <a:r>
+              <a:rPr sz="1500" b="0">
+                <a:solidFill>
+                  <a:srgbClr val="DCE2E8"/>
+                </a:solidFill>
+                <a:latin typeface="Calibri"/>
+              </a:rPr>
+              <a:t>That's already 14 of the 20-point lift your guarantee is built on — in just a few weeks.</a:t>
+            </a:r>
+          </a:p>
+        </p:txBody>
+      </p:sp>
+      <p:sp>
+        <p:nvSpPr>
+          <p:cNvPr id="26" name="TextBox 25"/>
+          <p:cNvSpPr txBox="1"/>
+          <p:nvPr/>
+        </p:nvSpPr>
+        <p:spPr>
+          <a:xfrm>
+            <a:off x="658368" y="5120640"/>
+            <a:ext cx="10881360" cy="548640"/>
+          </a:xfrm>
+          <a:prstGeom prst="rect">
+            <a:avLst/>
+          </a:prstGeom>
+          <a:noFill/>
+        </p:spPr>
+        <p:txBody>
+          <a:bodyPr wrap="square" anchor="t">
+            <a:spAutoFit/>
+          </a:bodyPr>
+          <a:lstStyle/>
+          <a:p>
+            <a:pPr algn="l">
+              <a:lnSpc>
+                <a:spcPct val="100000"/>
+              </a:lnSpc>
+            </a:pPr>
+            <a:r>
+              <a:rPr sz="1400" b="1">
+                <a:solidFill>
+                  <a:srgbClr val="4ADE80"/>
+                </a:solidFill>
+                <a:latin typeface="Calibri"/>
+              </a:rPr>
+              <a:t>Now pointed at your real Google search data and a backlink program — so the climb keeps compounding.</a:t>
+            </a:r>
+          </a:p>
+        </p:txBody>
+      </p:sp>
     </p:spTree>
   </p:cSld>
   <p:clrMapOvr>

</xml_diff>

<commit_message>
deck: explain WHY the score climbed — real component drivers on the score slide
Added a 'What moved it' breakdown to the PracticeRank Score slide using the
real component deltas: Technical Health 0->75 (foundation: schema/llms.txt/
HTTPS), Content Velocity 30->80 (service & location pages + content),
Reputation 56->81 (review profile). Ties the +14 directly to the work we did.
</commit_message>
<xml_diff>
--- a/deliverables/PracticeRank-SEO-Strategy-Paradigm-Experts.pptx
+++ b/deliverables/PracticeRank-SEO-Strategy-Paradigm-Experts.pptx
@@ -15799,8 +15799,8 @@
         </p:nvSpPr>
         <p:spPr>
           <a:xfrm>
-            <a:off x="822960" y="2743200"/>
-            <a:ext cx="3017520" cy="2057400"/>
+            <a:off x="822960" y="2468880"/>
+            <a:ext cx="2834640" cy="1783080"/>
           </a:xfrm>
           <a:prstGeom prst="roundRect">
             <a:avLst/>
@@ -15845,8 +15845,8 @@
         </p:nvSpPr>
         <p:spPr>
           <a:xfrm>
-            <a:off x="822960" y="2944368"/>
-            <a:ext cx="3017520" cy="365760"/>
+            <a:off x="822960" y="2633472"/>
+            <a:ext cx="2834640" cy="365760"/>
           </a:xfrm>
           <a:prstGeom prst="rect">
             <a:avLst/>
@@ -15865,7 +15865,7 @@
               </a:lnSpc>
             </a:pPr>
             <a:r>
-              <a:rPr sz="1200" b="1">
+              <a:rPr sz="1100" b="1">
                 <a:solidFill>
                   <a:srgbClr val="9AA6B4"/>
                 </a:solidFill>
@@ -15884,8 +15884,8 @@
         </p:nvSpPr>
         <p:spPr>
           <a:xfrm>
-            <a:off x="822960" y="3200400"/>
-            <a:ext cx="3017520" cy="1188720"/>
+            <a:off x="822960" y="2907792"/>
+            <a:ext cx="2834640" cy="1005840"/>
           </a:xfrm>
           <a:prstGeom prst="rect">
             <a:avLst/>
@@ -15904,7 +15904,7 @@
               </a:lnSpc>
             </a:pPr>
             <a:r>
-              <a:rPr sz="7800" b="1">
+              <a:rPr sz="6000" b="1">
                 <a:solidFill>
                   <a:srgbClr val="FFFFFF"/>
                 </a:solidFill>
@@ -15923,8 +15923,8 @@
         </p:nvSpPr>
         <p:spPr>
           <a:xfrm>
-            <a:off x="822960" y="4407408"/>
-            <a:ext cx="3017520" cy="274320"/>
+            <a:off x="822960" y="3931920"/>
+            <a:ext cx="2834640" cy="274320"/>
           </a:xfrm>
           <a:prstGeom prst="rect">
             <a:avLst/>
@@ -15943,7 +15943,7 @@
               </a:lnSpc>
             </a:pPr>
             <a:r>
-              <a:rPr sz="1200" b="0">
+              <a:rPr sz="1100" b="0">
                 <a:solidFill>
                   <a:srgbClr val="5E6A79"/>
                 </a:solidFill>
@@ -15962,8 +15962,8 @@
         </p:nvSpPr>
         <p:spPr>
           <a:xfrm>
-            <a:off x="3931920" y="3246120"/>
-            <a:ext cx="1371600" cy="914400"/>
+            <a:off x="3749039" y="2788920"/>
+            <a:ext cx="1188720" cy="914400"/>
           </a:xfrm>
           <a:prstGeom prst="rect">
             <a:avLst/>
@@ -15982,7 +15982,7 @@
               </a:lnSpc>
             </a:pPr>
             <a:r>
-              <a:rPr sz="4600" b="0">
+              <a:rPr sz="4000" b="0">
                 <a:solidFill>
                   <a:srgbClr val="4ADE80"/>
                 </a:solidFill>
@@ -16001,8 +16001,8 @@
         </p:nvSpPr>
         <p:spPr>
           <a:xfrm>
-            <a:off x="3977639" y="4160520"/>
-            <a:ext cx="1280160" cy="502920"/>
+            <a:off x="3749039" y="3611880"/>
+            <a:ext cx="1188720" cy="457200"/>
           </a:xfrm>
           <a:prstGeom prst="roundRect">
             <a:avLst/>
@@ -16045,8 +16045,8 @@
         </p:nvSpPr>
         <p:spPr>
           <a:xfrm>
-            <a:off x="3977639" y="4178808"/>
-            <a:ext cx="1280160" cy="457200"/>
+            <a:off x="3749039" y="3630168"/>
+            <a:ext cx="1188720" cy="420624"/>
           </a:xfrm>
           <a:prstGeom prst="rect">
             <a:avLst/>
@@ -16065,7 +16065,7 @@
               </a:lnSpc>
             </a:pPr>
             <a:r>
-              <a:rPr sz="1700" b="1">
+              <a:rPr sz="1500" b="1">
                 <a:solidFill>
                   <a:srgbClr val="04210F"/>
                 </a:solidFill>
@@ -16084,8 +16084,8 @@
         </p:nvSpPr>
         <p:spPr>
           <a:xfrm>
-            <a:off x="5349240" y="2743200"/>
-            <a:ext cx="3017520" cy="2057400"/>
+            <a:off x="5029200" y="2468880"/>
+            <a:ext cx="2834640" cy="1783080"/>
           </a:xfrm>
           <a:prstGeom prst="roundRect">
             <a:avLst/>
@@ -16130,8 +16130,8 @@
         </p:nvSpPr>
         <p:spPr>
           <a:xfrm>
-            <a:off x="5349240" y="2944368"/>
-            <a:ext cx="3017520" cy="365760"/>
+            <a:off x="5029200" y="2633472"/>
+            <a:ext cx="2834640" cy="365760"/>
           </a:xfrm>
           <a:prstGeom prst="rect">
             <a:avLst/>
@@ -16150,7 +16150,7 @@
               </a:lnSpc>
             </a:pPr>
             <a:r>
-              <a:rPr sz="1200" b="1">
+              <a:rPr sz="1100" b="1">
                 <a:solidFill>
                   <a:srgbClr val="4ADE80"/>
                 </a:solidFill>
@@ -16169,8 +16169,8 @@
         </p:nvSpPr>
         <p:spPr>
           <a:xfrm>
-            <a:off x="5349240" y="3200400"/>
-            <a:ext cx="3017520" cy="1188720"/>
+            <a:off x="5029200" y="2907792"/>
+            <a:ext cx="2834640" cy="1005840"/>
           </a:xfrm>
           <a:prstGeom prst="rect">
             <a:avLst/>
@@ -16189,7 +16189,7 @@
               </a:lnSpc>
             </a:pPr>
             <a:r>
-              <a:rPr sz="7800" b="1">
+              <a:rPr sz="6000" b="1">
                 <a:solidFill>
                   <a:srgbClr val="4ADE80"/>
                 </a:solidFill>
@@ -16208,8 +16208,8 @@
         </p:nvSpPr>
         <p:spPr>
           <a:xfrm>
-            <a:off x="5349240" y="4407408"/>
-            <a:ext cx="3017520" cy="274320"/>
+            <a:off x="5029200" y="3931920"/>
+            <a:ext cx="2834640" cy="274320"/>
           </a:xfrm>
           <a:prstGeom prst="rect">
             <a:avLst/>
@@ -16228,7 +16228,7 @@
               </a:lnSpc>
             </a:pPr>
             <a:r>
-              <a:rPr sz="1200" b="0">
+              <a:rPr sz="1100" b="0">
                 <a:solidFill>
                   <a:srgbClr val="5E6A79"/>
                 </a:solidFill>
@@ -16247,8 +16247,8 @@
         </p:nvSpPr>
         <p:spPr>
           <a:xfrm>
-            <a:off x="8778240" y="2743200"/>
-            <a:ext cx="2743200" cy="2057400"/>
+            <a:off x="8229600" y="2468880"/>
+            <a:ext cx="3291840" cy="1783080"/>
           </a:xfrm>
           <a:prstGeom prst="roundRect">
             <a:avLst/>
@@ -16293,8 +16293,8 @@
         </p:nvSpPr>
         <p:spPr>
           <a:xfrm>
-            <a:off x="9006840" y="2971800"/>
-            <a:ext cx="2331720" cy="1600200"/>
+            <a:off x="8458200" y="2651760"/>
+            <a:ext cx="2834640" cy="1463040"/>
           </a:xfrm>
           <a:prstGeom prst="rect">
             <a:avLst/>
@@ -16309,17 +16309,17 @@
           <a:p>
             <a:pPr algn="l">
               <a:lnSpc>
-                <a:spcPct val="122000"/>
-              </a:lnSpc>
-            </a:pPr>
-            <a:r>
-              <a:rPr sz="1500" b="0">
+                <a:spcPct val="120000"/>
+              </a:lnSpc>
+            </a:pPr>
+            <a:r>
+              <a:rPr sz="1450" b="0">
                 <a:solidFill>
                   <a:srgbClr val="DCE2E8"/>
                 </a:solidFill>
                 <a:latin typeface="Calibri"/>
               </a:rPr>
-              <a:t>That's already 14 of the 20-point lift your guarantee is built on — in just a few weeks.</a:t>
+              <a:t>Already 14 of the 20-point lift your guarantee is built on — in just a few weeks.</a:t>
             </a:r>
           </a:p>
         </p:txBody>
@@ -16332,8 +16332,8 @@
         </p:nvSpPr>
         <p:spPr>
           <a:xfrm>
-            <a:off x="658368" y="5120640"/>
-            <a:ext cx="10881360" cy="548640"/>
+            <a:off x="822960" y="4526280"/>
+            <a:ext cx="7315200" cy="320040"/>
           </a:xfrm>
           <a:prstGeom prst="rect">
             <a:avLst/>
@@ -16352,13 +16352,502 @@
               </a:lnSpc>
             </a:pPr>
             <a:r>
+              <a:rPr sz="1200" b="1">
+                <a:solidFill>
+                  <a:srgbClr val="4ADE80"/>
+                </a:solidFill>
+                <a:latin typeface="Calibri"/>
+              </a:rPr>
+              <a:t>WHAT MOVED IT</a:t>
+            </a:r>
+          </a:p>
+        </p:txBody>
+      </p:sp>
+      <p:sp>
+        <p:nvSpPr>
+          <p:cNvPr id="27" name="Rounded Rectangle 26"/>
+          <p:cNvSpPr/>
+          <p:nvPr/>
+        </p:nvSpPr>
+        <p:spPr>
+          <a:xfrm>
+            <a:off x="822960" y="4892040"/>
+            <a:ext cx="3383280" cy="1234440"/>
+          </a:xfrm>
+          <a:prstGeom prst="roundRect">
+            <a:avLst/>
+          </a:prstGeom>
+          <a:solidFill>
+            <a:srgbClr val="121822"/>
+          </a:solidFill>
+          <a:ln w="9525">
+            <a:solidFill>
+              <a:srgbClr val="232C39"/>
+            </a:solidFill>
+          </a:ln>
+          <a:effectLst/>
+        </p:spPr>
+        <p:style>
+          <a:lnRef idx="1">
+            <a:schemeClr val="accent1"/>
+          </a:lnRef>
+          <a:fillRef idx="3">
+            <a:schemeClr val="accent1"/>
+          </a:fillRef>
+          <a:effectRef idx="2">
+            <a:schemeClr val="accent1"/>
+          </a:effectRef>
+          <a:fontRef idx="minor">
+            <a:schemeClr val="lt1"/>
+          </a:fontRef>
+        </p:style>
+        <p:txBody>
+          <a:bodyPr rtlCol="0" anchor="ctr"/>
+          <a:lstStyle/>
+          <a:p>
+            <a:pPr algn="ctr"/>
+          </a:p>
+        </p:txBody>
+      </p:sp>
+      <p:sp>
+        <p:nvSpPr>
+          <p:cNvPr id="28" name="TextBox 27"/>
+          <p:cNvSpPr txBox="1"/>
+          <p:nvPr/>
+        </p:nvSpPr>
+        <p:spPr>
+          <a:xfrm>
+            <a:off x="1051560" y="5029200"/>
+            <a:ext cx="2194560" cy="365760"/>
+          </a:xfrm>
+          <a:prstGeom prst="rect">
+            <a:avLst/>
+          </a:prstGeom>
+          <a:noFill/>
+        </p:spPr>
+        <p:txBody>
+          <a:bodyPr wrap="square" anchor="t">
+            <a:spAutoFit/>
+          </a:bodyPr>
+          <a:lstStyle/>
+          <a:p>
+            <a:pPr algn="l">
+              <a:lnSpc>
+                <a:spcPct val="100000"/>
+              </a:lnSpc>
+            </a:pPr>
+            <a:r>
               <a:rPr sz="1400" b="1">
                 <a:solidFill>
+                  <a:srgbClr val="FFFFFF"/>
+                </a:solidFill>
+                <a:latin typeface="Calibri"/>
+              </a:rPr>
+              <a:t>Technical Health</a:t>
+            </a:r>
+          </a:p>
+        </p:txBody>
+      </p:sp>
+      <p:sp>
+        <p:nvSpPr>
+          <p:cNvPr id="29" name="TextBox 28"/>
+          <p:cNvSpPr txBox="1"/>
+          <p:nvPr/>
+        </p:nvSpPr>
+        <p:spPr>
+          <a:xfrm>
+            <a:off x="3154679" y="5029200"/>
+            <a:ext cx="914400" cy="365760"/>
+          </a:xfrm>
+          <a:prstGeom prst="rect">
+            <a:avLst/>
+          </a:prstGeom>
+          <a:noFill/>
+        </p:spPr>
+        <p:txBody>
+          <a:bodyPr wrap="square" anchor="t">
+            <a:spAutoFit/>
+          </a:bodyPr>
+          <a:lstStyle/>
+          <a:p>
+            <a:pPr algn="r">
+              <a:lnSpc>
+                <a:spcPct val="100000"/>
+              </a:lnSpc>
+            </a:pPr>
+            <a:r>
+              <a:rPr sz="1400" b="1">
+                <a:solidFill>
                   <a:srgbClr val="4ADE80"/>
                 </a:solidFill>
                 <a:latin typeface="Calibri"/>
               </a:rPr>
-              <a:t>Now pointed at your real Google search data and a backlink program — so the climb keeps compounding.</a:t>
+              <a:t>0 → 75</a:t>
+            </a:r>
+          </a:p>
+        </p:txBody>
+      </p:sp>
+      <p:sp>
+        <p:nvSpPr>
+          <p:cNvPr id="30" name="TextBox 29"/>
+          <p:cNvSpPr txBox="1"/>
+          <p:nvPr/>
+        </p:nvSpPr>
+        <p:spPr>
+          <a:xfrm>
+            <a:off x="1051560" y="5440680"/>
+            <a:ext cx="2971800" cy="640080"/>
+          </a:xfrm>
+          <a:prstGeom prst="rect">
+            <a:avLst/>
+          </a:prstGeom>
+          <a:noFill/>
+        </p:spPr>
+        <p:txBody>
+          <a:bodyPr wrap="square" anchor="t">
+            <a:spAutoFit/>
+          </a:bodyPr>
+          <a:lstStyle/>
+          <a:p>
+            <a:pPr algn="l">
+              <a:lnSpc>
+                <a:spcPct val="110000"/>
+              </a:lnSpc>
+            </a:pPr>
+            <a:r>
+              <a:rPr sz="1150" b="0">
+                <a:solidFill>
+                  <a:srgbClr val="9AA6B4"/>
+                </a:solidFill>
+                <a:latin typeface="Calibri"/>
+              </a:rPr>
+              <a:t>Foundation built: schema, llms.txt &amp; HTTPS-canonical fixes</a:t>
+            </a:r>
+          </a:p>
+        </p:txBody>
+      </p:sp>
+      <p:sp>
+        <p:nvSpPr>
+          <p:cNvPr id="31" name="Rounded Rectangle 30"/>
+          <p:cNvSpPr/>
+          <p:nvPr/>
+        </p:nvSpPr>
+        <p:spPr>
+          <a:xfrm>
+            <a:off x="4434840" y="4892040"/>
+            <a:ext cx="3383280" cy="1234440"/>
+          </a:xfrm>
+          <a:prstGeom prst="roundRect">
+            <a:avLst/>
+          </a:prstGeom>
+          <a:solidFill>
+            <a:srgbClr val="121822"/>
+          </a:solidFill>
+          <a:ln w="9525">
+            <a:solidFill>
+              <a:srgbClr val="232C39"/>
+            </a:solidFill>
+          </a:ln>
+          <a:effectLst/>
+        </p:spPr>
+        <p:style>
+          <a:lnRef idx="1">
+            <a:schemeClr val="accent1"/>
+          </a:lnRef>
+          <a:fillRef idx="3">
+            <a:schemeClr val="accent1"/>
+          </a:fillRef>
+          <a:effectRef idx="2">
+            <a:schemeClr val="accent1"/>
+          </a:effectRef>
+          <a:fontRef idx="minor">
+            <a:schemeClr val="lt1"/>
+          </a:fontRef>
+        </p:style>
+        <p:txBody>
+          <a:bodyPr rtlCol="0" anchor="ctr"/>
+          <a:lstStyle/>
+          <a:p>
+            <a:pPr algn="ctr"/>
+          </a:p>
+        </p:txBody>
+      </p:sp>
+      <p:sp>
+        <p:nvSpPr>
+          <p:cNvPr id="32" name="TextBox 31"/>
+          <p:cNvSpPr txBox="1"/>
+          <p:nvPr/>
+        </p:nvSpPr>
+        <p:spPr>
+          <a:xfrm>
+            <a:off x="4663440" y="5029200"/>
+            <a:ext cx="2194560" cy="365760"/>
+          </a:xfrm>
+          <a:prstGeom prst="rect">
+            <a:avLst/>
+          </a:prstGeom>
+          <a:noFill/>
+        </p:spPr>
+        <p:txBody>
+          <a:bodyPr wrap="square" anchor="t">
+            <a:spAutoFit/>
+          </a:bodyPr>
+          <a:lstStyle/>
+          <a:p>
+            <a:pPr algn="l">
+              <a:lnSpc>
+                <a:spcPct val="100000"/>
+              </a:lnSpc>
+            </a:pPr>
+            <a:r>
+              <a:rPr sz="1400" b="1">
+                <a:solidFill>
+                  <a:srgbClr val="FFFFFF"/>
+                </a:solidFill>
+                <a:latin typeface="Calibri"/>
+              </a:rPr>
+              <a:t>Content Velocity</a:t>
+            </a:r>
+          </a:p>
+        </p:txBody>
+      </p:sp>
+      <p:sp>
+        <p:nvSpPr>
+          <p:cNvPr id="33" name="TextBox 32"/>
+          <p:cNvSpPr txBox="1"/>
+          <p:nvPr/>
+        </p:nvSpPr>
+        <p:spPr>
+          <a:xfrm>
+            <a:off x="6766560" y="5029200"/>
+            <a:ext cx="914400" cy="365760"/>
+          </a:xfrm>
+          <a:prstGeom prst="rect">
+            <a:avLst/>
+          </a:prstGeom>
+          <a:noFill/>
+        </p:spPr>
+        <p:txBody>
+          <a:bodyPr wrap="square" anchor="t">
+            <a:spAutoFit/>
+          </a:bodyPr>
+          <a:lstStyle/>
+          <a:p>
+            <a:pPr algn="r">
+              <a:lnSpc>
+                <a:spcPct val="100000"/>
+              </a:lnSpc>
+            </a:pPr>
+            <a:r>
+              <a:rPr sz="1400" b="1">
+                <a:solidFill>
+                  <a:srgbClr val="4ADE80"/>
+                </a:solidFill>
+                <a:latin typeface="Calibri"/>
+              </a:rPr>
+              <a:t>30 → 80</a:t>
+            </a:r>
+          </a:p>
+        </p:txBody>
+      </p:sp>
+      <p:sp>
+        <p:nvSpPr>
+          <p:cNvPr id="34" name="TextBox 33"/>
+          <p:cNvSpPr txBox="1"/>
+          <p:nvPr/>
+        </p:nvSpPr>
+        <p:spPr>
+          <a:xfrm>
+            <a:off x="4663440" y="5440680"/>
+            <a:ext cx="2971800" cy="640080"/>
+          </a:xfrm>
+          <a:prstGeom prst="rect">
+            <a:avLst/>
+          </a:prstGeom>
+          <a:noFill/>
+        </p:spPr>
+        <p:txBody>
+          <a:bodyPr wrap="square" anchor="t">
+            <a:spAutoFit/>
+          </a:bodyPr>
+          <a:lstStyle/>
+          <a:p>
+            <a:pPr algn="l">
+              <a:lnSpc>
+                <a:spcPct val="110000"/>
+              </a:lnSpc>
+            </a:pPr>
+            <a:r>
+              <a:rPr sz="1150" b="0">
+                <a:solidFill>
+                  <a:srgbClr val="9AA6B4"/>
+                </a:solidFill>
+                <a:latin typeface="Calibri"/>
+              </a:rPr>
+              <a:t>Service &amp; location landing pages + fresh content</a:t>
+            </a:r>
+          </a:p>
+        </p:txBody>
+      </p:sp>
+      <p:sp>
+        <p:nvSpPr>
+          <p:cNvPr id="35" name="Rounded Rectangle 34"/>
+          <p:cNvSpPr/>
+          <p:nvPr/>
+        </p:nvSpPr>
+        <p:spPr>
+          <a:xfrm>
+            <a:off x="8046720" y="4892040"/>
+            <a:ext cx="3383280" cy="1234440"/>
+          </a:xfrm>
+          <a:prstGeom prst="roundRect">
+            <a:avLst/>
+          </a:prstGeom>
+          <a:solidFill>
+            <a:srgbClr val="121822"/>
+          </a:solidFill>
+          <a:ln w="9525">
+            <a:solidFill>
+              <a:srgbClr val="232C39"/>
+            </a:solidFill>
+          </a:ln>
+          <a:effectLst/>
+        </p:spPr>
+        <p:style>
+          <a:lnRef idx="1">
+            <a:schemeClr val="accent1"/>
+          </a:lnRef>
+          <a:fillRef idx="3">
+            <a:schemeClr val="accent1"/>
+          </a:fillRef>
+          <a:effectRef idx="2">
+            <a:schemeClr val="accent1"/>
+          </a:effectRef>
+          <a:fontRef idx="minor">
+            <a:schemeClr val="lt1"/>
+          </a:fontRef>
+        </p:style>
+        <p:txBody>
+          <a:bodyPr rtlCol="0" anchor="ctr"/>
+          <a:lstStyle/>
+          <a:p>
+            <a:pPr algn="ctr"/>
+          </a:p>
+        </p:txBody>
+      </p:sp>
+      <p:sp>
+        <p:nvSpPr>
+          <p:cNvPr id="36" name="TextBox 35"/>
+          <p:cNvSpPr txBox="1"/>
+          <p:nvPr/>
+        </p:nvSpPr>
+        <p:spPr>
+          <a:xfrm>
+            <a:off x="8275320" y="5029200"/>
+            <a:ext cx="2194560" cy="365760"/>
+          </a:xfrm>
+          <a:prstGeom prst="rect">
+            <a:avLst/>
+          </a:prstGeom>
+          <a:noFill/>
+        </p:spPr>
+        <p:txBody>
+          <a:bodyPr wrap="square" anchor="t">
+            <a:spAutoFit/>
+          </a:bodyPr>
+          <a:lstStyle/>
+          <a:p>
+            <a:pPr algn="l">
+              <a:lnSpc>
+                <a:spcPct val="100000"/>
+              </a:lnSpc>
+            </a:pPr>
+            <a:r>
+              <a:rPr sz="1400" b="1">
+                <a:solidFill>
+                  <a:srgbClr val="FFFFFF"/>
+                </a:solidFill>
+                <a:latin typeface="Calibri"/>
+              </a:rPr>
+              <a:t>Reputation</a:t>
+            </a:r>
+          </a:p>
+        </p:txBody>
+      </p:sp>
+      <p:sp>
+        <p:nvSpPr>
+          <p:cNvPr id="37" name="TextBox 36"/>
+          <p:cNvSpPr txBox="1"/>
+          <p:nvPr/>
+        </p:nvSpPr>
+        <p:spPr>
+          <a:xfrm>
+            <a:off x="10378440" y="5029200"/>
+            <a:ext cx="914400" cy="365760"/>
+          </a:xfrm>
+          <a:prstGeom prst="rect">
+            <a:avLst/>
+          </a:prstGeom>
+          <a:noFill/>
+        </p:spPr>
+        <p:txBody>
+          <a:bodyPr wrap="square" anchor="t">
+            <a:spAutoFit/>
+          </a:bodyPr>
+          <a:lstStyle/>
+          <a:p>
+            <a:pPr algn="r">
+              <a:lnSpc>
+                <a:spcPct val="100000"/>
+              </a:lnSpc>
+            </a:pPr>
+            <a:r>
+              <a:rPr sz="1400" b="1">
+                <a:solidFill>
+                  <a:srgbClr val="4ADE80"/>
+                </a:solidFill>
+                <a:latin typeface="Calibri"/>
+              </a:rPr>
+              <a:t>56 → 81</a:t>
+            </a:r>
+          </a:p>
+        </p:txBody>
+      </p:sp>
+      <p:sp>
+        <p:nvSpPr>
+          <p:cNvPr id="38" name="TextBox 37"/>
+          <p:cNvSpPr txBox="1"/>
+          <p:nvPr/>
+        </p:nvSpPr>
+        <p:spPr>
+          <a:xfrm>
+            <a:off x="8275320" y="5440680"/>
+            <a:ext cx="2971800" cy="640080"/>
+          </a:xfrm>
+          <a:prstGeom prst="rect">
+            <a:avLst/>
+          </a:prstGeom>
+          <a:noFill/>
+        </p:spPr>
+        <p:txBody>
+          <a:bodyPr wrap="square" anchor="t">
+            <a:spAutoFit/>
+          </a:bodyPr>
+          <a:lstStyle/>
+          <a:p>
+            <a:pPr algn="l">
+              <a:lnSpc>
+                <a:spcPct val="110000"/>
+              </a:lnSpc>
+            </a:pPr>
+            <a:r>
+              <a:rPr sz="1150" b="0">
+                <a:solidFill>
+                  <a:srgbClr val="9AA6B4"/>
+                </a:solidFill>
+                <a:latin typeface="Calibri"/>
+              </a:rPr>
+              <a:t>A stronger, more active review profile</a:t>
             </a:r>
           </a:p>
         </p:txBody>

</xml_diff>

<commit_message>
deck: reputation slide -> verified 64->95 reviews; add priced 'Your Options' tiers slide (founding rate)
- Score-driver reputation line now leads with the API-verified Google reviews
  (64 -> 95, +31 real reviews at 4.8) instead of the score-formula number.
- New 'Your Options' slide: 3 tiers with reg + Founding Client price
  ($1,250/$2,000/$2,500), Most-Popular highlight, onboarding-waived/refactor-
  at-cost note. Shows pricing since the client hasn't started paying.
</commit_message>
<xml_diff>
--- a/deliverables/PracticeRank-SEO-Strategy-Paradigm-Experts.pptx
+++ b/deliverables/PracticeRank-SEO-Strategy-Paradigm-Experts.pptx
@@ -20,6 +20,7 @@
     <p:sldId id="268" r:id="rId19"/>
     <p:sldId id="269" r:id="rId20"/>
     <p:sldId id="270" r:id="rId21"/>
+    <p:sldId id="271" r:id="rId22"/>
   </p:sldIdLst>
   <p:sldSz cx="12191695" cy="6858000" type="screen4x3"/>
   <p:notesSz cx="6858000" cy="9144000"/>
@@ -7361,55 +7362,7 @@
       </p:sp>
       <p:sp>
         <p:nvSpPr>
-          <p:cNvPr id="4" name="Oval 3"/>
-          <p:cNvSpPr/>
-          <p:nvPr/>
-        </p:nvSpPr>
-        <p:spPr>
-          <a:xfrm>
-            <a:off x="8503920" y="3749039"/>
-            <a:ext cx="6400800" cy="6400800"/>
-          </a:xfrm>
-          <a:prstGeom prst="ellipse">
-            <a:avLst/>
-          </a:prstGeom>
-          <a:solidFill>
-            <a:srgbClr val="4ADE80">
-              <a:alpha val="12000"/>
-            </a:srgbClr>
-          </a:solidFill>
-          <a:ln>
-            <a:noFill/>
-          </a:ln>
-          <a:effectLst>
-            <a:softEdge rad="1645920"/>
-          </a:effectLst>
-        </p:spPr>
-        <p:style>
-          <a:lnRef idx="1">
-            <a:schemeClr val="accent1"/>
-          </a:lnRef>
-          <a:fillRef idx="3">
-            <a:schemeClr val="accent1"/>
-          </a:fillRef>
-          <a:effectRef idx="2">
-            <a:schemeClr val="accent1"/>
-          </a:effectRef>
-          <a:fontRef idx="minor">
-            <a:schemeClr val="lt1"/>
-          </a:fontRef>
-        </p:style>
-        <p:txBody>
-          <a:bodyPr rtlCol="0" anchor="ctr"/>
-          <a:lstStyle/>
-          <a:p>
-            <a:pPr algn="ctr"/>
-          </a:p>
-        </p:txBody>
-      </p:sp>
-      <p:sp>
-        <p:nvSpPr>
-          <p:cNvPr id="5" name="Rectangle 4"/>
+          <p:cNvPr id="4" name="Rectangle 3"/>
           <p:cNvSpPr/>
           <p:nvPr/>
         </p:nvSpPr>
@@ -7453,14 +7406,58 @@
       </p:sp>
       <p:sp>
         <p:nvSpPr>
+          <p:cNvPr id="5" name="Rectangle 4"/>
+          <p:cNvSpPr/>
+          <p:nvPr/>
+        </p:nvSpPr>
+        <p:spPr>
+          <a:xfrm>
+            <a:off x="658368" y="566928"/>
+            <a:ext cx="201168" cy="201168"/>
+          </a:xfrm>
+          <a:prstGeom prst="rect">
+            <a:avLst/>
+          </a:prstGeom>
+          <a:solidFill>
+            <a:srgbClr val="4ADE80"/>
+          </a:solidFill>
+          <a:ln>
+            <a:noFill/>
+          </a:ln>
+          <a:effectLst/>
+        </p:spPr>
+        <p:style>
+          <a:lnRef idx="1">
+            <a:schemeClr val="accent1"/>
+          </a:lnRef>
+          <a:fillRef idx="3">
+            <a:schemeClr val="accent1"/>
+          </a:fillRef>
+          <a:effectRef idx="2">
+            <a:schemeClr val="accent1"/>
+          </a:effectRef>
+          <a:fontRef idx="minor">
+            <a:schemeClr val="lt1"/>
+          </a:fontRef>
+        </p:style>
+        <p:txBody>
+          <a:bodyPr rtlCol="0" anchor="ctr"/>
+          <a:lstStyle/>
+          <a:p>
+            <a:pPr algn="ctr"/>
+          </a:p>
+        </p:txBody>
+      </p:sp>
+      <p:sp>
+        <p:nvSpPr>
           <p:cNvPr id="6" name="TextBox 5"/>
           <p:cNvSpPr txBox="1"/>
           <p:nvPr/>
         </p:nvSpPr>
         <p:spPr>
           <a:xfrm>
-            <a:off x="640080" y="1920240"/>
-            <a:ext cx="10972800" cy="457200"/>
+            <a:off x="960120" y="502920"/>
+            <a:ext cx="10058400" cy="365760"/>
           </a:xfrm>
           <a:prstGeom prst="rect">
             <a:avLst/>
@@ -7473,33 +7470,794 @@
           </a:bodyPr>
           <a:lstStyle/>
           <a:p>
+            <a:pPr algn="l">
+              <a:lnSpc>
+                <a:spcPct val="100000"/>
+              </a:lnSpc>
+            </a:pPr>
+            <a:r>
+              <a:rPr sz="1300" b="1">
+                <a:solidFill>
+                  <a:srgbClr val="4ADE80"/>
+                </a:solidFill>
+                <a:latin typeface="Calibri"/>
+              </a:rPr>
+              <a:t>YOUR OPTIONS</a:t>
+            </a:r>
+          </a:p>
+        </p:txBody>
+      </p:sp>
+      <p:sp>
+        <p:nvSpPr>
+          <p:cNvPr id="7" name="TextBox 6"/>
+          <p:cNvSpPr txBox="1"/>
+          <p:nvPr/>
+        </p:nvSpPr>
+        <p:spPr>
+          <a:xfrm>
+            <a:off x="621792" y="896112"/>
+            <a:ext cx="10972800" cy="914400"/>
+          </a:xfrm>
+          <a:prstGeom prst="rect">
+            <a:avLst/>
+          </a:prstGeom>
+          <a:noFill/>
+        </p:spPr>
+        <p:txBody>
+          <a:bodyPr wrap="square" anchor="t">
+            <a:spAutoFit/>
+          </a:bodyPr>
+          <a:lstStyle/>
+          <a:p>
+            <a:pPr algn="l">
+              <a:lnSpc>
+                <a:spcPct val="100000"/>
+              </a:lnSpc>
+            </a:pPr>
+            <a:r>
+              <a:rPr sz="3200" b="1">
+                <a:solidFill>
+                  <a:srgbClr val="FFFFFF"/>
+                </a:solidFill>
+                <a:latin typeface="Calibri"/>
+              </a:rPr>
+              <a:t>Three Ways to Grow</a:t>
+            </a:r>
+          </a:p>
+        </p:txBody>
+      </p:sp>
+      <p:sp>
+        <p:nvSpPr>
+          <p:cNvPr id="8" name="Rectangle 7"/>
+          <p:cNvSpPr/>
+          <p:nvPr/>
+        </p:nvSpPr>
+        <p:spPr>
+          <a:xfrm>
+            <a:off x="676656" y="1627632"/>
+            <a:ext cx="731520" cy="50292"/>
+          </a:xfrm>
+          <a:prstGeom prst="rect">
+            <a:avLst/>
+          </a:prstGeom>
+          <a:solidFill>
+            <a:srgbClr val="4ADE80"/>
+          </a:solidFill>
+          <a:ln>
+            <a:noFill/>
+          </a:ln>
+          <a:effectLst/>
+        </p:spPr>
+        <p:style>
+          <a:lnRef idx="1">
+            <a:schemeClr val="accent1"/>
+          </a:lnRef>
+          <a:fillRef idx="3">
+            <a:schemeClr val="accent1"/>
+          </a:fillRef>
+          <a:effectRef idx="2">
+            <a:schemeClr val="accent1"/>
+          </a:effectRef>
+          <a:fontRef idx="minor">
+            <a:schemeClr val="lt1"/>
+          </a:fontRef>
+        </p:style>
+        <p:txBody>
+          <a:bodyPr rtlCol="0" anchor="ctr"/>
+          <a:lstStyle/>
+          <a:p>
+            <a:pPr algn="ctr"/>
+          </a:p>
+        </p:txBody>
+      </p:sp>
+      <p:pic>
+        <p:nvPicPr>
+          <p:cNvPr id="9" name="Picture 8" descr="practicerank-logo-360.png"/>
+          <p:cNvPicPr>
+            <a:picLocks noChangeAspect="1"/>
+          </p:cNvPicPr>
+          <p:nvPr/>
+        </p:nvPicPr>
+        <p:blipFill>
+          <a:blip r:embed="rId2"/>
+          <a:stretch>
+            <a:fillRect/>
+          </a:stretch>
+        </p:blipFill>
+        <p:spPr>
+          <a:xfrm>
+            <a:off x="640080" y="6419088"/>
+            <a:ext cx="237744" cy="237744"/>
+          </a:xfrm>
+          <a:prstGeom prst="rect">
+            <a:avLst/>
+          </a:prstGeom>
+        </p:spPr>
+      </p:pic>
+      <p:sp>
+        <p:nvSpPr>
+          <p:cNvPr id="10" name="TextBox 9"/>
+          <p:cNvSpPr txBox="1"/>
+          <p:nvPr/>
+        </p:nvSpPr>
+        <p:spPr>
+          <a:xfrm>
+            <a:off x="960120" y="6400800"/>
+            <a:ext cx="3657600" cy="274320"/>
+          </a:xfrm>
+          <a:prstGeom prst="rect">
+            <a:avLst/>
+          </a:prstGeom>
+          <a:noFill/>
+        </p:spPr>
+        <p:txBody>
+          <a:bodyPr wrap="square" anchor="ctr">
+            <a:spAutoFit/>
+          </a:bodyPr>
+          <a:lstStyle/>
+          <a:p>
+            <a:pPr algn="l">
+              <a:lnSpc>
+                <a:spcPct val="100000"/>
+              </a:lnSpc>
+            </a:pPr>
+            <a:r>
+              <a:rPr sz="900" b="0">
+                <a:solidFill>
+                  <a:srgbClr val="5E6A79"/>
+                </a:solidFill>
+                <a:latin typeface="Calibri"/>
+              </a:rPr>
+              <a:t>practicerank.ai</a:t>
+            </a:r>
+          </a:p>
+        </p:txBody>
+      </p:sp>
+      <p:sp>
+        <p:nvSpPr>
+          <p:cNvPr id="11" name="TextBox 10"/>
+          <p:cNvSpPr txBox="1"/>
+          <p:nvPr/>
+        </p:nvSpPr>
+        <p:spPr>
+          <a:xfrm>
+            <a:off x="10561320" y="6400800"/>
+            <a:ext cx="1005840" cy="274320"/>
+          </a:xfrm>
+          <a:prstGeom prst="rect">
+            <a:avLst/>
+          </a:prstGeom>
+          <a:noFill/>
+        </p:spPr>
+        <p:txBody>
+          <a:bodyPr wrap="square" anchor="ctr">
+            <a:spAutoFit/>
+          </a:bodyPr>
+          <a:lstStyle/>
+          <a:p>
+            <a:pPr algn="r">
+              <a:lnSpc>
+                <a:spcPct val="100000"/>
+              </a:lnSpc>
+            </a:pPr>
+            <a:r>
+              <a:rPr sz="900" b="0">
+                <a:solidFill>
+                  <a:srgbClr val="5E6A79"/>
+                </a:solidFill>
+                <a:latin typeface="Calibri"/>
+              </a:rPr>
+              <a:t>14</a:t>
+            </a:r>
+          </a:p>
+        </p:txBody>
+      </p:sp>
+      <p:sp>
+        <p:nvSpPr>
+          <p:cNvPr id="12" name="Rounded Rectangle 11"/>
+          <p:cNvSpPr/>
+          <p:nvPr/>
+        </p:nvSpPr>
+        <p:spPr>
+          <a:xfrm>
+            <a:off x="640080" y="2011680"/>
+            <a:ext cx="3474720" cy="3886200"/>
+          </a:xfrm>
+          <a:prstGeom prst="roundRect">
+            <a:avLst/>
+          </a:prstGeom>
+          <a:solidFill>
+            <a:srgbClr val="121822"/>
+          </a:solidFill>
+          <a:ln w="9525">
+            <a:solidFill>
+              <a:srgbClr val="232C39"/>
+            </a:solidFill>
+          </a:ln>
+          <a:effectLst/>
+        </p:spPr>
+        <p:style>
+          <a:lnRef idx="1">
+            <a:schemeClr val="accent1"/>
+          </a:lnRef>
+          <a:fillRef idx="3">
+            <a:schemeClr val="accent1"/>
+          </a:fillRef>
+          <a:effectRef idx="2">
+            <a:schemeClr val="accent1"/>
+          </a:effectRef>
+          <a:fontRef idx="minor">
+            <a:schemeClr val="lt1"/>
+          </a:fontRef>
+        </p:style>
+        <p:txBody>
+          <a:bodyPr rtlCol="0" anchor="ctr"/>
+          <a:lstStyle/>
+          <a:p>
+            <a:pPr algn="ctr"/>
+          </a:p>
+        </p:txBody>
+      </p:sp>
+      <p:sp>
+        <p:nvSpPr>
+          <p:cNvPr id="13" name="TextBox 12"/>
+          <p:cNvSpPr txBox="1"/>
+          <p:nvPr/>
+        </p:nvSpPr>
+        <p:spPr>
+          <a:xfrm>
+            <a:off x="914400" y="2212848"/>
+            <a:ext cx="2926080" cy="411480"/>
+          </a:xfrm>
+          <a:prstGeom prst="rect">
+            <a:avLst/>
+          </a:prstGeom>
+          <a:noFill/>
+        </p:spPr>
+        <p:txBody>
+          <a:bodyPr wrap="square" anchor="t">
+            <a:spAutoFit/>
+          </a:bodyPr>
+          <a:lstStyle/>
+          <a:p>
+            <a:pPr algn="l">
+              <a:lnSpc>
+                <a:spcPct val="100000"/>
+              </a:lnSpc>
+            </a:pPr>
+            <a:r>
+              <a:rPr sz="1900" b="1">
+                <a:solidFill>
+                  <a:srgbClr val="FFFFFF"/>
+                </a:solidFill>
+                <a:latin typeface="Calibri"/>
+              </a:rPr>
+              <a:t>Optimize</a:t>
+            </a:r>
+          </a:p>
+        </p:txBody>
+      </p:sp>
+      <p:sp>
+        <p:nvSpPr>
+          <p:cNvPr id="14" name="TextBox 13"/>
+          <p:cNvSpPr txBox="1"/>
+          <p:nvPr/>
+        </p:nvSpPr>
+        <p:spPr>
+          <a:xfrm>
+            <a:off x="914400" y="2624328"/>
+            <a:ext cx="2926080" cy="292608"/>
+          </a:xfrm>
+          <a:prstGeom prst="rect">
+            <a:avLst/>
+          </a:prstGeom>
+          <a:noFill/>
+        </p:spPr>
+        <p:txBody>
+          <a:bodyPr wrap="square" anchor="t">
+            <a:spAutoFit/>
+          </a:bodyPr>
+          <a:lstStyle/>
+          <a:p>
+            <a:pPr algn="l">
+              <a:lnSpc>
+                <a:spcPct val="100000"/>
+              </a:lnSpc>
+            </a:pPr>
+            <a:r>
+              <a:rPr sz="1200" b="1">
+                <a:solidFill>
+                  <a:srgbClr val="4ADE80"/>
+                </a:solidFill>
+                <a:latin typeface="Calibri"/>
+              </a:rPr>
+              <a:t>The Foundation</a:t>
+            </a:r>
+          </a:p>
+        </p:txBody>
+      </p:sp>
+      <p:sp>
+        <p:nvSpPr>
+          <p:cNvPr id="15" name="TextBox 14"/>
+          <p:cNvSpPr txBox="1"/>
+          <p:nvPr/>
+        </p:nvSpPr>
+        <p:spPr>
+          <a:xfrm>
+            <a:off x="914400" y="2962656"/>
+            <a:ext cx="2926080" cy="256032"/>
+          </a:xfrm>
+          <a:prstGeom prst="rect">
+            <a:avLst/>
+          </a:prstGeom>
+          <a:noFill/>
+        </p:spPr>
+        <p:txBody>
+          <a:bodyPr wrap="square" anchor="t">
+            <a:spAutoFit/>
+          </a:bodyPr>
+          <a:lstStyle/>
+          <a:p>
+            <a:pPr algn="l">
+              <a:lnSpc>
+                <a:spcPct val="100000"/>
+              </a:lnSpc>
+            </a:pPr>
+            <a:r>
+              <a:rPr sz="1100" b="0">
+                <a:solidFill>
+                  <a:srgbClr val="5E6A79"/>
+                </a:solidFill>
+                <a:latin typeface="Calibri"/>
+              </a:rPr>
+              <a:t>reg. $1,500/mo</a:t>
+            </a:r>
+          </a:p>
+        </p:txBody>
+      </p:sp>
+      <p:sp>
+        <p:nvSpPr>
+          <p:cNvPr id="16" name="TextBox 15"/>
+          <p:cNvSpPr txBox="1"/>
+          <p:nvPr/>
+        </p:nvSpPr>
+        <p:spPr>
+          <a:xfrm>
+            <a:off x="914400" y="3200400"/>
+            <a:ext cx="2926080" cy="548640"/>
+          </a:xfrm>
+          <a:prstGeom prst="rect">
+            <a:avLst/>
+          </a:prstGeom>
+          <a:noFill/>
+        </p:spPr>
+        <p:txBody>
+          <a:bodyPr wrap="square" anchor="t">
+            <a:spAutoFit/>
+          </a:bodyPr>
+          <a:lstStyle/>
+          <a:p>
+            <a:pPr algn="l">
+              <a:lnSpc>
+                <a:spcPct val="100000"/>
+              </a:lnSpc>
+            </a:pPr>
+            <a:r>
+              <a:rPr sz="2900" b="1">
+                <a:solidFill>
+                  <a:srgbClr val="4ADE80"/>
+                </a:solidFill>
+                <a:latin typeface="Calibri"/>
+              </a:rPr>
+              <a:t>$1,250</a:t>
+            </a:r>
+            <a:r>
+              <a:rPr sz="1400" b="0">
+                <a:solidFill>
+                  <a:srgbClr val="9AA6B4"/>
+                </a:solidFill>
+                <a:latin typeface="Calibri"/>
+              </a:rPr>
+              <a:t>/mo</a:t>
+            </a:r>
+          </a:p>
+        </p:txBody>
+      </p:sp>
+      <p:sp>
+        <p:nvSpPr>
+          <p:cNvPr id="17" name="TextBox 16"/>
+          <p:cNvSpPr txBox="1"/>
+          <p:nvPr/>
+        </p:nvSpPr>
+        <p:spPr>
+          <a:xfrm>
+            <a:off x="914400" y="3931920"/>
+            <a:ext cx="3017520" cy="4572000"/>
+          </a:xfrm>
+          <a:prstGeom prst="rect">
+            <a:avLst/>
+          </a:prstGeom>
+          <a:noFill/>
+        </p:spPr>
+        <p:txBody>
+          <a:bodyPr wrap="square">
+            <a:spAutoFit/>
+          </a:bodyPr>
+          <a:lstStyle/>
+          <a:p>
+            <a:pPr>
+              <a:lnSpc>
+                <a:spcPct val="110000"/>
+              </a:lnSpc>
+              <a:spcAft>
+                <a:spcPts val="1000"/>
+              </a:spcAft>
+            </a:pPr>
+            <a:r>
+              <a:rPr b="1" sz="1050">
+                <a:solidFill>
+                  <a:srgbClr val="4ADE80"/>
+                </a:solidFill>
+              </a:rPr>
+              <a:t>✓  </a:t>
+            </a:r>
+            <a:r>
+              <a:rPr sz="1050">
+                <a:solidFill>
+                  <a:srgbClr val="FFFFFF"/>
+                </a:solidFill>
+                <a:latin typeface="Calibri"/>
+              </a:rPr>
+              <a:t>Keep your current site</a:t>
+            </a:r>
+          </a:p>
+          <a:p>
+            <a:pPr>
+              <a:lnSpc>
+                <a:spcPct val="110000"/>
+              </a:lnSpc>
+              <a:spcAft>
+                <a:spcPts val="1000"/>
+              </a:spcAft>
+            </a:pPr>
+            <a:r>
+              <a:rPr b="1" sz="1050">
+                <a:solidFill>
+                  <a:srgbClr val="4ADE80"/>
+                </a:solidFill>
+              </a:rPr>
+              <a:t>✓  </a:t>
+            </a:r>
+            <a:r>
+              <a:rPr sz="1050">
+                <a:solidFill>
+                  <a:srgbClr val="FFFFFF"/>
+                </a:solidFill>
+                <a:latin typeface="Calibri"/>
+              </a:rPr>
+              <a:t>Local SEO + AI-search foundation</a:t>
+            </a:r>
+          </a:p>
+          <a:p>
+            <a:pPr>
+              <a:lnSpc>
+                <a:spcPct val="110000"/>
+              </a:lnSpc>
+              <a:spcAft>
+                <a:spcPts val="1000"/>
+              </a:spcAft>
+            </a:pPr>
+            <a:r>
+              <a:rPr b="1" sz="1050">
+                <a:solidFill>
+                  <a:srgbClr val="4ADE80"/>
+                </a:solidFill>
+              </a:rPr>
+              <a:t>✓  </a:t>
+            </a:r>
+            <a:r>
+              <a:rPr sz="1050">
+                <a:solidFill>
+                  <a:srgbClr val="FFFFFF"/>
+                </a:solidFill>
+                <a:latin typeface="Calibri"/>
+              </a:rPr>
+              <a:t>100 citations + Google Business Profile</a:t>
+            </a:r>
+          </a:p>
+          <a:p>
+            <a:pPr>
+              <a:lnSpc>
+                <a:spcPct val="110000"/>
+              </a:lnSpc>
+              <a:spcAft>
+                <a:spcPts val="1000"/>
+              </a:spcAft>
+            </a:pPr>
+            <a:r>
+              <a:rPr b="1" sz="1050">
+                <a:solidFill>
+                  <a:srgbClr val="4ADE80"/>
+                </a:solidFill>
+              </a:rPr>
+              <a:t>✓  </a:t>
+            </a:r>
+            <a:r>
+              <a:rPr sz="1050">
+                <a:solidFill>
+                  <a:srgbClr val="FFFFFF"/>
+                </a:solidFill>
+                <a:latin typeface="Calibri"/>
+              </a:rPr>
+              <a:t>2 content + 1 backlink / mo</a:t>
+            </a:r>
+          </a:p>
+          <a:p>
+            <a:pPr>
+              <a:lnSpc>
+                <a:spcPct val="110000"/>
+              </a:lnSpc>
+              <a:spcAft>
+                <a:spcPts val="1000"/>
+              </a:spcAft>
+            </a:pPr>
+            <a:r>
+              <a:rPr b="1" sz="1050">
+                <a:solidFill>
+                  <a:srgbClr val="4ADE80"/>
+                </a:solidFill>
+              </a:rPr>
+              <a:t>✓  </a:t>
+            </a:r>
+            <a:r>
+              <a:rPr sz="1050">
+                <a:solidFill>
+                  <a:srgbClr val="FFFFFF"/>
+                </a:solidFill>
+                <a:latin typeface="Calibri"/>
+              </a:rPr>
+              <a:t>Review funnel + monthly report</a:t>
+            </a:r>
+          </a:p>
+        </p:txBody>
+      </p:sp>
+      <p:sp>
+        <p:nvSpPr>
+          <p:cNvPr id="18" name="Rounded Rectangle 17"/>
+          <p:cNvSpPr/>
+          <p:nvPr/>
+        </p:nvSpPr>
+        <p:spPr>
+          <a:xfrm>
+            <a:off x="4389120" y="2011680"/>
+            <a:ext cx="3474720" cy="3886200"/>
+          </a:xfrm>
+          <a:prstGeom prst="roundRect">
+            <a:avLst/>
+          </a:prstGeom>
+          <a:solidFill>
+            <a:srgbClr val="16213E"/>
+          </a:solidFill>
+          <a:ln w="12700">
+            <a:solidFill>
+              <a:srgbClr val="4ADE80"/>
+            </a:solidFill>
+          </a:ln>
+          <a:effectLst/>
+        </p:spPr>
+        <p:style>
+          <a:lnRef idx="1">
+            <a:schemeClr val="accent1"/>
+          </a:lnRef>
+          <a:fillRef idx="3">
+            <a:schemeClr val="accent1"/>
+          </a:fillRef>
+          <a:effectRef idx="2">
+            <a:schemeClr val="accent1"/>
+          </a:effectRef>
+          <a:fontRef idx="minor">
+            <a:schemeClr val="lt1"/>
+          </a:fontRef>
+        </p:style>
+        <p:txBody>
+          <a:bodyPr rtlCol="0" anchor="ctr"/>
+          <a:lstStyle/>
+          <a:p>
+            <a:pPr algn="ctr"/>
+          </a:p>
+        </p:txBody>
+      </p:sp>
+      <p:sp>
+        <p:nvSpPr>
+          <p:cNvPr id="19" name="Rounded Rectangle 18"/>
+          <p:cNvSpPr/>
+          <p:nvPr/>
+        </p:nvSpPr>
+        <p:spPr>
+          <a:xfrm>
+            <a:off x="5349240" y="1847088"/>
+            <a:ext cx="1554480" cy="365760"/>
+          </a:xfrm>
+          <a:prstGeom prst="roundRect">
+            <a:avLst/>
+          </a:prstGeom>
+          <a:solidFill>
+            <a:srgbClr val="4ADE80"/>
+          </a:solidFill>
+          <a:ln>
+            <a:noFill/>
+          </a:ln>
+          <a:effectLst/>
+        </p:spPr>
+        <p:style>
+          <a:lnRef idx="1">
+            <a:schemeClr val="accent1"/>
+          </a:lnRef>
+          <a:fillRef idx="3">
+            <a:schemeClr val="accent1"/>
+          </a:fillRef>
+          <a:effectRef idx="2">
+            <a:schemeClr val="accent1"/>
+          </a:effectRef>
+          <a:fontRef idx="minor">
+            <a:schemeClr val="lt1"/>
+          </a:fontRef>
+        </p:style>
+        <p:txBody>
+          <a:bodyPr rtlCol="0" anchor="ctr"/>
+          <a:lstStyle/>
+          <a:p>
+            <a:pPr algn="ctr"/>
+          </a:p>
+        </p:txBody>
+      </p:sp>
+      <p:sp>
+        <p:nvSpPr>
+          <p:cNvPr id="20" name="TextBox 19"/>
+          <p:cNvSpPr txBox="1"/>
+          <p:nvPr/>
+        </p:nvSpPr>
+        <p:spPr>
+          <a:xfrm>
+            <a:off x="5349240" y="1856231"/>
+            <a:ext cx="1554480" cy="347472"/>
+          </a:xfrm>
+          <a:prstGeom prst="rect">
+            <a:avLst/>
+          </a:prstGeom>
+          <a:noFill/>
+        </p:spPr>
+        <p:txBody>
+          <a:bodyPr wrap="square" anchor="ctr">
+            <a:spAutoFit/>
+          </a:bodyPr>
+          <a:lstStyle/>
+          <a:p>
             <a:pPr algn="ctr">
               <a:lnSpc>
                 <a:spcPct val="100000"/>
               </a:lnSpc>
             </a:pPr>
             <a:r>
-              <a:rPr sz="1500" b="1">
+              <a:rPr sz="900" b="1">
+                <a:solidFill>
+                  <a:srgbClr val="04210F"/>
+                </a:solidFill>
+                <a:latin typeface="Calibri"/>
+              </a:rPr>
+              <a:t>MOST POPULAR</a:t>
+            </a:r>
+          </a:p>
+        </p:txBody>
+      </p:sp>
+      <p:sp>
+        <p:nvSpPr>
+          <p:cNvPr id="21" name="TextBox 20"/>
+          <p:cNvSpPr txBox="1"/>
+          <p:nvPr/>
+        </p:nvSpPr>
+        <p:spPr>
+          <a:xfrm>
+            <a:off x="4663440" y="2212848"/>
+            <a:ext cx="2926080" cy="411480"/>
+          </a:xfrm>
+          <a:prstGeom prst="rect">
+            <a:avLst/>
+          </a:prstGeom>
+          <a:noFill/>
+        </p:spPr>
+        <p:txBody>
+          <a:bodyPr wrap="square" anchor="t">
+            <a:spAutoFit/>
+          </a:bodyPr>
+          <a:lstStyle/>
+          <a:p>
+            <a:pPr algn="l">
+              <a:lnSpc>
+                <a:spcPct val="100000"/>
+              </a:lnSpc>
+            </a:pPr>
+            <a:r>
+              <a:rPr sz="1900" b="1">
+                <a:solidFill>
+                  <a:srgbClr val="FFFFFF"/>
+                </a:solidFill>
+                <a:latin typeface="Calibri"/>
+              </a:rPr>
+              <a:t>Grow</a:t>
+            </a:r>
+          </a:p>
+        </p:txBody>
+      </p:sp>
+      <p:sp>
+        <p:nvSpPr>
+          <p:cNvPr id="22" name="TextBox 21"/>
+          <p:cNvSpPr txBox="1"/>
+          <p:nvPr/>
+        </p:nvSpPr>
+        <p:spPr>
+          <a:xfrm>
+            <a:off x="4663440" y="2624328"/>
+            <a:ext cx="2926080" cy="292608"/>
+          </a:xfrm>
+          <a:prstGeom prst="rect">
+            <a:avLst/>
+          </a:prstGeom>
+          <a:noFill/>
+        </p:spPr>
+        <p:txBody>
+          <a:bodyPr wrap="square" anchor="t">
+            <a:spAutoFit/>
+          </a:bodyPr>
+          <a:lstStyle/>
+          <a:p>
+            <a:pPr algn="l">
+              <a:lnSpc>
+                <a:spcPct val="100000"/>
+              </a:lnSpc>
+            </a:pPr>
+            <a:r>
+              <a:rPr sz="1200" b="1">
                 <a:solidFill>
                   <a:srgbClr val="4ADE80"/>
                 </a:solidFill>
                 <a:latin typeface="Calibri"/>
               </a:rPr>
-              <a:t>OUR PROMISE</a:t>
-            </a:r>
-          </a:p>
-        </p:txBody>
-      </p:sp>
-      <p:sp>
-        <p:nvSpPr>
-          <p:cNvPr id="7" name="TextBox 6"/>
-          <p:cNvSpPr txBox="1"/>
-          <p:nvPr/>
-        </p:nvSpPr>
-        <p:spPr>
-          <a:xfrm>
-            <a:off x="914400" y="2468880"/>
-            <a:ext cx="10332720" cy="1097280"/>
+              <a:t>The Growth Engine</a:t>
+            </a:r>
+          </a:p>
+        </p:txBody>
+      </p:sp>
+      <p:sp>
+        <p:nvSpPr>
+          <p:cNvPr id="23" name="TextBox 22"/>
+          <p:cNvSpPr txBox="1"/>
+          <p:nvPr/>
+        </p:nvSpPr>
+        <p:spPr>
+          <a:xfrm>
+            <a:off x="4663440" y="2962656"/>
+            <a:ext cx="2926080" cy="256032"/>
           </a:xfrm>
           <a:prstGeom prst="rect">
             <a:avLst/>
@@ -7512,58 +8270,579 @@
           </a:bodyPr>
           <a:lstStyle/>
           <a:p>
+            <a:pPr algn="l">
+              <a:lnSpc>
+                <a:spcPct val="100000"/>
+              </a:lnSpc>
+            </a:pPr>
+            <a:r>
+              <a:rPr sz="1100" b="0">
+                <a:solidFill>
+                  <a:srgbClr val="5E6A79"/>
+                </a:solidFill>
+                <a:latin typeface="Calibri"/>
+              </a:rPr>
+              <a:t>reg. $2,500/mo</a:t>
+            </a:r>
+          </a:p>
+        </p:txBody>
+      </p:sp>
+      <p:sp>
+        <p:nvSpPr>
+          <p:cNvPr id="24" name="TextBox 23"/>
+          <p:cNvSpPr txBox="1"/>
+          <p:nvPr/>
+        </p:nvSpPr>
+        <p:spPr>
+          <a:xfrm>
+            <a:off x="4663440" y="3200400"/>
+            <a:ext cx="2926080" cy="548640"/>
+          </a:xfrm>
+          <a:prstGeom prst="rect">
+            <a:avLst/>
+          </a:prstGeom>
+          <a:noFill/>
+        </p:spPr>
+        <p:txBody>
+          <a:bodyPr wrap="square" anchor="t">
+            <a:spAutoFit/>
+          </a:bodyPr>
+          <a:lstStyle/>
+          <a:p>
+            <a:pPr algn="l">
+              <a:lnSpc>
+                <a:spcPct val="100000"/>
+              </a:lnSpc>
+            </a:pPr>
+            <a:r>
+              <a:rPr sz="2900" b="1">
+                <a:solidFill>
+                  <a:srgbClr val="4ADE80"/>
+                </a:solidFill>
+                <a:latin typeface="Calibri"/>
+              </a:rPr>
+              <a:t>$2,000</a:t>
+            </a:r>
+            <a:r>
+              <a:rPr sz="1400" b="0">
+                <a:solidFill>
+                  <a:srgbClr val="9AA6B4"/>
+                </a:solidFill>
+                <a:latin typeface="Calibri"/>
+              </a:rPr>
+              <a:t>/mo</a:t>
+            </a:r>
+          </a:p>
+        </p:txBody>
+      </p:sp>
+      <p:sp>
+        <p:nvSpPr>
+          <p:cNvPr id="25" name="TextBox 24"/>
+          <p:cNvSpPr txBox="1"/>
+          <p:nvPr/>
+        </p:nvSpPr>
+        <p:spPr>
+          <a:xfrm>
+            <a:off x="4663440" y="3931920"/>
+            <a:ext cx="3017520" cy="4572000"/>
+          </a:xfrm>
+          <a:prstGeom prst="rect">
+            <a:avLst/>
+          </a:prstGeom>
+          <a:noFill/>
+        </p:spPr>
+        <p:txBody>
+          <a:bodyPr wrap="square">
+            <a:spAutoFit/>
+          </a:bodyPr>
+          <a:lstStyle/>
+          <a:p>
+            <a:pPr>
+              <a:lnSpc>
+                <a:spcPct val="110000"/>
+              </a:lnSpc>
+              <a:spcAft>
+                <a:spcPts val="1000"/>
+              </a:spcAft>
+            </a:pPr>
+            <a:r>
+              <a:rPr b="1" sz="1050">
+                <a:solidFill>
+                  <a:srgbClr val="4ADE80"/>
+                </a:solidFill>
+              </a:rPr>
+              <a:t>✓  </a:t>
+            </a:r>
+            <a:r>
+              <a:rPr sz="1050">
+                <a:solidFill>
+                  <a:srgbClr val="FFFFFF"/>
+                </a:solidFill>
+                <a:latin typeface="Calibri"/>
+              </a:rPr>
+              <a:t>Everything in Optimize, plus:</a:t>
+            </a:r>
+          </a:p>
+          <a:p>
+            <a:pPr>
+              <a:lnSpc>
+                <a:spcPct val="110000"/>
+              </a:lnSpc>
+              <a:spcAft>
+                <a:spcPts val="1000"/>
+              </a:spcAft>
+            </a:pPr>
+            <a:r>
+              <a:rPr b="1" sz="1050">
+                <a:solidFill>
+                  <a:srgbClr val="4ADE80"/>
+                </a:solidFill>
+              </a:rPr>
+              <a:t>✓  </a:t>
+            </a:r>
+            <a:r>
+              <a:rPr sz="1050">
+                <a:solidFill>
+                  <a:srgbClr val="FFFFFF"/>
+                </a:solidFill>
+                <a:latin typeface="Calibri"/>
+              </a:rPr>
+              <a:t>Migrated, fast managed site</a:t>
+            </a:r>
+          </a:p>
+          <a:p>
+            <a:pPr>
+              <a:lnSpc>
+                <a:spcPct val="110000"/>
+              </a:lnSpc>
+              <a:spcAft>
+                <a:spcPts val="1000"/>
+              </a:spcAft>
+            </a:pPr>
+            <a:r>
+              <a:rPr b="1" sz="1050">
+                <a:solidFill>
+                  <a:srgbClr val="4ADE80"/>
+                </a:solidFill>
+              </a:rPr>
+              <a:t>✓  </a:t>
+            </a:r>
+            <a:r>
+              <a:rPr sz="1050">
+                <a:solidFill>
+                  <a:srgbClr val="FFFFFF"/>
+                </a:solidFill>
+                <a:latin typeface="Calibri"/>
+              </a:rPr>
+              <a:t>4 content + 2 backlinks / mo</a:t>
+            </a:r>
+          </a:p>
+          <a:p>
+            <a:pPr>
+              <a:lnSpc>
+                <a:spcPct val="110000"/>
+              </a:lnSpc>
+              <a:spcAft>
+                <a:spcPts val="1000"/>
+              </a:spcAft>
+            </a:pPr>
+            <a:r>
+              <a:rPr b="1" sz="1050">
+                <a:solidFill>
+                  <a:srgbClr val="4ADE80"/>
+                </a:solidFill>
+              </a:rPr>
+              <a:t>✓  </a:t>
+            </a:r>
+            <a:r>
+              <a:rPr sz="1050">
+                <a:solidFill>
+                  <a:srgbClr val="FFFFFF"/>
+                </a:solidFill>
+                <a:latin typeface="Calibri"/>
+              </a:rPr>
+              <a:t>Location pages + keyword tracking</a:t>
+            </a:r>
+          </a:p>
+        </p:txBody>
+      </p:sp>
+      <p:sp>
+        <p:nvSpPr>
+          <p:cNvPr id="26" name="Rounded Rectangle 25"/>
+          <p:cNvSpPr/>
+          <p:nvPr/>
+        </p:nvSpPr>
+        <p:spPr>
+          <a:xfrm>
+            <a:off x="8138159" y="2011680"/>
+            <a:ext cx="3474720" cy="3886200"/>
+          </a:xfrm>
+          <a:prstGeom prst="roundRect">
+            <a:avLst/>
+          </a:prstGeom>
+          <a:solidFill>
+            <a:srgbClr val="121822"/>
+          </a:solidFill>
+          <a:ln w="9525">
+            <a:solidFill>
+              <a:srgbClr val="232C39"/>
+            </a:solidFill>
+          </a:ln>
+          <a:effectLst/>
+        </p:spPr>
+        <p:style>
+          <a:lnRef idx="1">
+            <a:schemeClr val="accent1"/>
+          </a:lnRef>
+          <a:fillRef idx="3">
+            <a:schemeClr val="accent1"/>
+          </a:fillRef>
+          <a:effectRef idx="2">
+            <a:schemeClr val="accent1"/>
+          </a:effectRef>
+          <a:fontRef idx="minor">
+            <a:schemeClr val="lt1"/>
+          </a:fontRef>
+        </p:style>
+        <p:txBody>
+          <a:bodyPr rtlCol="0" anchor="ctr"/>
+          <a:lstStyle/>
+          <a:p>
+            <a:pPr algn="ctr"/>
+          </a:p>
+        </p:txBody>
+      </p:sp>
+      <p:sp>
+        <p:nvSpPr>
+          <p:cNvPr id="27" name="TextBox 26"/>
+          <p:cNvSpPr txBox="1"/>
+          <p:nvPr/>
+        </p:nvSpPr>
+        <p:spPr>
+          <a:xfrm>
+            <a:off x="8412480" y="2212848"/>
+            <a:ext cx="2926080" cy="411480"/>
+          </a:xfrm>
+          <a:prstGeom prst="rect">
+            <a:avLst/>
+          </a:prstGeom>
+          <a:noFill/>
+        </p:spPr>
+        <p:txBody>
+          <a:bodyPr wrap="square" anchor="t">
+            <a:spAutoFit/>
+          </a:bodyPr>
+          <a:lstStyle/>
+          <a:p>
+            <a:pPr algn="l">
+              <a:lnSpc>
+                <a:spcPct val="100000"/>
+              </a:lnSpc>
+            </a:pPr>
+            <a:r>
+              <a:rPr sz="1900" b="1">
+                <a:solidFill>
+                  <a:srgbClr val="FFFFFF"/>
+                </a:solidFill>
+                <a:latin typeface="Calibri"/>
+              </a:rPr>
+              <a:t>Dominate</a:t>
+            </a:r>
+          </a:p>
+        </p:txBody>
+      </p:sp>
+      <p:sp>
+        <p:nvSpPr>
+          <p:cNvPr id="28" name="TextBox 27"/>
+          <p:cNvSpPr txBox="1"/>
+          <p:nvPr/>
+        </p:nvSpPr>
+        <p:spPr>
+          <a:xfrm>
+            <a:off x="8412480" y="2624328"/>
+            <a:ext cx="2926080" cy="292608"/>
+          </a:xfrm>
+          <a:prstGeom prst="rect">
+            <a:avLst/>
+          </a:prstGeom>
+          <a:noFill/>
+        </p:spPr>
+        <p:txBody>
+          <a:bodyPr wrap="square" anchor="t">
+            <a:spAutoFit/>
+          </a:bodyPr>
+          <a:lstStyle/>
+          <a:p>
+            <a:pPr algn="l">
+              <a:lnSpc>
+                <a:spcPct val="100000"/>
+              </a:lnSpc>
+            </a:pPr>
+            <a:r>
+              <a:rPr sz="1200" b="1">
+                <a:solidFill>
+                  <a:srgbClr val="4ADE80"/>
+                </a:solidFill>
+                <a:latin typeface="Calibri"/>
+              </a:rPr>
+              <a:t>Market Domination</a:t>
+            </a:r>
+          </a:p>
+        </p:txBody>
+      </p:sp>
+      <p:sp>
+        <p:nvSpPr>
+          <p:cNvPr id="29" name="TextBox 28"/>
+          <p:cNvSpPr txBox="1"/>
+          <p:nvPr/>
+        </p:nvSpPr>
+        <p:spPr>
+          <a:xfrm>
+            <a:off x="8412480" y="2962656"/>
+            <a:ext cx="2926080" cy="256032"/>
+          </a:xfrm>
+          <a:prstGeom prst="rect">
+            <a:avLst/>
+          </a:prstGeom>
+          <a:noFill/>
+        </p:spPr>
+        <p:txBody>
+          <a:bodyPr wrap="square" anchor="t">
+            <a:spAutoFit/>
+          </a:bodyPr>
+          <a:lstStyle/>
+          <a:p>
+            <a:pPr algn="l">
+              <a:lnSpc>
+                <a:spcPct val="100000"/>
+              </a:lnSpc>
+            </a:pPr>
+            <a:r>
+              <a:rPr sz="1100" b="0">
+                <a:solidFill>
+                  <a:srgbClr val="5E6A79"/>
+                </a:solidFill>
+                <a:latin typeface="Calibri"/>
+              </a:rPr>
+              <a:t>reg. $3,500/mo</a:t>
+            </a:r>
+          </a:p>
+        </p:txBody>
+      </p:sp>
+      <p:sp>
+        <p:nvSpPr>
+          <p:cNvPr id="30" name="TextBox 29"/>
+          <p:cNvSpPr txBox="1"/>
+          <p:nvPr/>
+        </p:nvSpPr>
+        <p:spPr>
+          <a:xfrm>
+            <a:off x="8412480" y="3200400"/>
+            <a:ext cx="2926080" cy="548640"/>
+          </a:xfrm>
+          <a:prstGeom prst="rect">
+            <a:avLst/>
+          </a:prstGeom>
+          <a:noFill/>
+        </p:spPr>
+        <p:txBody>
+          <a:bodyPr wrap="square" anchor="t">
+            <a:spAutoFit/>
+          </a:bodyPr>
+          <a:lstStyle/>
+          <a:p>
+            <a:pPr algn="l">
+              <a:lnSpc>
+                <a:spcPct val="100000"/>
+              </a:lnSpc>
+            </a:pPr>
+            <a:r>
+              <a:rPr sz="2900" b="1">
+                <a:solidFill>
+                  <a:srgbClr val="4ADE80"/>
+                </a:solidFill>
+                <a:latin typeface="Calibri"/>
+              </a:rPr>
+              <a:t>$2,500</a:t>
+            </a:r>
+            <a:r>
+              <a:rPr sz="1400" b="0">
+                <a:solidFill>
+                  <a:srgbClr val="9AA6B4"/>
+                </a:solidFill>
+                <a:latin typeface="Calibri"/>
+              </a:rPr>
+              <a:t>/mo</a:t>
+            </a:r>
+          </a:p>
+        </p:txBody>
+      </p:sp>
+      <p:sp>
+        <p:nvSpPr>
+          <p:cNvPr id="31" name="TextBox 30"/>
+          <p:cNvSpPr txBox="1"/>
+          <p:nvPr/>
+        </p:nvSpPr>
+        <p:spPr>
+          <a:xfrm>
+            <a:off x="8412480" y="3931920"/>
+            <a:ext cx="3017520" cy="4572000"/>
+          </a:xfrm>
+          <a:prstGeom prst="rect">
+            <a:avLst/>
+          </a:prstGeom>
+          <a:noFill/>
+        </p:spPr>
+        <p:txBody>
+          <a:bodyPr wrap="square">
+            <a:spAutoFit/>
+          </a:bodyPr>
+          <a:lstStyle/>
+          <a:p>
+            <a:pPr>
+              <a:lnSpc>
+                <a:spcPct val="110000"/>
+              </a:lnSpc>
+              <a:spcAft>
+                <a:spcPts val="1000"/>
+              </a:spcAft>
+            </a:pPr>
+            <a:r>
+              <a:rPr b="1" sz="1050">
+                <a:solidFill>
+                  <a:srgbClr val="4ADE80"/>
+                </a:solidFill>
+              </a:rPr>
+              <a:t>✓  </a:t>
+            </a:r>
+            <a:r>
+              <a:rPr sz="1050">
+                <a:solidFill>
+                  <a:srgbClr val="FFFFFF"/>
+                </a:solidFill>
+                <a:latin typeface="Calibri"/>
+              </a:rPr>
+              <a:t>Everything in Grow, plus:</a:t>
+            </a:r>
+          </a:p>
+          <a:p>
+            <a:pPr>
+              <a:lnSpc>
+                <a:spcPct val="110000"/>
+              </a:lnSpc>
+              <a:spcAft>
+                <a:spcPts val="1000"/>
+              </a:spcAft>
+            </a:pPr>
+            <a:r>
+              <a:rPr b="1" sz="1050">
+                <a:solidFill>
+                  <a:srgbClr val="4ADE80"/>
+                </a:solidFill>
+              </a:rPr>
+              <a:t>✓  </a:t>
+            </a:r>
+            <a:r>
+              <a:rPr sz="1050">
+                <a:solidFill>
+                  <a:srgbClr val="FFFFFF"/>
+                </a:solidFill>
+                <a:latin typeface="Calibri"/>
+              </a:rPr>
+              <a:t>Pro website redesign</a:t>
+            </a:r>
+          </a:p>
+          <a:p>
+            <a:pPr>
+              <a:lnSpc>
+                <a:spcPct val="110000"/>
+              </a:lnSpc>
+              <a:spcAft>
+                <a:spcPts val="1000"/>
+              </a:spcAft>
+            </a:pPr>
+            <a:r>
+              <a:rPr b="1" sz="1050">
+                <a:solidFill>
+                  <a:srgbClr val="4ADE80"/>
+                </a:solidFill>
+              </a:rPr>
+              <a:t>✓  </a:t>
+            </a:r>
+            <a:r>
+              <a:rPr sz="1050">
+                <a:solidFill>
+                  <a:srgbClr val="FFFFFF"/>
+                </a:solidFill>
+                <a:latin typeface="Calibri"/>
+              </a:rPr>
+              <a:t>6–8 content + 4 backlinks / mo</a:t>
+            </a:r>
+          </a:p>
+          <a:p>
+            <a:pPr>
+              <a:lnSpc>
+                <a:spcPct val="110000"/>
+              </a:lnSpc>
+              <a:spcAft>
+                <a:spcPts val="1000"/>
+              </a:spcAft>
+            </a:pPr>
+            <a:r>
+              <a:rPr b="1" sz="1050">
+                <a:solidFill>
+                  <a:srgbClr val="4ADE80"/>
+                </a:solidFill>
+              </a:rPr>
+              <a:t>✓  </a:t>
+            </a:r>
+            <a:r>
+              <a:rPr sz="1050">
+                <a:solidFill>
+                  <a:srgbClr val="FFFFFF"/>
+                </a:solidFill>
+                <a:latin typeface="Calibri"/>
+              </a:rPr>
+              <a:t>Advanced AI/entity building + CRO</a:t>
+            </a:r>
+          </a:p>
+        </p:txBody>
+      </p:sp>
+      <p:sp>
+        <p:nvSpPr>
+          <p:cNvPr id="32" name="TextBox 31"/>
+          <p:cNvSpPr txBox="1"/>
+          <p:nvPr/>
+        </p:nvSpPr>
+        <p:spPr>
+          <a:xfrm>
+            <a:off x="658368" y="6053328"/>
+            <a:ext cx="10881360" cy="411480"/>
+          </a:xfrm>
+          <a:prstGeom prst="rect">
+            <a:avLst/>
+          </a:prstGeom>
+          <a:noFill/>
+        </p:spPr>
+        <p:txBody>
+          <a:bodyPr wrap="square" anchor="t">
+            <a:spAutoFit/>
+          </a:bodyPr>
+          <a:lstStyle/>
+          <a:p>
             <a:pPr algn="ctr">
               <a:lnSpc>
                 <a:spcPct val="100000"/>
               </a:lnSpc>
             </a:pPr>
             <a:r>
-              <a:rPr sz="3400" b="1">
-                <a:solidFill>
-                  <a:srgbClr val="FFFFFF"/>
-                </a:solidFill>
-                <a:latin typeface="Calibri"/>
-              </a:rPr>
-              <a:t>The 90-Day Results-or-Refund Guarantee</a:t>
-            </a:r>
-          </a:p>
-        </p:txBody>
-      </p:sp>
-      <p:sp>
-        <p:nvSpPr>
-          <p:cNvPr id="8" name="TextBox 7"/>
-          <p:cNvSpPr txBox="1"/>
-          <p:nvPr/>
-        </p:nvSpPr>
-        <p:spPr>
-          <a:xfrm>
-            <a:off x="1371600" y="3749039"/>
-            <a:ext cx="9418320" cy="1280160"/>
-          </a:xfrm>
-          <a:prstGeom prst="rect">
-            <a:avLst/>
-          </a:prstGeom>
-          <a:noFill/>
-        </p:spPr>
-        <p:txBody>
-          <a:bodyPr wrap="square" anchor="t">
-            <a:spAutoFit/>
-          </a:bodyPr>
-          <a:lstStyle/>
-          <a:p>
-            <a:pPr algn="ctr">
-              <a:lnSpc>
-                <a:spcPct val="125000"/>
-              </a:lnSpc>
-            </a:pPr>
-            <a:r>
-              <a:rPr sz="1800" b="0">
-                <a:solidFill>
-                  <a:srgbClr val="9AA6B4"/>
-                </a:solidFill>
-                <a:latin typeface="Calibri"/>
-              </a:rPr>
-              <a:t>If your PracticeRank Score doesn't improve by 20+ points in 90 days, we refund your monthly fees — and you keep everything we built. Month-to-month. No long-term contracts.</a:t>
+              <a:rPr sz="1200" b="1">
+                <a:solidFill>
+                  <a:srgbClr val="4ADE80"/>
+                </a:solidFill>
+                <a:latin typeface="Calibri"/>
+              </a:rPr>
+              <a:t>Founding Client rate — your first-customer pricing.  ·  Onboarding waived  ·  Website refactor billed at our exact cost.</a:t>
             </a:r>
           </a:p>
         </p:txBody>
@@ -7770,6 +9049,325 @@
           </a:p>
         </p:txBody>
       </p:sp>
+      <p:sp>
+        <p:nvSpPr>
+          <p:cNvPr id="6" name="TextBox 5"/>
+          <p:cNvSpPr txBox="1"/>
+          <p:nvPr/>
+        </p:nvSpPr>
+        <p:spPr>
+          <a:xfrm>
+            <a:off x="640080" y="1920240"/>
+            <a:ext cx="10972800" cy="457200"/>
+          </a:xfrm>
+          <a:prstGeom prst="rect">
+            <a:avLst/>
+          </a:prstGeom>
+          <a:noFill/>
+        </p:spPr>
+        <p:txBody>
+          <a:bodyPr wrap="square" anchor="t">
+            <a:spAutoFit/>
+          </a:bodyPr>
+          <a:lstStyle/>
+          <a:p>
+            <a:pPr algn="ctr">
+              <a:lnSpc>
+                <a:spcPct val="100000"/>
+              </a:lnSpc>
+            </a:pPr>
+            <a:r>
+              <a:rPr sz="1500" b="1">
+                <a:solidFill>
+                  <a:srgbClr val="4ADE80"/>
+                </a:solidFill>
+                <a:latin typeface="Calibri"/>
+              </a:rPr>
+              <a:t>OUR PROMISE</a:t>
+            </a:r>
+          </a:p>
+        </p:txBody>
+      </p:sp>
+      <p:sp>
+        <p:nvSpPr>
+          <p:cNvPr id="7" name="TextBox 6"/>
+          <p:cNvSpPr txBox="1"/>
+          <p:nvPr/>
+        </p:nvSpPr>
+        <p:spPr>
+          <a:xfrm>
+            <a:off x="914400" y="2468880"/>
+            <a:ext cx="10332720" cy="1097280"/>
+          </a:xfrm>
+          <a:prstGeom prst="rect">
+            <a:avLst/>
+          </a:prstGeom>
+          <a:noFill/>
+        </p:spPr>
+        <p:txBody>
+          <a:bodyPr wrap="square" anchor="t">
+            <a:spAutoFit/>
+          </a:bodyPr>
+          <a:lstStyle/>
+          <a:p>
+            <a:pPr algn="ctr">
+              <a:lnSpc>
+                <a:spcPct val="100000"/>
+              </a:lnSpc>
+            </a:pPr>
+            <a:r>
+              <a:rPr sz="3400" b="1">
+                <a:solidFill>
+                  <a:srgbClr val="FFFFFF"/>
+                </a:solidFill>
+                <a:latin typeface="Calibri"/>
+              </a:rPr>
+              <a:t>The 90-Day Results-or-Refund Guarantee</a:t>
+            </a:r>
+          </a:p>
+        </p:txBody>
+      </p:sp>
+      <p:sp>
+        <p:nvSpPr>
+          <p:cNvPr id="8" name="TextBox 7"/>
+          <p:cNvSpPr txBox="1"/>
+          <p:nvPr/>
+        </p:nvSpPr>
+        <p:spPr>
+          <a:xfrm>
+            <a:off x="1371600" y="3749039"/>
+            <a:ext cx="9418320" cy="1280160"/>
+          </a:xfrm>
+          <a:prstGeom prst="rect">
+            <a:avLst/>
+          </a:prstGeom>
+          <a:noFill/>
+        </p:spPr>
+        <p:txBody>
+          <a:bodyPr wrap="square" anchor="t">
+            <a:spAutoFit/>
+          </a:bodyPr>
+          <a:lstStyle/>
+          <a:p>
+            <a:pPr algn="ctr">
+              <a:lnSpc>
+                <a:spcPct val="125000"/>
+              </a:lnSpc>
+            </a:pPr>
+            <a:r>
+              <a:rPr sz="1800" b="0">
+                <a:solidFill>
+                  <a:srgbClr val="9AA6B4"/>
+                </a:solidFill>
+                <a:latin typeface="Calibri"/>
+              </a:rPr>
+              <a:t>If your PracticeRank Score doesn't improve by 20+ points in 90 days, we refund your monthly fees — and you keep everything we built. Month-to-month. No long-term contracts.</a:t>
+            </a:r>
+          </a:p>
+        </p:txBody>
+      </p:sp>
+    </p:spTree>
+  </p:cSld>
+  <p:clrMapOvr>
+    <a:masterClrMapping/>
+  </p:clrMapOvr>
+</p:sld>
+</file>
+
+<file path=ppt/slides/slide16.xml><?xml version="1.0" encoding="utf-8"?>
+<p:sld xmlns:a="http://schemas.openxmlformats.org/drawingml/2006/main" xmlns:p="http://schemas.openxmlformats.org/presentationml/2006/main" xmlns:r="http://schemas.openxmlformats.org/officeDocument/2006/relationships">
+  <p:cSld>
+    <p:spTree>
+      <p:nvGrpSpPr>
+        <p:cNvPr id="1" name=""/>
+        <p:cNvGrpSpPr/>
+        <p:nvPr/>
+      </p:nvGrpSpPr>
+      <p:grpSpPr/>
+      <p:sp>
+        <p:nvSpPr>
+          <p:cNvPr id="2" name="Rectangle 1"/>
+          <p:cNvSpPr/>
+          <p:nvPr/>
+        </p:nvSpPr>
+        <p:spPr>
+          <a:xfrm>
+            <a:off x="0" y="0"/>
+            <a:ext cx="12191695" cy="6858000"/>
+          </a:xfrm>
+          <a:prstGeom prst="rect">
+            <a:avLst/>
+          </a:prstGeom>
+          <a:solidFill>
+            <a:srgbClr val="08080D"/>
+          </a:solidFill>
+          <a:ln>
+            <a:noFill/>
+          </a:ln>
+          <a:effectLst/>
+        </p:spPr>
+        <p:style>
+          <a:lnRef idx="1">
+            <a:schemeClr val="accent1"/>
+          </a:lnRef>
+          <a:fillRef idx="3">
+            <a:schemeClr val="accent1"/>
+          </a:fillRef>
+          <a:effectRef idx="2">
+            <a:schemeClr val="accent1"/>
+          </a:effectRef>
+          <a:fontRef idx="minor">
+            <a:schemeClr val="lt1"/>
+          </a:fontRef>
+        </p:style>
+        <p:txBody>
+          <a:bodyPr rtlCol="0" anchor="ctr"/>
+          <a:lstStyle/>
+          <a:p>
+            <a:pPr algn="ctr"/>
+          </a:p>
+        </p:txBody>
+      </p:sp>
+      <p:sp>
+        <p:nvSpPr>
+          <p:cNvPr id="3" name="Oval 2"/>
+          <p:cNvSpPr/>
+          <p:nvPr/>
+        </p:nvSpPr>
+        <p:spPr>
+          <a:xfrm>
+            <a:off x="-758952" y="-4251960"/>
+            <a:ext cx="13716000" cy="5943600"/>
+          </a:xfrm>
+          <a:prstGeom prst="ellipse">
+            <a:avLst/>
+          </a:prstGeom>
+          <a:solidFill>
+            <a:srgbClr val="16213E">
+              <a:alpha val="46000"/>
+            </a:srgbClr>
+          </a:solidFill>
+          <a:ln>
+            <a:noFill/>
+          </a:ln>
+          <a:effectLst>
+            <a:softEdge rad="1463040"/>
+          </a:effectLst>
+        </p:spPr>
+        <p:style>
+          <a:lnRef idx="1">
+            <a:schemeClr val="accent1"/>
+          </a:lnRef>
+          <a:fillRef idx="3">
+            <a:schemeClr val="accent1"/>
+          </a:fillRef>
+          <a:effectRef idx="2">
+            <a:schemeClr val="accent1"/>
+          </a:effectRef>
+          <a:fontRef idx="minor">
+            <a:schemeClr val="lt1"/>
+          </a:fontRef>
+        </p:style>
+        <p:txBody>
+          <a:bodyPr rtlCol="0" anchor="ctr"/>
+          <a:lstStyle/>
+          <a:p>
+            <a:pPr algn="ctr"/>
+          </a:p>
+        </p:txBody>
+      </p:sp>
+      <p:sp>
+        <p:nvSpPr>
+          <p:cNvPr id="4" name="Oval 3"/>
+          <p:cNvSpPr/>
+          <p:nvPr/>
+        </p:nvSpPr>
+        <p:spPr>
+          <a:xfrm>
+            <a:off x="8503920" y="3749039"/>
+            <a:ext cx="6400800" cy="6400800"/>
+          </a:xfrm>
+          <a:prstGeom prst="ellipse">
+            <a:avLst/>
+          </a:prstGeom>
+          <a:solidFill>
+            <a:srgbClr val="4ADE80">
+              <a:alpha val="12000"/>
+            </a:srgbClr>
+          </a:solidFill>
+          <a:ln>
+            <a:noFill/>
+          </a:ln>
+          <a:effectLst>
+            <a:softEdge rad="1645920"/>
+          </a:effectLst>
+        </p:spPr>
+        <p:style>
+          <a:lnRef idx="1">
+            <a:schemeClr val="accent1"/>
+          </a:lnRef>
+          <a:fillRef idx="3">
+            <a:schemeClr val="accent1"/>
+          </a:fillRef>
+          <a:effectRef idx="2">
+            <a:schemeClr val="accent1"/>
+          </a:effectRef>
+          <a:fontRef idx="minor">
+            <a:schemeClr val="lt1"/>
+          </a:fontRef>
+        </p:style>
+        <p:txBody>
+          <a:bodyPr rtlCol="0" anchor="ctr"/>
+          <a:lstStyle/>
+          <a:p>
+            <a:pPr algn="ctr"/>
+          </a:p>
+        </p:txBody>
+      </p:sp>
+      <p:sp>
+        <p:nvSpPr>
+          <p:cNvPr id="5" name="Rectangle 4"/>
+          <p:cNvSpPr/>
+          <p:nvPr/>
+        </p:nvSpPr>
+        <p:spPr>
+          <a:xfrm>
+            <a:off x="0" y="0"/>
+            <a:ext cx="12191695" cy="109728"/>
+          </a:xfrm>
+          <a:prstGeom prst="rect">
+            <a:avLst/>
+          </a:prstGeom>
+          <a:solidFill>
+            <a:srgbClr val="4ADE80"/>
+          </a:solidFill>
+          <a:ln>
+            <a:noFill/>
+          </a:ln>
+          <a:effectLst/>
+        </p:spPr>
+        <p:style>
+          <a:lnRef idx="1">
+            <a:schemeClr val="accent1"/>
+          </a:lnRef>
+          <a:fillRef idx="3">
+            <a:schemeClr val="accent1"/>
+          </a:fillRef>
+          <a:effectRef idx="2">
+            <a:schemeClr val="accent1"/>
+          </a:effectRef>
+          <a:fontRef idx="minor">
+            <a:schemeClr val="lt1"/>
+          </a:fontRef>
+        </p:style>
+        <p:txBody>
+          <a:bodyPr rtlCol="0" anchor="ctr"/>
+          <a:lstStyle/>
+          <a:p>
+            <a:pPr algn="ctr"/>
+          </a:p>
+        </p:txBody>
+      </p:sp>
       <p:pic>
         <p:nvPicPr>
           <p:cNvPr id="6" name="Picture 5" descr="practicerank-logo-360.png"/>
@@ -16769,7 +18367,7 @@
                 </a:solidFill>
                 <a:latin typeface="Calibri"/>
               </a:rPr>
-              <a:t>Reputation</a:t>
+              <a:t>Google Reviews</a:t>
             </a:r>
           </a:p>
         </p:txBody>
@@ -16808,7 +18406,7 @@
                 </a:solidFill>
                 <a:latin typeface="Calibri"/>
               </a:rPr>
-              <a:t>56 → 81</a:t>
+              <a:t>64 → 95</a:t>
             </a:r>
           </a:p>
         </p:txBody>
@@ -16847,7 +18445,7 @@
                 </a:solidFill>
                 <a:latin typeface="Calibri"/>
               </a:rPr>
-              <a:t>A stronger, more active review profile</a:t>
+              <a:t>+31 real new reviews, holding a strong 4.8★ rating</a:t>
             </a:r>
           </a:p>
         </p:txBody>

</xml_diff>

<commit_message>
deck+proposal: Paradigm keeps Webflow — drop migration/redesign, push Dominate (citations + comparison posts + backlinks)
- Tiers reframed for Paradigm: no website migration/redesign/managed-site
  language; Grow/Dominate lean into citations, backlinks, and 'Best in Northern
  VA' comparison placements. Dominate highlighted as RECOMMENDED (popular_tier).
- Replaced jargon 'Advanced AI/entity building + CRO' with 'Aggressive citations
  + AI authority building'.
- Proposal recommends Dominate, drops migration/redesign, frames the site work
  as Webflow improvements billed at cost.
</commit_message>
<xml_diff>
--- a/deliverables/PracticeRank-SEO-Strategy-Paradigm-Experts.pptx
+++ b/deliverables/PracticeRank-SEO-Strategy-Paradigm-Experts.pptx
@@ -7928,7 +7928,7 @@
                 </a:solidFill>
                 <a:latin typeface="Calibri"/>
               </a:rPr>
-              <a:t>Keep your current site</a:t>
+              <a:t>Keep your Webflow site — we optimize it</a:t>
             </a:r>
           </a:p>
           <a:p>
@@ -7982,7 +7982,7 @@
                 </a:solidFill>
                 <a:latin typeface="Calibri"/>
               </a:rPr>
-              <a:t>100 citations + Google Business Profile</a:t>
+              <a:t>100 local citations + Google Business Profile</a:t>
             </a:r>
           </a:p>
           <a:p>
@@ -8050,6 +8050,348 @@
         <p:spPr>
           <a:xfrm>
             <a:off x="4389120" y="2011680"/>
+            <a:ext cx="3474720" cy="3886200"/>
+          </a:xfrm>
+          <a:prstGeom prst="roundRect">
+            <a:avLst/>
+          </a:prstGeom>
+          <a:solidFill>
+            <a:srgbClr val="121822"/>
+          </a:solidFill>
+          <a:ln w="9525">
+            <a:solidFill>
+              <a:srgbClr val="232C39"/>
+            </a:solidFill>
+          </a:ln>
+          <a:effectLst/>
+        </p:spPr>
+        <p:style>
+          <a:lnRef idx="1">
+            <a:schemeClr val="accent1"/>
+          </a:lnRef>
+          <a:fillRef idx="3">
+            <a:schemeClr val="accent1"/>
+          </a:fillRef>
+          <a:effectRef idx="2">
+            <a:schemeClr val="accent1"/>
+          </a:effectRef>
+          <a:fontRef idx="minor">
+            <a:schemeClr val="lt1"/>
+          </a:fontRef>
+        </p:style>
+        <p:txBody>
+          <a:bodyPr rtlCol="0" anchor="ctr"/>
+          <a:lstStyle/>
+          <a:p>
+            <a:pPr algn="ctr"/>
+          </a:p>
+        </p:txBody>
+      </p:sp>
+      <p:sp>
+        <p:nvSpPr>
+          <p:cNvPr id="19" name="TextBox 18"/>
+          <p:cNvSpPr txBox="1"/>
+          <p:nvPr/>
+        </p:nvSpPr>
+        <p:spPr>
+          <a:xfrm>
+            <a:off x="4663440" y="2212848"/>
+            <a:ext cx="2926080" cy="411480"/>
+          </a:xfrm>
+          <a:prstGeom prst="rect">
+            <a:avLst/>
+          </a:prstGeom>
+          <a:noFill/>
+        </p:spPr>
+        <p:txBody>
+          <a:bodyPr wrap="square" anchor="t">
+            <a:spAutoFit/>
+          </a:bodyPr>
+          <a:lstStyle/>
+          <a:p>
+            <a:pPr algn="l">
+              <a:lnSpc>
+                <a:spcPct val="100000"/>
+              </a:lnSpc>
+            </a:pPr>
+            <a:r>
+              <a:rPr sz="1900" b="1">
+                <a:solidFill>
+                  <a:srgbClr val="FFFFFF"/>
+                </a:solidFill>
+                <a:latin typeface="Calibri"/>
+              </a:rPr>
+              <a:t>Grow</a:t>
+            </a:r>
+          </a:p>
+        </p:txBody>
+      </p:sp>
+      <p:sp>
+        <p:nvSpPr>
+          <p:cNvPr id="20" name="TextBox 19"/>
+          <p:cNvSpPr txBox="1"/>
+          <p:nvPr/>
+        </p:nvSpPr>
+        <p:spPr>
+          <a:xfrm>
+            <a:off x="4663440" y="2624328"/>
+            <a:ext cx="2926080" cy="292608"/>
+          </a:xfrm>
+          <a:prstGeom prst="rect">
+            <a:avLst/>
+          </a:prstGeom>
+          <a:noFill/>
+        </p:spPr>
+        <p:txBody>
+          <a:bodyPr wrap="square" anchor="t">
+            <a:spAutoFit/>
+          </a:bodyPr>
+          <a:lstStyle/>
+          <a:p>
+            <a:pPr algn="l">
+              <a:lnSpc>
+                <a:spcPct val="100000"/>
+              </a:lnSpc>
+            </a:pPr>
+            <a:r>
+              <a:rPr sz="1200" b="1">
+                <a:solidFill>
+                  <a:srgbClr val="4ADE80"/>
+                </a:solidFill>
+                <a:latin typeface="Calibri"/>
+              </a:rPr>
+              <a:t>The Growth Engine</a:t>
+            </a:r>
+          </a:p>
+        </p:txBody>
+      </p:sp>
+      <p:sp>
+        <p:nvSpPr>
+          <p:cNvPr id="21" name="TextBox 20"/>
+          <p:cNvSpPr txBox="1"/>
+          <p:nvPr/>
+        </p:nvSpPr>
+        <p:spPr>
+          <a:xfrm>
+            <a:off x="4663440" y="2962656"/>
+            <a:ext cx="2926080" cy="256032"/>
+          </a:xfrm>
+          <a:prstGeom prst="rect">
+            <a:avLst/>
+          </a:prstGeom>
+          <a:noFill/>
+        </p:spPr>
+        <p:txBody>
+          <a:bodyPr wrap="square" anchor="t">
+            <a:spAutoFit/>
+          </a:bodyPr>
+          <a:lstStyle/>
+          <a:p>
+            <a:pPr algn="l">
+              <a:lnSpc>
+                <a:spcPct val="100000"/>
+              </a:lnSpc>
+            </a:pPr>
+            <a:r>
+              <a:rPr sz="1100" b="0">
+                <a:solidFill>
+                  <a:srgbClr val="5E6A79"/>
+                </a:solidFill>
+                <a:latin typeface="Calibri"/>
+              </a:rPr>
+              <a:t>reg. $2,500/mo</a:t>
+            </a:r>
+          </a:p>
+        </p:txBody>
+      </p:sp>
+      <p:sp>
+        <p:nvSpPr>
+          <p:cNvPr id="22" name="TextBox 21"/>
+          <p:cNvSpPr txBox="1"/>
+          <p:nvPr/>
+        </p:nvSpPr>
+        <p:spPr>
+          <a:xfrm>
+            <a:off x="4663440" y="3200400"/>
+            <a:ext cx="2926080" cy="548640"/>
+          </a:xfrm>
+          <a:prstGeom prst="rect">
+            <a:avLst/>
+          </a:prstGeom>
+          <a:noFill/>
+        </p:spPr>
+        <p:txBody>
+          <a:bodyPr wrap="square" anchor="t">
+            <a:spAutoFit/>
+          </a:bodyPr>
+          <a:lstStyle/>
+          <a:p>
+            <a:pPr algn="l">
+              <a:lnSpc>
+                <a:spcPct val="100000"/>
+              </a:lnSpc>
+            </a:pPr>
+            <a:r>
+              <a:rPr sz="2900" b="1">
+                <a:solidFill>
+                  <a:srgbClr val="4ADE80"/>
+                </a:solidFill>
+                <a:latin typeface="Calibri"/>
+              </a:rPr>
+              <a:t>$2,000</a:t>
+            </a:r>
+            <a:r>
+              <a:rPr sz="1400" b="0">
+                <a:solidFill>
+                  <a:srgbClr val="9AA6B4"/>
+                </a:solidFill>
+                <a:latin typeface="Calibri"/>
+              </a:rPr>
+              <a:t>/mo</a:t>
+            </a:r>
+          </a:p>
+        </p:txBody>
+      </p:sp>
+      <p:sp>
+        <p:nvSpPr>
+          <p:cNvPr id="23" name="TextBox 22"/>
+          <p:cNvSpPr txBox="1"/>
+          <p:nvPr/>
+        </p:nvSpPr>
+        <p:spPr>
+          <a:xfrm>
+            <a:off x="4663440" y="3931920"/>
+            <a:ext cx="3017520" cy="4572000"/>
+          </a:xfrm>
+          <a:prstGeom prst="rect">
+            <a:avLst/>
+          </a:prstGeom>
+          <a:noFill/>
+        </p:spPr>
+        <p:txBody>
+          <a:bodyPr wrap="square">
+            <a:spAutoFit/>
+          </a:bodyPr>
+          <a:lstStyle/>
+          <a:p>
+            <a:pPr>
+              <a:lnSpc>
+                <a:spcPct val="110000"/>
+              </a:lnSpc>
+              <a:spcAft>
+                <a:spcPts val="1000"/>
+              </a:spcAft>
+            </a:pPr>
+            <a:r>
+              <a:rPr b="1" sz="1050">
+                <a:solidFill>
+                  <a:srgbClr val="4ADE80"/>
+                </a:solidFill>
+              </a:rPr>
+              <a:t>✓  </a:t>
+            </a:r>
+            <a:r>
+              <a:rPr sz="1050">
+                <a:solidFill>
+                  <a:srgbClr val="FFFFFF"/>
+                </a:solidFill>
+                <a:latin typeface="Calibri"/>
+              </a:rPr>
+              <a:t>Everything in Optimize, plus:</a:t>
+            </a:r>
+          </a:p>
+          <a:p>
+            <a:pPr>
+              <a:lnSpc>
+                <a:spcPct val="110000"/>
+              </a:lnSpc>
+              <a:spcAft>
+                <a:spcPts val="1000"/>
+              </a:spcAft>
+            </a:pPr>
+            <a:r>
+              <a:rPr b="1" sz="1050">
+                <a:solidFill>
+                  <a:srgbClr val="4ADE80"/>
+                </a:solidFill>
+              </a:rPr>
+              <a:t>✓  </a:t>
+            </a:r>
+            <a:r>
+              <a:rPr sz="1050">
+                <a:solidFill>
+                  <a:srgbClr val="FFFFFF"/>
+                </a:solidFill>
+                <a:latin typeface="Calibri"/>
+              </a:rPr>
+              <a:t>4 content + 2 backlinks / mo</a:t>
+            </a:r>
+          </a:p>
+          <a:p>
+            <a:pPr>
+              <a:lnSpc>
+                <a:spcPct val="110000"/>
+              </a:lnSpc>
+              <a:spcAft>
+                <a:spcPts val="1000"/>
+              </a:spcAft>
+            </a:pPr>
+            <a:r>
+              <a:rPr b="1" sz="1050">
+                <a:solidFill>
+                  <a:srgbClr val="4ADE80"/>
+                </a:solidFill>
+              </a:rPr>
+              <a:t>✓  </a:t>
+            </a:r>
+            <a:r>
+              <a:rPr sz="1050">
+                <a:solidFill>
+                  <a:srgbClr val="FFFFFF"/>
+                </a:solidFill>
+                <a:latin typeface="Calibri"/>
+              </a:rPr>
+              <a:t>Citation building + NAP cleanup</a:t>
+            </a:r>
+          </a:p>
+          <a:p>
+            <a:pPr>
+              <a:lnSpc>
+                <a:spcPct val="110000"/>
+              </a:lnSpc>
+              <a:spcAft>
+                <a:spcPts val="1000"/>
+              </a:spcAft>
+            </a:pPr>
+            <a:r>
+              <a:rPr b="1" sz="1050">
+                <a:solidFill>
+                  <a:srgbClr val="4ADE80"/>
+                </a:solidFill>
+              </a:rPr>
+              <a:t>✓  </a:t>
+            </a:r>
+            <a:r>
+              <a:rPr sz="1050">
+                <a:solidFill>
+                  <a:srgbClr val="FFFFFF"/>
+                </a:solidFill>
+                <a:latin typeface="Calibri"/>
+              </a:rPr>
+              <a:t>Local landing pages + keyword tracking</a:t>
+            </a:r>
+          </a:p>
+        </p:txBody>
+      </p:sp>
+      <p:sp>
+        <p:nvSpPr>
+          <p:cNvPr id="24" name="Rounded Rectangle 23"/>
+          <p:cNvSpPr/>
+          <p:nvPr/>
+        </p:nvSpPr>
+        <p:spPr>
+          <a:xfrm>
+            <a:off x="8138159" y="2011680"/>
             <a:ext cx="3474720" cy="3886200"/>
           </a:xfrm>
           <a:prstGeom prst="roundRect">
@@ -8089,14 +8431,14 @@
       </p:sp>
       <p:sp>
         <p:nvSpPr>
-          <p:cNvPr id="19" name="Rounded Rectangle 18"/>
+          <p:cNvPr id="25" name="Rounded Rectangle 24"/>
           <p:cNvSpPr/>
           <p:nvPr/>
         </p:nvSpPr>
         <p:spPr>
           <a:xfrm>
-            <a:off x="5349240" y="1847088"/>
-            <a:ext cx="1554480" cy="365760"/>
+            <a:off x="9189719" y="1847088"/>
+            <a:ext cx="1371600" cy="365760"/>
           </a:xfrm>
           <a:prstGeom prst="roundRect">
             <a:avLst/>
@@ -8133,14 +8475,14 @@
       </p:sp>
       <p:sp>
         <p:nvSpPr>
-          <p:cNvPr id="20" name="TextBox 19"/>
-          <p:cNvSpPr txBox="1"/>
-          <p:nvPr/>
-        </p:nvSpPr>
-        <p:spPr>
-          <a:xfrm>
-            <a:off x="5349240" y="1856231"/>
-            <a:ext cx="1554480" cy="347472"/>
+          <p:cNvPr id="26" name="TextBox 25"/>
+          <p:cNvSpPr txBox="1"/>
+          <p:nvPr/>
+        </p:nvSpPr>
+        <p:spPr>
+          <a:xfrm>
+            <a:off x="9189719" y="1856231"/>
+            <a:ext cx="1371600" cy="347472"/>
           </a:xfrm>
           <a:prstGeom prst="rect">
             <a:avLst/>
@@ -8165,20 +8507,20 @@
                 </a:solidFill>
                 <a:latin typeface="Calibri"/>
               </a:rPr>
-              <a:t>MOST POPULAR</a:t>
-            </a:r>
-          </a:p>
-        </p:txBody>
-      </p:sp>
-      <p:sp>
-        <p:nvSpPr>
-          <p:cNvPr id="21" name="TextBox 20"/>
-          <p:cNvSpPr txBox="1"/>
-          <p:nvPr/>
-        </p:nvSpPr>
-        <p:spPr>
-          <a:xfrm>
-            <a:off x="4663440" y="2212848"/>
+              <a:t>RECOMMENDED</a:t>
+            </a:r>
+          </a:p>
+        </p:txBody>
+      </p:sp>
+      <p:sp>
+        <p:nvSpPr>
+          <p:cNvPr id="27" name="TextBox 26"/>
+          <p:cNvSpPr txBox="1"/>
+          <p:nvPr/>
+        </p:nvSpPr>
+        <p:spPr>
+          <a:xfrm>
+            <a:off x="8412480" y="2212848"/>
             <a:ext cx="2926080" cy="411480"/>
           </a:xfrm>
           <a:prstGeom prst="rect">
@@ -8204,20 +8546,20 @@
                 </a:solidFill>
                 <a:latin typeface="Calibri"/>
               </a:rPr>
-              <a:t>Grow</a:t>
-            </a:r>
-          </a:p>
-        </p:txBody>
-      </p:sp>
-      <p:sp>
-        <p:nvSpPr>
-          <p:cNvPr id="22" name="TextBox 21"/>
-          <p:cNvSpPr txBox="1"/>
-          <p:nvPr/>
-        </p:nvSpPr>
-        <p:spPr>
-          <a:xfrm>
-            <a:off x="4663440" y="2624328"/>
+              <a:t>Dominate</a:t>
+            </a:r>
+          </a:p>
+        </p:txBody>
+      </p:sp>
+      <p:sp>
+        <p:nvSpPr>
+          <p:cNvPr id="28" name="TextBox 27"/>
+          <p:cNvSpPr txBox="1"/>
+          <p:nvPr/>
+        </p:nvSpPr>
+        <p:spPr>
+          <a:xfrm>
+            <a:off x="8412480" y="2624328"/>
             <a:ext cx="2926080" cy="292608"/>
           </a:xfrm>
           <a:prstGeom prst="rect">
@@ -8243,20 +8585,20 @@
                 </a:solidFill>
                 <a:latin typeface="Calibri"/>
               </a:rPr>
-              <a:t>The Growth Engine</a:t>
-            </a:r>
-          </a:p>
-        </p:txBody>
-      </p:sp>
-      <p:sp>
-        <p:nvSpPr>
-          <p:cNvPr id="23" name="TextBox 22"/>
-          <p:cNvSpPr txBox="1"/>
-          <p:nvPr/>
-        </p:nvSpPr>
-        <p:spPr>
-          <a:xfrm>
-            <a:off x="4663440" y="2962656"/>
+              <a:t>Market Domination</a:t>
+            </a:r>
+          </a:p>
+        </p:txBody>
+      </p:sp>
+      <p:sp>
+        <p:nvSpPr>
+          <p:cNvPr id="29" name="TextBox 28"/>
+          <p:cNvSpPr txBox="1"/>
+          <p:nvPr/>
+        </p:nvSpPr>
+        <p:spPr>
+          <a:xfrm>
+            <a:off x="8412480" y="2962656"/>
             <a:ext cx="2926080" cy="256032"/>
           </a:xfrm>
           <a:prstGeom prst="rect">
@@ -8282,20 +8624,20 @@
                 </a:solidFill>
                 <a:latin typeface="Calibri"/>
               </a:rPr>
-              <a:t>reg. $2,500/mo</a:t>
-            </a:r>
-          </a:p>
-        </p:txBody>
-      </p:sp>
-      <p:sp>
-        <p:nvSpPr>
-          <p:cNvPr id="24" name="TextBox 23"/>
-          <p:cNvSpPr txBox="1"/>
-          <p:nvPr/>
-        </p:nvSpPr>
-        <p:spPr>
-          <a:xfrm>
-            <a:off x="4663440" y="3200400"/>
+              <a:t>reg. $3,500/mo</a:t>
+            </a:r>
+          </a:p>
+        </p:txBody>
+      </p:sp>
+      <p:sp>
+        <p:nvSpPr>
+          <p:cNvPr id="30" name="TextBox 29"/>
+          <p:cNvSpPr txBox="1"/>
+          <p:nvPr/>
+        </p:nvSpPr>
+        <p:spPr>
+          <a:xfrm>
+            <a:off x="8412480" y="3200400"/>
             <a:ext cx="2926080" cy="548640"/>
           </a:xfrm>
           <a:prstGeom prst="rect">
@@ -8321,7 +8663,7 @@
                 </a:solidFill>
                 <a:latin typeface="Calibri"/>
               </a:rPr>
-              <a:t>$2,000</a:t>
+              <a:t>$2,500</a:t>
             </a:r>
             <a:r>
               <a:rPr sz="1400" b="0">
@@ -8337,13 +8679,13 @@
       </p:sp>
       <p:sp>
         <p:nvSpPr>
-          <p:cNvPr id="25" name="TextBox 24"/>
-          <p:cNvSpPr txBox="1"/>
-          <p:nvPr/>
-        </p:nvSpPr>
-        <p:spPr>
-          <a:xfrm>
-            <a:off x="4663440" y="3931920"/>
+          <p:cNvPr id="31" name="TextBox 30"/>
+          <p:cNvSpPr txBox="1"/>
+          <p:nvPr/>
+        </p:nvSpPr>
+        <p:spPr>
+          <a:xfrm>
+            <a:off x="8412480" y="3931920"/>
             <a:ext cx="3017520" cy="4572000"/>
           </a:xfrm>
           <a:prstGeom prst="rect">
@@ -8380,7 +8722,7 @@
                 </a:solidFill>
                 <a:latin typeface="Calibri"/>
               </a:rPr>
-              <a:t>Everything in Optimize, plus:</a:t>
+              <a:t>Everything in Grow, plus:</a:t>
             </a:r>
           </a:p>
           <a:p>
@@ -8407,7 +8749,7 @@
                 </a:solidFill>
                 <a:latin typeface="Calibri"/>
               </a:rPr>
-              <a:t>Migrated, fast managed site</a:t>
+              <a:t>4 high-authority backlinks / mo</a:t>
             </a:r>
           </a:p>
           <a:p>
@@ -8434,7 +8776,7 @@
                 </a:solidFill>
                 <a:latin typeface="Calibri"/>
               </a:rPr>
-              <a:t>4 content + 2 backlinks / mo</a:t>
+              <a:t>“Best in Northern VA” comparison placements</a:t>
             </a:r>
           </a:p>
           <a:p>
@@ -8461,349 +8803,7 @@
                 </a:solidFill>
                 <a:latin typeface="Calibri"/>
               </a:rPr>
-              <a:t>Location pages + keyword tracking</a:t>
-            </a:r>
-          </a:p>
-        </p:txBody>
-      </p:sp>
-      <p:sp>
-        <p:nvSpPr>
-          <p:cNvPr id="26" name="Rounded Rectangle 25"/>
-          <p:cNvSpPr/>
-          <p:nvPr/>
-        </p:nvSpPr>
-        <p:spPr>
-          <a:xfrm>
-            <a:off x="8138159" y="2011680"/>
-            <a:ext cx="3474720" cy="3886200"/>
-          </a:xfrm>
-          <a:prstGeom prst="roundRect">
-            <a:avLst/>
-          </a:prstGeom>
-          <a:solidFill>
-            <a:srgbClr val="121822"/>
-          </a:solidFill>
-          <a:ln w="9525">
-            <a:solidFill>
-              <a:srgbClr val="232C39"/>
-            </a:solidFill>
-          </a:ln>
-          <a:effectLst/>
-        </p:spPr>
-        <p:style>
-          <a:lnRef idx="1">
-            <a:schemeClr val="accent1"/>
-          </a:lnRef>
-          <a:fillRef idx="3">
-            <a:schemeClr val="accent1"/>
-          </a:fillRef>
-          <a:effectRef idx="2">
-            <a:schemeClr val="accent1"/>
-          </a:effectRef>
-          <a:fontRef idx="minor">
-            <a:schemeClr val="lt1"/>
-          </a:fontRef>
-        </p:style>
-        <p:txBody>
-          <a:bodyPr rtlCol="0" anchor="ctr"/>
-          <a:lstStyle/>
-          <a:p>
-            <a:pPr algn="ctr"/>
-          </a:p>
-        </p:txBody>
-      </p:sp>
-      <p:sp>
-        <p:nvSpPr>
-          <p:cNvPr id="27" name="TextBox 26"/>
-          <p:cNvSpPr txBox="1"/>
-          <p:nvPr/>
-        </p:nvSpPr>
-        <p:spPr>
-          <a:xfrm>
-            <a:off x="8412480" y="2212848"/>
-            <a:ext cx="2926080" cy="411480"/>
-          </a:xfrm>
-          <a:prstGeom prst="rect">
-            <a:avLst/>
-          </a:prstGeom>
-          <a:noFill/>
-        </p:spPr>
-        <p:txBody>
-          <a:bodyPr wrap="square" anchor="t">
-            <a:spAutoFit/>
-          </a:bodyPr>
-          <a:lstStyle/>
-          <a:p>
-            <a:pPr algn="l">
-              <a:lnSpc>
-                <a:spcPct val="100000"/>
-              </a:lnSpc>
-            </a:pPr>
-            <a:r>
-              <a:rPr sz="1900" b="1">
-                <a:solidFill>
-                  <a:srgbClr val="FFFFFF"/>
-                </a:solidFill>
-                <a:latin typeface="Calibri"/>
-              </a:rPr>
-              <a:t>Dominate</a:t>
-            </a:r>
-          </a:p>
-        </p:txBody>
-      </p:sp>
-      <p:sp>
-        <p:nvSpPr>
-          <p:cNvPr id="28" name="TextBox 27"/>
-          <p:cNvSpPr txBox="1"/>
-          <p:nvPr/>
-        </p:nvSpPr>
-        <p:spPr>
-          <a:xfrm>
-            <a:off x="8412480" y="2624328"/>
-            <a:ext cx="2926080" cy="292608"/>
-          </a:xfrm>
-          <a:prstGeom prst="rect">
-            <a:avLst/>
-          </a:prstGeom>
-          <a:noFill/>
-        </p:spPr>
-        <p:txBody>
-          <a:bodyPr wrap="square" anchor="t">
-            <a:spAutoFit/>
-          </a:bodyPr>
-          <a:lstStyle/>
-          <a:p>
-            <a:pPr algn="l">
-              <a:lnSpc>
-                <a:spcPct val="100000"/>
-              </a:lnSpc>
-            </a:pPr>
-            <a:r>
-              <a:rPr sz="1200" b="1">
-                <a:solidFill>
-                  <a:srgbClr val="4ADE80"/>
-                </a:solidFill>
-                <a:latin typeface="Calibri"/>
-              </a:rPr>
-              <a:t>Market Domination</a:t>
-            </a:r>
-          </a:p>
-        </p:txBody>
-      </p:sp>
-      <p:sp>
-        <p:nvSpPr>
-          <p:cNvPr id="29" name="TextBox 28"/>
-          <p:cNvSpPr txBox="1"/>
-          <p:nvPr/>
-        </p:nvSpPr>
-        <p:spPr>
-          <a:xfrm>
-            <a:off x="8412480" y="2962656"/>
-            <a:ext cx="2926080" cy="256032"/>
-          </a:xfrm>
-          <a:prstGeom prst="rect">
-            <a:avLst/>
-          </a:prstGeom>
-          <a:noFill/>
-        </p:spPr>
-        <p:txBody>
-          <a:bodyPr wrap="square" anchor="t">
-            <a:spAutoFit/>
-          </a:bodyPr>
-          <a:lstStyle/>
-          <a:p>
-            <a:pPr algn="l">
-              <a:lnSpc>
-                <a:spcPct val="100000"/>
-              </a:lnSpc>
-            </a:pPr>
-            <a:r>
-              <a:rPr sz="1100" b="0">
-                <a:solidFill>
-                  <a:srgbClr val="5E6A79"/>
-                </a:solidFill>
-                <a:latin typeface="Calibri"/>
-              </a:rPr>
-              <a:t>reg. $3,500/mo</a:t>
-            </a:r>
-          </a:p>
-        </p:txBody>
-      </p:sp>
-      <p:sp>
-        <p:nvSpPr>
-          <p:cNvPr id="30" name="TextBox 29"/>
-          <p:cNvSpPr txBox="1"/>
-          <p:nvPr/>
-        </p:nvSpPr>
-        <p:spPr>
-          <a:xfrm>
-            <a:off x="8412480" y="3200400"/>
-            <a:ext cx="2926080" cy="548640"/>
-          </a:xfrm>
-          <a:prstGeom prst="rect">
-            <a:avLst/>
-          </a:prstGeom>
-          <a:noFill/>
-        </p:spPr>
-        <p:txBody>
-          <a:bodyPr wrap="square" anchor="t">
-            <a:spAutoFit/>
-          </a:bodyPr>
-          <a:lstStyle/>
-          <a:p>
-            <a:pPr algn="l">
-              <a:lnSpc>
-                <a:spcPct val="100000"/>
-              </a:lnSpc>
-            </a:pPr>
-            <a:r>
-              <a:rPr sz="2900" b="1">
-                <a:solidFill>
-                  <a:srgbClr val="4ADE80"/>
-                </a:solidFill>
-                <a:latin typeface="Calibri"/>
-              </a:rPr>
-              <a:t>$2,500</a:t>
-            </a:r>
-            <a:r>
-              <a:rPr sz="1400" b="0">
-                <a:solidFill>
-                  <a:srgbClr val="9AA6B4"/>
-                </a:solidFill>
-                <a:latin typeface="Calibri"/>
-              </a:rPr>
-              <a:t>/mo</a:t>
-            </a:r>
-          </a:p>
-        </p:txBody>
-      </p:sp>
-      <p:sp>
-        <p:nvSpPr>
-          <p:cNvPr id="31" name="TextBox 30"/>
-          <p:cNvSpPr txBox="1"/>
-          <p:nvPr/>
-        </p:nvSpPr>
-        <p:spPr>
-          <a:xfrm>
-            <a:off x="8412480" y="3931920"/>
-            <a:ext cx="3017520" cy="4572000"/>
-          </a:xfrm>
-          <a:prstGeom prst="rect">
-            <a:avLst/>
-          </a:prstGeom>
-          <a:noFill/>
-        </p:spPr>
-        <p:txBody>
-          <a:bodyPr wrap="square">
-            <a:spAutoFit/>
-          </a:bodyPr>
-          <a:lstStyle/>
-          <a:p>
-            <a:pPr>
-              <a:lnSpc>
-                <a:spcPct val="110000"/>
-              </a:lnSpc>
-              <a:spcAft>
-                <a:spcPts val="1000"/>
-              </a:spcAft>
-            </a:pPr>
-            <a:r>
-              <a:rPr b="1" sz="1050">
-                <a:solidFill>
-                  <a:srgbClr val="4ADE80"/>
-                </a:solidFill>
-              </a:rPr>
-              <a:t>✓  </a:t>
-            </a:r>
-            <a:r>
-              <a:rPr sz="1050">
-                <a:solidFill>
-                  <a:srgbClr val="FFFFFF"/>
-                </a:solidFill>
-                <a:latin typeface="Calibri"/>
-              </a:rPr>
-              <a:t>Everything in Grow, plus:</a:t>
-            </a:r>
-          </a:p>
-          <a:p>
-            <a:pPr>
-              <a:lnSpc>
-                <a:spcPct val="110000"/>
-              </a:lnSpc>
-              <a:spcAft>
-                <a:spcPts val="1000"/>
-              </a:spcAft>
-            </a:pPr>
-            <a:r>
-              <a:rPr b="1" sz="1050">
-                <a:solidFill>
-                  <a:srgbClr val="4ADE80"/>
-                </a:solidFill>
-              </a:rPr>
-              <a:t>✓  </a:t>
-            </a:r>
-            <a:r>
-              <a:rPr sz="1050">
-                <a:solidFill>
-                  <a:srgbClr val="FFFFFF"/>
-                </a:solidFill>
-                <a:latin typeface="Calibri"/>
-              </a:rPr>
-              <a:t>Pro website redesign</a:t>
-            </a:r>
-          </a:p>
-          <a:p>
-            <a:pPr>
-              <a:lnSpc>
-                <a:spcPct val="110000"/>
-              </a:lnSpc>
-              <a:spcAft>
-                <a:spcPts val="1000"/>
-              </a:spcAft>
-            </a:pPr>
-            <a:r>
-              <a:rPr b="1" sz="1050">
-                <a:solidFill>
-                  <a:srgbClr val="4ADE80"/>
-                </a:solidFill>
-              </a:rPr>
-              <a:t>✓  </a:t>
-            </a:r>
-            <a:r>
-              <a:rPr sz="1050">
-                <a:solidFill>
-                  <a:srgbClr val="FFFFFF"/>
-                </a:solidFill>
-                <a:latin typeface="Calibri"/>
-              </a:rPr>
-              <a:t>6–8 content + 4 backlinks / mo</a:t>
-            </a:r>
-          </a:p>
-          <a:p>
-            <a:pPr>
-              <a:lnSpc>
-                <a:spcPct val="110000"/>
-              </a:lnSpc>
-              <a:spcAft>
-                <a:spcPts val="1000"/>
-              </a:spcAft>
-            </a:pPr>
-            <a:r>
-              <a:rPr b="1" sz="1050">
-                <a:solidFill>
-                  <a:srgbClr val="4ADE80"/>
-                </a:solidFill>
-              </a:rPr>
-              <a:t>✓  </a:t>
-            </a:r>
-            <a:r>
-              <a:rPr sz="1050">
-                <a:solidFill>
-                  <a:srgbClr val="FFFFFF"/>
-                </a:solidFill>
-                <a:latin typeface="Calibri"/>
-              </a:rPr>
-              <a:t>Advanced AI/entity building + CRO</a:t>
+              <a:t>Aggressive citations + AI authority building</a:t>
             </a:r>
           </a:p>
         </p:txBody>
@@ -8842,7 +8842,7 @@
                 </a:solidFill>
                 <a:latin typeface="Calibri"/>
               </a:rPr>
-              <a:t>Founding Client rate — your first-customer pricing.  ·  Onboarding waived  ·  Website refactor billed at our exact cost.</a:t>
+              <a:t>Founding Client rate — your first-customer pricing.  ·  Onboarding waived  ·  Webflow site improvements billed at our exact cost.</a:t>
             </a:r>
           </a:p>
         </p:txBody>

</xml_diff>

<commit_message>
deck: backlinks slide names the comparison/listicle placement explicitly (reinforces Dominate)
Retitled to 'Citations & Backlinks' and led with the FATJOE-style 'Best Gold &
Silver Buyer in Northern VA' comparison placement + aggressive citations +
high-authority backlinks — tying the authority slide directly to the Dominate
pitch and the DA-toward-30 goal.
</commit_message>
<xml_diff>
--- a/deliverables/PracticeRank-SEO-Strategy-Paradigm-Experts.pptx
+++ b/deliverables/PracticeRank-SEO-Strategy-Paradigm-Experts.pptx
@@ -3827,7 +3827,7 @@
                 </a:solidFill>
                 <a:latin typeface="Calibri"/>
               </a:rPr>
-              <a:t>Building Authority — High-Value Backlinks</a:t>
+              <a:t>Building Authority — Citations &amp; Backlinks</a:t>
             </a:r>
           </a:p>
         </p:txBody>
@@ -4012,7 +4012,7 @@
                 </a:solidFill>
                 <a:latin typeface="Calibri"/>
               </a:rPr>
-              <a:t>Quality over volume: a few strong, locally-relevant links that lift rankings AND AI recommendations.</a:t>
+              <a:t>Quality over volume: the work that raises your Domain Authority toward ~30 and gets you cited by AI.</a:t>
             </a:r>
           </a:p>
         </p:txBody>
@@ -4025,7 +4025,7 @@
         </p:nvSpPr>
         <p:spPr>
           <a:xfrm>
-            <a:off x="822960" y="2697480"/>
+            <a:off x="822960" y="2606040"/>
             <a:ext cx="6583680" cy="4572000"/>
           </a:xfrm>
           <a:prstGeom prst="rect">
@@ -4048,7 +4048,7 @@
               </a:spcAft>
             </a:pPr>
             <a:r>
-              <a:rPr b="1" sz="1500">
+              <a:rPr b="1" sz="1450">
                 <a:solidFill>
                   <a:srgbClr val="4ADE80"/>
                 </a:solidFill>
@@ -4056,13 +4056,13 @@
               <a:t>—  </a:t>
             </a:r>
             <a:r>
-              <a:rPr sz="1500">
+              <a:rPr sz="1450">
                 <a:solidFill>
                   <a:srgbClr val="FFFFFF"/>
                 </a:solidFill>
                 <a:latin typeface="Calibri"/>
               </a:rPr>
-              <a:t>Local citations + NAP consistency across the directories that matter</a:t>
+              <a:t>Aggressive local citation building + NAP cleanup across the directories that matter</a:t>
             </a:r>
           </a:p>
           <a:p>
@@ -4075,7 +4075,7 @@
               </a:spcAft>
             </a:pPr>
             <a:r>
-              <a:rPr b="1" sz="1500">
+              <a:rPr b="1" sz="1450">
                 <a:solidFill>
                   <a:srgbClr val="4ADE80"/>
                 </a:solidFill>
@@ -4083,13 +4083,13 @@
               <a:t>—  </a:t>
             </a:r>
             <a:r>
-              <a:rPr sz="1500">
+              <a:rPr sz="1450">
                 <a:solidFill>
                   <a:srgbClr val="FFFFFF"/>
                 </a:solidFill>
                 <a:latin typeface="Calibri"/>
               </a:rPr>
-              <a:t>Local press, community sponsorships &amp; events for authoritative mentions</a:t>
+              <a:t>“Best Gold &amp; Silver Buyer in Northern VA” comparison placements — rank for high-intent searches AND get cited by AI</a:t>
             </a:r>
           </a:p>
           <a:p>
@@ -4102,7 +4102,7 @@
               </a:spcAft>
             </a:pPr>
             <a:r>
-              <a:rPr b="1" sz="1500">
+              <a:rPr b="1" sz="1450">
                 <a:solidFill>
                   <a:srgbClr val="4ADE80"/>
                 </a:solidFill>
@@ -4110,13 +4110,13 @@
               <a:t>—  </a:t>
             </a:r>
             <a:r>
-              <a:rPr sz="1500">
+              <a:rPr sz="1450">
                 <a:solidFill>
                   <a:srgbClr val="FFFFFF"/>
                 </a:solidFill>
                 <a:latin typeface="Calibri"/>
               </a:rPr>
-              <a:t>Partner, supplier &amp; association links relevant to your business</a:t>
+              <a:t>High-authority backlinks from real, locally-relevant sites — no spam, no risky tactics</a:t>
             </a:r>
           </a:p>
           <a:p>
@@ -4129,7 +4129,7 @@
               </a:spcAft>
             </a:pPr>
             <a:r>
-              <a:rPr b="1" sz="1500">
+              <a:rPr b="1" sz="1450">
                 <a:solidFill>
                   <a:srgbClr val="4ADE80"/>
                 </a:solidFill>
@@ -4137,13 +4137,13 @@
               <a:t>—  </a:t>
             </a:r>
             <a:r>
-              <a:rPr sz="1500">
+              <a:rPr sz="1450">
                 <a:solidFill>
                   <a:srgbClr val="FFFFFF"/>
                 </a:solidFill>
                 <a:latin typeface="Calibri"/>
               </a:rPr>
-              <a:t>“Best in {city}” roundups and local guides that AI assistants cite</a:t>
+              <a:t>Local press, partner &amp; supplier links for authoritative mentions</a:t>
             </a:r>
           </a:p>
           <a:p>
@@ -4156,7 +4156,7 @@
               </a:spcAft>
             </a:pPr>
             <a:r>
-              <a:rPr b="1" sz="1500">
+              <a:rPr b="1" sz="1450">
                 <a:solidFill>
                   <a:srgbClr val="4ADE80"/>
                 </a:solidFill>
@@ -4164,13 +4164,13 @@
               <a:t>—  </a:t>
             </a:r>
             <a:r>
-              <a:rPr sz="1500">
+              <a:rPr sz="1450">
                 <a:solidFill>
                   <a:srgbClr val="FFFFFF"/>
                 </a:solidFill>
                 <a:latin typeface="Calibri"/>
               </a:rPr>
-              <a:t>Steady cadence of high-authority links each month — no spam</a:t>
+              <a:t>A steady monthly cadence — compounding authority that competitors can't shortcut</a:t>
             </a:r>
           </a:p>
         </p:txBody>

</xml_diff>